<commit_message>
Adiciona Editor Divine (HTML) que gera o PPTX + paleta de carimbos no modelo
- editor/Editor_Divine.html: editor com botões de status clicáveis, selects,
  imagem por arrastar-e-soltar e exportação do PowerPoint no padrão Divine
- editor/divine_export.js: módulo de layout compartilhado (pptxgenjs)
- apresentacao/: modelo PPTX atualizado com paleta de carimbos fora do slide

Co-Authored-By: Claude Opus 4.8 <noreply@anthropic.com>
Claude-Session: https://claude.ai/code/session_01J4WuzLuPWbPdpadmrD14Gs
</commit_message>
<xml_diff>
--- a/apresentacao/Divine_Acompanhamento_Projetos_MODELO.pptx
+++ b/apresentacao/Divine_Acompanhamento_Projetos_MODELO.pptx
@@ -6657,6 +6657,437 @@
           </a:p>
         </p:txBody>
       </p:sp>
+      <p:sp>
+        <p:nvSpPr>
+          <p:cNvPr id="49" name="Rounded Rectangle 48"/>
+          <p:cNvSpPr/>
+          <p:nvPr/>
+        </p:nvSpPr>
+        <p:spPr>
+          <a:xfrm>
+            <a:off x="12390120" y="1481328"/>
+            <a:ext cx="1417320" cy="2834640"/>
+          </a:xfrm>
+          <a:prstGeom prst="roundRect">
+            <a:avLst>
+              <a:gd name="adj" fmla="val 5500"/>
+            </a:avLst>
+          </a:prstGeom>
+          <a:solidFill>
+            <a:srgbClr val="FFFFFF"/>
+          </a:solidFill>
+          <a:ln w="12700">
+            <a:solidFill>
+              <a:srgbClr val="E3D6BF"/>
+            </a:solidFill>
+          </a:ln>
+          <a:effectLst/>
+        </p:spPr>
+        <p:style>
+          <a:lnRef idx="1">
+            <a:schemeClr val="accent1"/>
+          </a:lnRef>
+          <a:fillRef idx="3">
+            <a:schemeClr val="accent1"/>
+          </a:fillRef>
+          <a:effectRef idx="2">
+            <a:schemeClr val="accent1"/>
+          </a:effectRef>
+          <a:fontRef idx="minor">
+            <a:schemeClr val="lt1"/>
+          </a:fontRef>
+        </p:style>
+        <p:txBody>
+          <a:bodyPr rtlCol="0" anchor="ctr"/>
+          <a:lstStyle/>
+          <a:p>
+            <a:pPr algn="ctr"/>
+          </a:p>
+        </p:txBody>
+      </p:sp>
+      <p:sp>
+        <p:nvSpPr>
+          <p:cNvPr id="50" name="TextBox 49"/>
+          <p:cNvSpPr txBox="1"/>
+          <p:nvPr/>
+        </p:nvSpPr>
+        <p:spPr>
+          <a:xfrm>
+            <a:off x="12499848" y="1591056"/>
+            <a:ext cx="1234440" cy="457200"/>
+          </a:xfrm>
+          <a:prstGeom prst="rect">
+            <a:avLst/>
+          </a:prstGeom>
+          <a:noFill/>
+        </p:spPr>
+        <p:txBody>
+          <a:bodyPr wrap="square" anchor="t" lIns="0" rIns="0" tIns="0" bIns="0">
+            <a:spAutoFit/>
+          </a:bodyPr>
+          <a:lstStyle/>
+          <a:p>
+            <a:pPr algn="l"/>
+            <a:r>
+              <a:rPr sz="900" b="1" i="0">
+                <a:solidFill>
+                  <a:srgbClr val="3E2419"/>
+                </a:solidFill>
+                <a:latin typeface="Segoe UI"/>
+              </a:rPr>
+              <a:t>PALETA</a:t>
+            </a:r>
+          </a:p>
+          <a:p>
+            <a:pPr algn="l"/>
+            <a:r>
+              <a:rPr sz="800" b="0" i="1">
+                <a:solidFill>
+                  <a:srgbClr val="9C8C72"/>
+                </a:solidFill>
+                <a:latin typeface="Segoe UI"/>
+              </a:rPr>
+              <a:t>copie e cole ↓</a:t>
+            </a:r>
+          </a:p>
+        </p:txBody>
+      </p:sp>
+      <p:sp>
+        <p:nvSpPr>
+          <p:cNvPr id="51" name="Oval 50"/>
+          <p:cNvSpPr/>
+          <p:nvPr/>
+        </p:nvSpPr>
+        <p:spPr>
+          <a:xfrm>
+            <a:off x="12556998" y="2151126"/>
+            <a:ext cx="214884" cy="214884"/>
+          </a:xfrm>
+          <a:prstGeom prst="ellipse">
+            <a:avLst/>
+          </a:prstGeom>
+          <a:solidFill>
+            <a:srgbClr val="43A047"/>
+          </a:solidFill>
+          <a:ln>
+            <a:noFill/>
+          </a:ln>
+          <a:effectLst/>
+        </p:spPr>
+        <p:style>
+          <a:lnRef idx="1">
+            <a:schemeClr val="accent1"/>
+          </a:lnRef>
+          <a:fillRef idx="3">
+            <a:schemeClr val="accent1"/>
+          </a:fillRef>
+          <a:effectRef idx="2">
+            <a:schemeClr val="accent1"/>
+          </a:effectRef>
+          <a:fontRef idx="minor">
+            <a:schemeClr val="lt1"/>
+          </a:fontRef>
+        </p:style>
+        <p:txBody>
+          <a:bodyPr rtlCol="0" anchor="ctr" lIns="0" rIns="0" tIns="0" bIns="0"/>
+          <a:lstStyle/>
+          <a:p>
+            <a:pPr algn="ctr"/>
+            <a:r>
+              <a:rPr sz="1100" b="1">
+                <a:solidFill>
+                  <a:srgbClr val="FFFFFF"/>
+                </a:solidFill>
+                <a:latin typeface="Segoe UI"/>
+              </a:rPr>
+              <a:t>✓</a:t>
+            </a:r>
+          </a:p>
+        </p:txBody>
+      </p:sp>
+      <p:sp>
+        <p:nvSpPr>
+          <p:cNvPr id="52" name="TextBox 51"/>
+          <p:cNvSpPr txBox="1"/>
+          <p:nvPr/>
+        </p:nvSpPr>
+        <p:spPr>
+          <a:xfrm>
+            <a:off x="12847320" y="2167128"/>
+            <a:ext cx="914400" cy="201168"/>
+          </a:xfrm>
+          <a:prstGeom prst="rect">
+            <a:avLst/>
+          </a:prstGeom>
+          <a:noFill/>
+        </p:spPr>
+        <p:txBody>
+          <a:bodyPr wrap="none" anchor="t" lIns="0" rIns="0" tIns="0" bIns="0">
+            <a:spAutoFit/>
+          </a:bodyPr>
+          <a:lstStyle/>
+          <a:p>
+            <a:pPr algn="l"/>
+            <a:r>
+              <a:rPr sz="800" b="0" i="0">
+                <a:solidFill>
+                  <a:srgbClr val="5A3A2A"/>
+                </a:solidFill>
+                <a:latin typeface="Segoe UI"/>
+              </a:rPr>
+              <a:t>Concluído</a:t>
+            </a:r>
+          </a:p>
+        </p:txBody>
+      </p:sp>
+      <p:sp>
+        <p:nvSpPr>
+          <p:cNvPr id="53" name="Oval 52"/>
+          <p:cNvSpPr/>
+          <p:nvPr/>
+        </p:nvSpPr>
+        <p:spPr>
+          <a:xfrm>
+            <a:off x="12556998" y="2663190"/>
+            <a:ext cx="214884" cy="214884"/>
+          </a:xfrm>
+          <a:prstGeom prst="ellipse">
+            <a:avLst/>
+          </a:prstGeom>
+          <a:solidFill>
+            <a:srgbClr val="E0A53A"/>
+          </a:solidFill>
+          <a:ln>
+            <a:noFill/>
+          </a:ln>
+          <a:effectLst/>
+        </p:spPr>
+        <p:style>
+          <a:lnRef idx="1">
+            <a:schemeClr val="accent1"/>
+          </a:lnRef>
+          <a:fillRef idx="3">
+            <a:schemeClr val="accent1"/>
+          </a:fillRef>
+          <a:effectRef idx="2">
+            <a:schemeClr val="accent1"/>
+          </a:effectRef>
+          <a:fontRef idx="minor">
+            <a:schemeClr val="lt1"/>
+          </a:fontRef>
+        </p:style>
+        <p:txBody>
+          <a:bodyPr rtlCol="0" anchor="ctr"/>
+          <a:lstStyle/>
+          <a:p>
+            <a:pPr algn="ctr"/>
+          </a:p>
+        </p:txBody>
+      </p:sp>
+      <p:sp>
+        <p:nvSpPr>
+          <p:cNvPr id="54" name="TextBox 53"/>
+          <p:cNvSpPr txBox="1"/>
+          <p:nvPr/>
+        </p:nvSpPr>
+        <p:spPr>
+          <a:xfrm>
+            <a:off x="12847320" y="2679192"/>
+            <a:ext cx="914400" cy="201168"/>
+          </a:xfrm>
+          <a:prstGeom prst="rect">
+            <a:avLst/>
+          </a:prstGeom>
+          <a:noFill/>
+        </p:spPr>
+        <p:txBody>
+          <a:bodyPr wrap="none" anchor="t" lIns="0" rIns="0" tIns="0" bIns="0">
+            <a:spAutoFit/>
+          </a:bodyPr>
+          <a:lstStyle/>
+          <a:p>
+            <a:pPr algn="l"/>
+            <a:r>
+              <a:rPr sz="800" b="0" i="0">
+                <a:solidFill>
+                  <a:srgbClr val="5A3A2A"/>
+                </a:solidFill>
+                <a:latin typeface="Segoe UI"/>
+              </a:rPr>
+              <a:t>Andamento</a:t>
+            </a:r>
+          </a:p>
+        </p:txBody>
+      </p:sp>
+      <p:sp>
+        <p:nvSpPr>
+          <p:cNvPr id="55" name="Oval 54"/>
+          <p:cNvSpPr/>
+          <p:nvPr/>
+        </p:nvSpPr>
+        <p:spPr>
+          <a:xfrm>
+            <a:off x="12556998" y="3175254"/>
+            <a:ext cx="214884" cy="214884"/>
+          </a:xfrm>
+          <a:prstGeom prst="ellipse">
+            <a:avLst/>
+          </a:prstGeom>
+          <a:solidFill>
+            <a:srgbClr val="C0392F"/>
+          </a:solidFill>
+          <a:ln>
+            <a:noFill/>
+          </a:ln>
+          <a:effectLst/>
+        </p:spPr>
+        <p:style>
+          <a:lnRef idx="1">
+            <a:schemeClr val="accent1"/>
+          </a:lnRef>
+          <a:fillRef idx="3">
+            <a:schemeClr val="accent1"/>
+          </a:fillRef>
+          <a:effectRef idx="2">
+            <a:schemeClr val="accent1"/>
+          </a:effectRef>
+          <a:fontRef idx="minor">
+            <a:schemeClr val="lt1"/>
+          </a:fontRef>
+        </p:style>
+        <p:txBody>
+          <a:bodyPr rtlCol="0" anchor="ctr" lIns="0" rIns="0" tIns="0" bIns="0"/>
+          <a:lstStyle/>
+          <a:p>
+            <a:pPr algn="ctr"/>
+            <a:r>
+              <a:rPr sz="1100" b="1">
+                <a:solidFill>
+                  <a:srgbClr val="FFFFFF"/>
+                </a:solidFill>
+                <a:latin typeface="Segoe UI"/>
+              </a:rPr>
+              <a:t>!</a:t>
+            </a:r>
+          </a:p>
+        </p:txBody>
+      </p:sp>
+      <p:sp>
+        <p:nvSpPr>
+          <p:cNvPr id="56" name="TextBox 55"/>
+          <p:cNvSpPr txBox="1"/>
+          <p:nvPr/>
+        </p:nvSpPr>
+        <p:spPr>
+          <a:xfrm>
+            <a:off x="12847320" y="3191256"/>
+            <a:ext cx="914400" cy="201168"/>
+          </a:xfrm>
+          <a:prstGeom prst="rect">
+            <a:avLst/>
+          </a:prstGeom>
+          <a:noFill/>
+        </p:spPr>
+        <p:txBody>
+          <a:bodyPr wrap="none" anchor="t" lIns="0" rIns="0" tIns="0" bIns="0">
+            <a:spAutoFit/>
+          </a:bodyPr>
+          <a:lstStyle/>
+          <a:p>
+            <a:pPr algn="l"/>
+            <a:r>
+              <a:rPr sz="800" b="0" i="0">
+                <a:solidFill>
+                  <a:srgbClr val="5A3A2A"/>
+                </a:solidFill>
+                <a:latin typeface="Segoe UI"/>
+              </a:rPr>
+              <a:t>Bloqueado</a:t>
+            </a:r>
+          </a:p>
+        </p:txBody>
+      </p:sp>
+      <p:sp>
+        <p:nvSpPr>
+          <p:cNvPr id="57" name="Oval 56"/>
+          <p:cNvSpPr/>
+          <p:nvPr/>
+        </p:nvSpPr>
+        <p:spPr>
+          <a:xfrm>
+            <a:off x="12556998" y="3687318"/>
+            <a:ext cx="214884" cy="214884"/>
+          </a:xfrm>
+          <a:prstGeom prst="ellipse">
+            <a:avLst/>
+          </a:prstGeom>
+          <a:solidFill>
+            <a:srgbClr val="FFFFFF"/>
+          </a:solidFill>
+          <a:ln w="19050">
+            <a:solidFill>
+              <a:srgbClr val="CDBDA4"/>
+            </a:solidFill>
+          </a:ln>
+          <a:effectLst/>
+        </p:spPr>
+        <p:style>
+          <a:lnRef idx="1">
+            <a:schemeClr val="accent1"/>
+          </a:lnRef>
+          <a:fillRef idx="3">
+            <a:schemeClr val="accent1"/>
+          </a:fillRef>
+          <a:effectRef idx="2">
+            <a:schemeClr val="accent1"/>
+          </a:effectRef>
+          <a:fontRef idx="minor">
+            <a:schemeClr val="lt1"/>
+          </a:fontRef>
+        </p:style>
+        <p:txBody>
+          <a:bodyPr rtlCol="0" anchor="ctr"/>
+          <a:lstStyle/>
+          <a:p>
+            <a:pPr algn="ctr"/>
+          </a:p>
+        </p:txBody>
+      </p:sp>
+      <p:sp>
+        <p:nvSpPr>
+          <p:cNvPr id="58" name="TextBox 57"/>
+          <p:cNvSpPr txBox="1"/>
+          <p:nvPr/>
+        </p:nvSpPr>
+        <p:spPr>
+          <a:xfrm>
+            <a:off x="12847320" y="3703320"/>
+            <a:ext cx="914400" cy="201168"/>
+          </a:xfrm>
+          <a:prstGeom prst="rect">
+            <a:avLst/>
+          </a:prstGeom>
+          <a:noFill/>
+        </p:spPr>
+        <p:txBody>
+          <a:bodyPr wrap="none" anchor="t" lIns="0" rIns="0" tIns="0" bIns="0">
+            <a:spAutoFit/>
+          </a:bodyPr>
+          <a:lstStyle/>
+          <a:p>
+            <a:pPr algn="l"/>
+            <a:r>
+              <a:rPr sz="800" b="0" i="0">
+                <a:solidFill>
+                  <a:srgbClr val="5A3A2A"/>
+                </a:solidFill>
+                <a:latin typeface="Segoe UI"/>
+              </a:rPr>
+              <a:t>Não inic.</a:t>
+            </a:r>
+          </a:p>
+        </p:txBody>
+      </p:sp>
     </p:spTree>
   </p:cSld>
   <p:clrMapOvr>
@@ -11035,6 +11466,437 @@
           </a:p>
         </p:txBody>
       </p:sp>
+      <p:sp>
+        <p:nvSpPr>
+          <p:cNvPr id="49" name="Rounded Rectangle 48"/>
+          <p:cNvSpPr/>
+          <p:nvPr/>
+        </p:nvSpPr>
+        <p:spPr>
+          <a:xfrm>
+            <a:off x="12390120" y="1481328"/>
+            <a:ext cx="1417320" cy="2834640"/>
+          </a:xfrm>
+          <a:prstGeom prst="roundRect">
+            <a:avLst>
+              <a:gd name="adj" fmla="val 5500"/>
+            </a:avLst>
+          </a:prstGeom>
+          <a:solidFill>
+            <a:srgbClr val="FFFFFF"/>
+          </a:solidFill>
+          <a:ln w="12700">
+            <a:solidFill>
+              <a:srgbClr val="E3D6BF"/>
+            </a:solidFill>
+          </a:ln>
+          <a:effectLst/>
+        </p:spPr>
+        <p:style>
+          <a:lnRef idx="1">
+            <a:schemeClr val="accent1"/>
+          </a:lnRef>
+          <a:fillRef idx="3">
+            <a:schemeClr val="accent1"/>
+          </a:fillRef>
+          <a:effectRef idx="2">
+            <a:schemeClr val="accent1"/>
+          </a:effectRef>
+          <a:fontRef idx="minor">
+            <a:schemeClr val="lt1"/>
+          </a:fontRef>
+        </p:style>
+        <p:txBody>
+          <a:bodyPr rtlCol="0" anchor="ctr"/>
+          <a:lstStyle/>
+          <a:p>
+            <a:pPr algn="ctr"/>
+          </a:p>
+        </p:txBody>
+      </p:sp>
+      <p:sp>
+        <p:nvSpPr>
+          <p:cNvPr id="50" name="TextBox 49"/>
+          <p:cNvSpPr txBox="1"/>
+          <p:nvPr/>
+        </p:nvSpPr>
+        <p:spPr>
+          <a:xfrm>
+            <a:off x="12499848" y="1591056"/>
+            <a:ext cx="1234440" cy="457200"/>
+          </a:xfrm>
+          <a:prstGeom prst="rect">
+            <a:avLst/>
+          </a:prstGeom>
+          <a:noFill/>
+        </p:spPr>
+        <p:txBody>
+          <a:bodyPr wrap="square" anchor="t" lIns="0" rIns="0" tIns="0" bIns="0">
+            <a:spAutoFit/>
+          </a:bodyPr>
+          <a:lstStyle/>
+          <a:p>
+            <a:pPr algn="l"/>
+            <a:r>
+              <a:rPr sz="900" b="1" i="0">
+                <a:solidFill>
+                  <a:srgbClr val="3E2419"/>
+                </a:solidFill>
+                <a:latin typeface="Segoe UI"/>
+              </a:rPr>
+              <a:t>PALETA</a:t>
+            </a:r>
+          </a:p>
+          <a:p>
+            <a:pPr algn="l"/>
+            <a:r>
+              <a:rPr sz="800" b="0" i="1">
+                <a:solidFill>
+                  <a:srgbClr val="9C8C72"/>
+                </a:solidFill>
+                <a:latin typeface="Segoe UI"/>
+              </a:rPr>
+              <a:t>copie e cole ↓</a:t>
+            </a:r>
+          </a:p>
+        </p:txBody>
+      </p:sp>
+      <p:sp>
+        <p:nvSpPr>
+          <p:cNvPr id="51" name="Oval 50"/>
+          <p:cNvSpPr/>
+          <p:nvPr/>
+        </p:nvSpPr>
+        <p:spPr>
+          <a:xfrm>
+            <a:off x="12556998" y="2151126"/>
+            <a:ext cx="214884" cy="214884"/>
+          </a:xfrm>
+          <a:prstGeom prst="ellipse">
+            <a:avLst/>
+          </a:prstGeom>
+          <a:solidFill>
+            <a:srgbClr val="43A047"/>
+          </a:solidFill>
+          <a:ln>
+            <a:noFill/>
+          </a:ln>
+          <a:effectLst/>
+        </p:spPr>
+        <p:style>
+          <a:lnRef idx="1">
+            <a:schemeClr val="accent1"/>
+          </a:lnRef>
+          <a:fillRef idx="3">
+            <a:schemeClr val="accent1"/>
+          </a:fillRef>
+          <a:effectRef idx="2">
+            <a:schemeClr val="accent1"/>
+          </a:effectRef>
+          <a:fontRef idx="minor">
+            <a:schemeClr val="lt1"/>
+          </a:fontRef>
+        </p:style>
+        <p:txBody>
+          <a:bodyPr rtlCol="0" anchor="ctr" lIns="0" rIns="0" tIns="0" bIns="0"/>
+          <a:lstStyle/>
+          <a:p>
+            <a:pPr algn="ctr"/>
+            <a:r>
+              <a:rPr sz="1100" b="1">
+                <a:solidFill>
+                  <a:srgbClr val="FFFFFF"/>
+                </a:solidFill>
+                <a:latin typeface="Segoe UI"/>
+              </a:rPr>
+              <a:t>✓</a:t>
+            </a:r>
+          </a:p>
+        </p:txBody>
+      </p:sp>
+      <p:sp>
+        <p:nvSpPr>
+          <p:cNvPr id="52" name="TextBox 51"/>
+          <p:cNvSpPr txBox="1"/>
+          <p:nvPr/>
+        </p:nvSpPr>
+        <p:spPr>
+          <a:xfrm>
+            <a:off x="12847320" y="2167128"/>
+            <a:ext cx="914400" cy="201168"/>
+          </a:xfrm>
+          <a:prstGeom prst="rect">
+            <a:avLst/>
+          </a:prstGeom>
+          <a:noFill/>
+        </p:spPr>
+        <p:txBody>
+          <a:bodyPr wrap="none" anchor="t" lIns="0" rIns="0" tIns="0" bIns="0">
+            <a:spAutoFit/>
+          </a:bodyPr>
+          <a:lstStyle/>
+          <a:p>
+            <a:pPr algn="l"/>
+            <a:r>
+              <a:rPr sz="800" b="0" i="0">
+                <a:solidFill>
+                  <a:srgbClr val="5A3A2A"/>
+                </a:solidFill>
+                <a:latin typeface="Segoe UI"/>
+              </a:rPr>
+              <a:t>Concluído</a:t>
+            </a:r>
+          </a:p>
+        </p:txBody>
+      </p:sp>
+      <p:sp>
+        <p:nvSpPr>
+          <p:cNvPr id="53" name="Oval 52"/>
+          <p:cNvSpPr/>
+          <p:nvPr/>
+        </p:nvSpPr>
+        <p:spPr>
+          <a:xfrm>
+            <a:off x="12556998" y="2663190"/>
+            <a:ext cx="214884" cy="214884"/>
+          </a:xfrm>
+          <a:prstGeom prst="ellipse">
+            <a:avLst/>
+          </a:prstGeom>
+          <a:solidFill>
+            <a:srgbClr val="E0A53A"/>
+          </a:solidFill>
+          <a:ln>
+            <a:noFill/>
+          </a:ln>
+          <a:effectLst/>
+        </p:spPr>
+        <p:style>
+          <a:lnRef idx="1">
+            <a:schemeClr val="accent1"/>
+          </a:lnRef>
+          <a:fillRef idx="3">
+            <a:schemeClr val="accent1"/>
+          </a:fillRef>
+          <a:effectRef idx="2">
+            <a:schemeClr val="accent1"/>
+          </a:effectRef>
+          <a:fontRef idx="minor">
+            <a:schemeClr val="lt1"/>
+          </a:fontRef>
+        </p:style>
+        <p:txBody>
+          <a:bodyPr rtlCol="0" anchor="ctr"/>
+          <a:lstStyle/>
+          <a:p>
+            <a:pPr algn="ctr"/>
+          </a:p>
+        </p:txBody>
+      </p:sp>
+      <p:sp>
+        <p:nvSpPr>
+          <p:cNvPr id="54" name="TextBox 53"/>
+          <p:cNvSpPr txBox="1"/>
+          <p:nvPr/>
+        </p:nvSpPr>
+        <p:spPr>
+          <a:xfrm>
+            <a:off x="12847320" y="2679192"/>
+            <a:ext cx="914400" cy="201168"/>
+          </a:xfrm>
+          <a:prstGeom prst="rect">
+            <a:avLst/>
+          </a:prstGeom>
+          <a:noFill/>
+        </p:spPr>
+        <p:txBody>
+          <a:bodyPr wrap="none" anchor="t" lIns="0" rIns="0" tIns="0" bIns="0">
+            <a:spAutoFit/>
+          </a:bodyPr>
+          <a:lstStyle/>
+          <a:p>
+            <a:pPr algn="l"/>
+            <a:r>
+              <a:rPr sz="800" b="0" i="0">
+                <a:solidFill>
+                  <a:srgbClr val="5A3A2A"/>
+                </a:solidFill>
+                <a:latin typeface="Segoe UI"/>
+              </a:rPr>
+              <a:t>Andamento</a:t>
+            </a:r>
+          </a:p>
+        </p:txBody>
+      </p:sp>
+      <p:sp>
+        <p:nvSpPr>
+          <p:cNvPr id="55" name="Oval 54"/>
+          <p:cNvSpPr/>
+          <p:nvPr/>
+        </p:nvSpPr>
+        <p:spPr>
+          <a:xfrm>
+            <a:off x="12556998" y="3175254"/>
+            <a:ext cx="214884" cy="214884"/>
+          </a:xfrm>
+          <a:prstGeom prst="ellipse">
+            <a:avLst/>
+          </a:prstGeom>
+          <a:solidFill>
+            <a:srgbClr val="C0392F"/>
+          </a:solidFill>
+          <a:ln>
+            <a:noFill/>
+          </a:ln>
+          <a:effectLst/>
+        </p:spPr>
+        <p:style>
+          <a:lnRef idx="1">
+            <a:schemeClr val="accent1"/>
+          </a:lnRef>
+          <a:fillRef idx="3">
+            <a:schemeClr val="accent1"/>
+          </a:fillRef>
+          <a:effectRef idx="2">
+            <a:schemeClr val="accent1"/>
+          </a:effectRef>
+          <a:fontRef idx="minor">
+            <a:schemeClr val="lt1"/>
+          </a:fontRef>
+        </p:style>
+        <p:txBody>
+          <a:bodyPr rtlCol="0" anchor="ctr" lIns="0" rIns="0" tIns="0" bIns="0"/>
+          <a:lstStyle/>
+          <a:p>
+            <a:pPr algn="ctr"/>
+            <a:r>
+              <a:rPr sz="1100" b="1">
+                <a:solidFill>
+                  <a:srgbClr val="FFFFFF"/>
+                </a:solidFill>
+                <a:latin typeface="Segoe UI"/>
+              </a:rPr>
+              <a:t>!</a:t>
+            </a:r>
+          </a:p>
+        </p:txBody>
+      </p:sp>
+      <p:sp>
+        <p:nvSpPr>
+          <p:cNvPr id="56" name="TextBox 55"/>
+          <p:cNvSpPr txBox="1"/>
+          <p:nvPr/>
+        </p:nvSpPr>
+        <p:spPr>
+          <a:xfrm>
+            <a:off x="12847320" y="3191256"/>
+            <a:ext cx="914400" cy="201168"/>
+          </a:xfrm>
+          <a:prstGeom prst="rect">
+            <a:avLst/>
+          </a:prstGeom>
+          <a:noFill/>
+        </p:spPr>
+        <p:txBody>
+          <a:bodyPr wrap="none" anchor="t" lIns="0" rIns="0" tIns="0" bIns="0">
+            <a:spAutoFit/>
+          </a:bodyPr>
+          <a:lstStyle/>
+          <a:p>
+            <a:pPr algn="l"/>
+            <a:r>
+              <a:rPr sz="800" b="0" i="0">
+                <a:solidFill>
+                  <a:srgbClr val="5A3A2A"/>
+                </a:solidFill>
+                <a:latin typeface="Segoe UI"/>
+              </a:rPr>
+              <a:t>Bloqueado</a:t>
+            </a:r>
+          </a:p>
+        </p:txBody>
+      </p:sp>
+      <p:sp>
+        <p:nvSpPr>
+          <p:cNvPr id="57" name="Oval 56"/>
+          <p:cNvSpPr/>
+          <p:nvPr/>
+        </p:nvSpPr>
+        <p:spPr>
+          <a:xfrm>
+            <a:off x="12556998" y="3687318"/>
+            <a:ext cx="214884" cy="214884"/>
+          </a:xfrm>
+          <a:prstGeom prst="ellipse">
+            <a:avLst/>
+          </a:prstGeom>
+          <a:solidFill>
+            <a:srgbClr val="FFFFFF"/>
+          </a:solidFill>
+          <a:ln w="19050">
+            <a:solidFill>
+              <a:srgbClr val="CDBDA4"/>
+            </a:solidFill>
+          </a:ln>
+          <a:effectLst/>
+        </p:spPr>
+        <p:style>
+          <a:lnRef idx="1">
+            <a:schemeClr val="accent1"/>
+          </a:lnRef>
+          <a:fillRef idx="3">
+            <a:schemeClr val="accent1"/>
+          </a:fillRef>
+          <a:effectRef idx="2">
+            <a:schemeClr val="accent1"/>
+          </a:effectRef>
+          <a:fontRef idx="minor">
+            <a:schemeClr val="lt1"/>
+          </a:fontRef>
+        </p:style>
+        <p:txBody>
+          <a:bodyPr rtlCol="0" anchor="ctr"/>
+          <a:lstStyle/>
+          <a:p>
+            <a:pPr algn="ctr"/>
+          </a:p>
+        </p:txBody>
+      </p:sp>
+      <p:sp>
+        <p:nvSpPr>
+          <p:cNvPr id="58" name="TextBox 57"/>
+          <p:cNvSpPr txBox="1"/>
+          <p:nvPr/>
+        </p:nvSpPr>
+        <p:spPr>
+          <a:xfrm>
+            <a:off x="12847320" y="3703320"/>
+            <a:ext cx="914400" cy="201168"/>
+          </a:xfrm>
+          <a:prstGeom prst="rect">
+            <a:avLst/>
+          </a:prstGeom>
+          <a:noFill/>
+        </p:spPr>
+        <p:txBody>
+          <a:bodyPr wrap="none" anchor="t" lIns="0" rIns="0" tIns="0" bIns="0">
+            <a:spAutoFit/>
+          </a:bodyPr>
+          <a:lstStyle/>
+          <a:p>
+            <a:pPr algn="l"/>
+            <a:r>
+              <a:rPr sz="800" b="0" i="0">
+                <a:solidFill>
+                  <a:srgbClr val="5A3A2A"/>
+                </a:solidFill>
+                <a:latin typeface="Segoe UI"/>
+              </a:rPr>
+              <a:t>Não inic.</a:t>
+            </a:r>
+          </a:p>
+        </p:txBody>
+      </p:sp>
     </p:spTree>
   </p:cSld>
   <p:clrMapOvr>

</xml_diff>

<commit_message>
Aplica foto de capa e harmoniza os slides com a identidade
- Capa: foto de chocolate em tela cheia (espelhada, texto/logo à esquerda
  sobre degradê de leitura)
- Slides de conteúdo: cabeçalho ganha textura sutil da mesma foto (eco
  visual), corpo segue creme limpo para legibilidade dos dados
- processa_capa.py agora também gera a faixa de cabeçalho (header_bg)
- gera_apresentacao.py salva o modelo na própria pasta e usa capa+header

Co-Authored-By: Claude Opus 4.8 <noreply@anthropic.com>
Claude-Session: https://claude.ai/code/session_01J4WuzLuPWbPdpadmrD14Gs
</commit_message>
<xml_diff>
--- a/apresentacao/Divine_Acompanhamento_Projetos_MODELO.pptx
+++ b/apresentacao/Divine_Acompanhamento_Projetos_MODELO.pptx
@@ -3101,97 +3101,33 @@
         <p:nvPr/>
       </p:nvGrpSpPr>
       <p:grpSpPr/>
-      <p:sp>
-        <p:nvSpPr>
-          <p:cNvPr id="2" name="Oval 1"/>
-          <p:cNvSpPr/>
-          <p:nvPr/>
-        </p:nvSpPr>
-        <p:spPr>
-          <a:xfrm>
-            <a:off x="9509760" y="-1463040"/>
-            <a:ext cx="4206240" cy="4206240"/>
-          </a:xfrm>
-          <a:prstGeom prst="ellipse">
-            <a:avLst/>
-          </a:prstGeom>
-          <a:solidFill>
-            <a:srgbClr val="4A2E1E"/>
-          </a:solidFill>
-          <a:ln>
-            <a:noFill/>
-          </a:ln>
-          <a:effectLst/>
-        </p:spPr>
-        <p:style>
-          <a:lnRef idx="1">
-            <a:schemeClr val="accent1"/>
-          </a:lnRef>
-          <a:fillRef idx="3">
-            <a:schemeClr val="accent1"/>
-          </a:fillRef>
-          <a:effectRef idx="2">
-            <a:schemeClr val="accent1"/>
-          </a:effectRef>
-          <a:fontRef idx="minor">
-            <a:schemeClr val="lt1"/>
-          </a:fontRef>
-        </p:style>
-        <p:txBody>
-          <a:bodyPr rtlCol="0" anchor="ctr"/>
-          <a:lstStyle/>
-          <a:p>
-            <a:pPr algn="ctr"/>
-          </a:p>
-        </p:txBody>
-      </p:sp>
-      <p:sp>
-        <p:nvSpPr>
-          <p:cNvPr id="3" name="Oval 2"/>
-          <p:cNvSpPr/>
-          <p:nvPr/>
-        </p:nvSpPr>
-        <p:spPr>
-          <a:xfrm>
-            <a:off x="10515600" y="4846320"/>
-            <a:ext cx="3108960" cy="3108960"/>
-          </a:xfrm>
-          <a:prstGeom prst="ellipse">
-            <a:avLst/>
-          </a:prstGeom>
-          <a:solidFill>
-            <a:srgbClr val="472B1C"/>
-          </a:solidFill>
-          <a:ln>
-            <a:noFill/>
-          </a:ln>
-          <a:effectLst/>
-        </p:spPr>
-        <p:style>
-          <a:lnRef idx="1">
-            <a:schemeClr val="accent1"/>
-          </a:lnRef>
-          <a:fillRef idx="3">
-            <a:schemeClr val="accent1"/>
-          </a:fillRef>
-          <a:effectRef idx="2">
-            <a:schemeClr val="accent1"/>
-          </a:effectRef>
-          <a:fontRef idx="minor">
-            <a:schemeClr val="lt1"/>
-          </a:fontRef>
-        </p:style>
-        <p:txBody>
-          <a:bodyPr rtlCol="0" anchor="ctr"/>
-          <a:lstStyle/>
-          <a:p>
-            <a:pPr algn="ctr"/>
-          </a:p>
-        </p:txBody>
-      </p:sp>
-      <p:sp>
-        <p:nvSpPr>
-          <p:cNvPr id="4" name="Rectangle 3"/>
+      <p:pic>
+        <p:nvPicPr>
+          <p:cNvPr id="2" name="Picture 1" descr="capa_bg.jpg"/>
+          <p:cNvPicPr>
+            <a:picLocks noChangeAspect="1"/>
+          </p:cNvPicPr>
+          <p:nvPr/>
+        </p:nvPicPr>
+        <p:blipFill>
+          <a:blip r:embed="rId2"/>
+          <a:stretch>
+            <a:fillRect/>
+          </a:stretch>
+        </p:blipFill>
+        <p:spPr>
+          <a:xfrm>
+            <a:off x="0" y="0"/>
+            <a:ext cx="12191695" cy="6858000"/>
+          </a:xfrm>
+          <a:prstGeom prst="rect">
+            <a:avLst/>
+          </a:prstGeom>
+        </p:spPr>
+      </p:pic>
+      <p:sp>
+        <p:nvSpPr>
+          <p:cNvPr id="3" name="Rectangle 2"/>
           <p:cNvSpPr/>
           <p:nvPr/>
         </p:nvSpPr>
@@ -3235,7 +3171,7 @@
       </p:sp>
       <p:sp>
         <p:nvSpPr>
-          <p:cNvPr id="5" name="TextBox 4"/>
+          <p:cNvPr id="4" name="TextBox 3"/>
           <p:cNvSpPr txBox="1"/>
           <p:nvPr/>
         </p:nvSpPr>
@@ -3270,7 +3206,7 @@
       </p:sp>
       <p:sp>
         <p:nvSpPr>
-          <p:cNvPr id="6" name="TextBox 5"/>
+          <p:cNvPr id="5" name="TextBox 4"/>
           <p:cNvSpPr txBox="1"/>
           <p:nvPr/>
         </p:nvSpPr>
@@ -3325,7 +3261,7 @@
       </p:sp>
       <p:sp>
         <p:nvSpPr>
-          <p:cNvPr id="7" name="TextBox 6"/>
+          <p:cNvPr id="6" name="TextBox 5"/>
           <p:cNvSpPr txBox="1"/>
           <p:nvPr/>
         </p:nvSpPr>
@@ -3364,7 +3300,7 @@
       </p:sp>
       <p:sp>
         <p:nvSpPr>
-          <p:cNvPr id="8" name="Rounded Rectangle 7"/>
+          <p:cNvPr id="7" name="Rounded Rectangle 6"/>
           <p:cNvSpPr/>
           <p:nvPr/>
         </p:nvSpPr>
@@ -3417,6 +3353,30 @@
           </a:p>
         </p:txBody>
       </p:sp>
+      <p:pic>
+        <p:nvPicPr>
+          <p:cNvPr id="8" name="Picture 7" descr="logo_wordmark.png"/>
+          <p:cNvPicPr>
+            <a:picLocks noChangeAspect="1"/>
+          </p:cNvPicPr>
+          <p:nvPr/>
+        </p:nvPicPr>
+        <p:blipFill>
+          <a:blip r:embed="rId3"/>
+          <a:stretch>
+            <a:fillRect/>
+          </a:stretch>
+        </p:blipFill>
+        <p:spPr>
+          <a:xfrm>
+            <a:off x="841248" y="5349240"/>
+            <a:ext cx="2799184" cy="914400"/>
+          </a:xfrm>
+          <a:prstGeom prst="rect">
+            <a:avLst/>
+          </a:prstGeom>
+        </p:spPr>
+      </p:pic>
       <p:sp>
         <p:nvSpPr>
           <p:cNvPr id="9" name="TextBox 8"/>
@@ -3425,8 +3385,8 @@
         </p:nvSpPr>
         <p:spPr>
           <a:xfrm>
-            <a:off x="841248" y="5532120"/>
-            <a:ext cx="3657600" cy="777240"/>
+            <a:off x="841248" y="6355080"/>
+            <a:ext cx="2799184" cy="274320"/>
           </a:xfrm>
           <a:prstGeom prst="rect">
             <a:avLst/>
@@ -3439,42 +3399,7 @@
           </a:bodyPr>
           <a:lstStyle/>
           <a:p>
-            <a:pPr algn="l"/>
-            <a:r>
-              <a:rPr sz="3800" b="1" i="1">
-                <a:solidFill>
-                  <a:srgbClr val="E0A53A"/>
-                </a:solidFill>
-                <a:latin typeface="Segoe Script"/>
-              </a:rPr>
-              <a:t>Divine</a:t>
-            </a:r>
-          </a:p>
-        </p:txBody>
-      </p:sp>
-      <p:sp>
-        <p:nvSpPr>
-          <p:cNvPr id="10" name="TextBox 9"/>
-          <p:cNvSpPr txBox="1"/>
-          <p:nvPr/>
-        </p:nvSpPr>
-        <p:spPr>
-          <a:xfrm>
-            <a:off x="896112" y="6327648"/>
-            <a:ext cx="4572000" cy="274320"/>
-          </a:xfrm>
-          <a:prstGeom prst="rect">
-            <a:avLst/>
-          </a:prstGeom>
-          <a:noFill/>
-        </p:spPr>
-        <p:txBody>
-          <a:bodyPr wrap="none" anchor="t" lIns="0" rIns="0" tIns="0" bIns="0">
-            <a:spAutoFit/>
-          </a:bodyPr>
-          <a:lstStyle/>
-          <a:p>
-            <a:pPr algn="l"/>
+            <a:pPr algn="ctr"/>
             <a:r>
               <a:rPr sz="950" b="1" i="0">
                 <a:solidFill>
@@ -3513,12 +3438,20 @@
         <p:nvPr/>
       </p:nvGrpSpPr>
       <p:grpSpPr/>
-      <p:sp>
-        <p:nvSpPr>
-          <p:cNvPr id="2" name="Rectangle 1"/>
-          <p:cNvSpPr/>
-          <p:nvPr/>
-        </p:nvSpPr>
+      <p:pic>
+        <p:nvPicPr>
+          <p:cNvPr id="2" name="Picture 1" descr="header_bg.jpg"/>
+          <p:cNvPicPr>
+            <a:picLocks noChangeAspect="1"/>
+          </p:cNvPicPr>
+          <p:nvPr/>
+        </p:nvPicPr>
+        <p:blipFill>
+          <a:blip r:embed="rId2"/>
+          <a:stretch>
+            <a:fillRect/>
+          </a:stretch>
+        </p:blipFill>
         <p:spPr>
           <a:xfrm>
             <a:off x="0" y="0"/>
@@ -3527,36 +3460,8 @@
           <a:prstGeom prst="rect">
             <a:avLst/>
           </a:prstGeom>
-          <a:solidFill>
-            <a:srgbClr val="3E2419"/>
-          </a:solidFill>
-          <a:ln>
-            <a:noFill/>
-          </a:ln>
-          <a:effectLst/>
-        </p:spPr>
-        <p:style>
-          <a:lnRef idx="1">
-            <a:schemeClr val="accent1"/>
-          </a:lnRef>
-          <a:fillRef idx="3">
-            <a:schemeClr val="accent1"/>
-          </a:fillRef>
-          <a:effectRef idx="2">
-            <a:schemeClr val="accent1"/>
-          </a:effectRef>
-          <a:fontRef idx="minor">
-            <a:schemeClr val="lt1"/>
-          </a:fontRef>
-        </p:style>
-        <p:txBody>
-          <a:bodyPr rtlCol="0" anchor="ctr"/>
-          <a:lstStyle/>
-          <a:p>
-            <a:pPr algn="ctr"/>
-          </a:p>
-        </p:txBody>
-      </p:sp>
+        </p:spPr>
+      </p:pic>
       <p:sp>
         <p:nvSpPr>
           <p:cNvPr id="3" name="Rectangle 2"/>
@@ -3601,61 +3506,30 @@
           </a:p>
         </p:txBody>
       </p:sp>
-      <p:sp>
-        <p:nvSpPr>
-          <p:cNvPr id="4" name="Rounded Rectangle 3"/>
-          <p:cNvSpPr/>
-          <p:nvPr/>
-        </p:nvSpPr>
-        <p:spPr>
-          <a:xfrm>
-            <a:off x="274320" y="155448"/>
-            <a:ext cx="566928" cy="566928"/>
-          </a:xfrm>
-          <a:prstGeom prst="roundRect">
-            <a:avLst>
-              <a:gd name="adj" fmla="val 22000"/>
-            </a:avLst>
-          </a:prstGeom>
-          <a:solidFill>
-            <a:srgbClr val="A83224"/>
-          </a:solidFill>
-          <a:ln>
-            <a:noFill/>
-          </a:ln>
-          <a:effectLst/>
-        </p:spPr>
-        <p:style>
-          <a:lnRef idx="1">
-            <a:schemeClr val="accent1"/>
-          </a:lnRef>
-          <a:fillRef idx="3">
-            <a:schemeClr val="accent1"/>
-          </a:fillRef>
-          <a:effectRef idx="2">
-            <a:schemeClr val="accent1"/>
-          </a:effectRef>
-          <a:fontRef idx="minor">
-            <a:schemeClr val="lt1"/>
-          </a:fontRef>
-        </p:style>
-        <p:txBody>
-          <a:bodyPr rtlCol="0" anchor="ctr" lIns="0" rIns="0" tIns="0" bIns="0"/>
-          <a:lstStyle/>
-          <a:p>
-            <a:pPr algn="ctr"/>
-            <a:r>
-              <a:rPr sz="1000" b="1" i="1">
-                <a:solidFill>
-                  <a:srgbClr val="E0A53A"/>
-                </a:solidFill>
-                <a:latin typeface="Segoe Script"/>
-              </a:rPr>
-              <a:t>Divine</a:t>
-            </a:r>
-          </a:p>
-        </p:txBody>
-      </p:sp>
+      <p:pic>
+        <p:nvPicPr>
+          <p:cNvPr id="4" name="Picture 3" descr="logo_wordmark.png"/>
+          <p:cNvPicPr>
+            <a:picLocks noChangeAspect="1"/>
+          </p:cNvPicPr>
+          <p:nvPr/>
+        </p:nvPicPr>
+        <p:blipFill>
+          <a:blip r:embed="rId3"/>
+          <a:stretch>
+            <a:fillRect/>
+          </a:stretch>
+        </p:blipFill>
+        <p:spPr>
+          <a:xfrm>
+            <a:off x="292608" y="201168"/>
+            <a:ext cx="1511559" cy="493776"/>
+          </a:xfrm>
+          <a:prstGeom prst="rect">
+            <a:avLst/>
+          </a:prstGeom>
+        </p:spPr>
+      </p:pic>
       <p:sp>
         <p:nvSpPr>
           <p:cNvPr id="5" name="TextBox 4"/>
@@ -3664,7 +3538,7 @@
         </p:nvSpPr>
         <p:spPr>
           <a:xfrm>
-            <a:off x="987552" y="141732"/>
+            <a:off x="1968759" y="141732"/>
             <a:ext cx="7315200" cy="228600"/>
           </a:xfrm>
           <a:prstGeom prst="rect">
@@ -3699,7 +3573,7 @@
         </p:nvSpPr>
         <p:spPr>
           <a:xfrm>
-            <a:off x="969264" y="342900"/>
+            <a:off x="1950471" y="342900"/>
             <a:ext cx="7315200" cy="502920"/>
           </a:xfrm>
           <a:prstGeom prst="rect">
@@ -6304,41 +6178,30 @@
           </a:p>
         </p:txBody>
       </p:sp>
-      <p:sp>
-        <p:nvSpPr>
-          <p:cNvPr id="40" name="TextBox 39"/>
-          <p:cNvSpPr txBox="1"/>
-          <p:nvPr/>
-        </p:nvSpPr>
-        <p:spPr>
-          <a:xfrm>
-            <a:off x="11109960" y="6597396"/>
-            <a:ext cx="868680" cy="237744"/>
+      <p:pic>
+        <p:nvPicPr>
+          <p:cNvPr id="40" name="Picture 39" descr="logo_wordmark.png"/>
+          <p:cNvPicPr>
+            <a:picLocks noChangeAspect="1"/>
+          </p:cNvPicPr>
+          <p:nvPr/>
+        </p:nvPicPr>
+        <p:blipFill>
+          <a:blip r:embed="rId3"/>
+          <a:stretch>
+            <a:fillRect/>
+          </a:stretch>
+        </p:blipFill>
+        <p:spPr>
+          <a:xfrm>
+            <a:off x="11225660" y="6611112"/>
+            <a:ext cx="615820" cy="201168"/>
           </a:xfrm>
           <a:prstGeom prst="rect">
             <a:avLst/>
           </a:prstGeom>
-          <a:noFill/>
-        </p:spPr>
-        <p:txBody>
-          <a:bodyPr wrap="none" anchor="t" lIns="0" rIns="0" tIns="0" bIns="0">
-            <a:spAutoFit/>
-          </a:bodyPr>
-          <a:lstStyle/>
-          <a:p>
-            <a:pPr algn="r"/>
-            <a:r>
-              <a:rPr sz="1100" b="1" i="1">
-                <a:solidFill>
-                  <a:srgbClr val="E0A53A"/>
-                </a:solidFill>
-                <a:latin typeface="Segoe Script"/>
-              </a:rPr>
-              <a:t>Divine</a:t>
-            </a:r>
-          </a:p>
-        </p:txBody>
-      </p:sp>
+        </p:spPr>
+      </p:pic>
       <p:sp>
         <p:nvSpPr>
           <p:cNvPr id="41" name="Oval 40"/>
@@ -7114,12 +6977,20 @@
         <p:nvPr/>
       </p:nvGrpSpPr>
       <p:grpSpPr/>
-      <p:sp>
-        <p:nvSpPr>
-          <p:cNvPr id="2" name="Rectangle 1"/>
-          <p:cNvSpPr/>
-          <p:nvPr/>
-        </p:nvSpPr>
+      <p:pic>
+        <p:nvPicPr>
+          <p:cNvPr id="2" name="Picture 1" descr="header_bg.jpg"/>
+          <p:cNvPicPr>
+            <a:picLocks noChangeAspect="1"/>
+          </p:cNvPicPr>
+          <p:nvPr/>
+        </p:nvPicPr>
+        <p:blipFill>
+          <a:blip r:embed="rId2"/>
+          <a:stretch>
+            <a:fillRect/>
+          </a:stretch>
+        </p:blipFill>
         <p:spPr>
           <a:xfrm>
             <a:off x="0" y="0"/>
@@ -7128,36 +6999,8 @@
           <a:prstGeom prst="rect">
             <a:avLst/>
           </a:prstGeom>
-          <a:solidFill>
-            <a:srgbClr val="3E2419"/>
-          </a:solidFill>
-          <a:ln>
-            <a:noFill/>
-          </a:ln>
-          <a:effectLst/>
-        </p:spPr>
-        <p:style>
-          <a:lnRef idx="1">
-            <a:schemeClr val="accent1"/>
-          </a:lnRef>
-          <a:fillRef idx="3">
-            <a:schemeClr val="accent1"/>
-          </a:fillRef>
-          <a:effectRef idx="2">
-            <a:schemeClr val="accent1"/>
-          </a:effectRef>
-          <a:fontRef idx="minor">
-            <a:schemeClr val="lt1"/>
-          </a:fontRef>
-        </p:style>
-        <p:txBody>
-          <a:bodyPr rtlCol="0" anchor="ctr"/>
-          <a:lstStyle/>
-          <a:p>
-            <a:pPr algn="ctr"/>
-          </a:p>
-        </p:txBody>
-      </p:sp>
+        </p:spPr>
+      </p:pic>
       <p:sp>
         <p:nvSpPr>
           <p:cNvPr id="3" name="Rectangle 2"/>
@@ -7202,61 +7045,30 @@
           </a:p>
         </p:txBody>
       </p:sp>
-      <p:sp>
-        <p:nvSpPr>
-          <p:cNvPr id="4" name="Rounded Rectangle 3"/>
-          <p:cNvSpPr/>
-          <p:nvPr/>
-        </p:nvSpPr>
-        <p:spPr>
-          <a:xfrm>
-            <a:off x="274320" y="155448"/>
-            <a:ext cx="566928" cy="566928"/>
-          </a:xfrm>
-          <a:prstGeom prst="roundRect">
-            <a:avLst>
-              <a:gd name="adj" fmla="val 22000"/>
-            </a:avLst>
-          </a:prstGeom>
-          <a:solidFill>
-            <a:srgbClr val="A83224"/>
-          </a:solidFill>
-          <a:ln>
-            <a:noFill/>
-          </a:ln>
-          <a:effectLst/>
-        </p:spPr>
-        <p:style>
-          <a:lnRef idx="1">
-            <a:schemeClr val="accent1"/>
-          </a:lnRef>
-          <a:fillRef idx="3">
-            <a:schemeClr val="accent1"/>
-          </a:fillRef>
-          <a:effectRef idx="2">
-            <a:schemeClr val="accent1"/>
-          </a:effectRef>
-          <a:fontRef idx="minor">
-            <a:schemeClr val="lt1"/>
-          </a:fontRef>
-        </p:style>
-        <p:txBody>
-          <a:bodyPr rtlCol="0" anchor="ctr" lIns="0" rIns="0" tIns="0" bIns="0"/>
-          <a:lstStyle/>
-          <a:p>
-            <a:pPr algn="ctr"/>
-            <a:r>
-              <a:rPr sz="1000" b="1" i="1">
-                <a:solidFill>
-                  <a:srgbClr val="E0A53A"/>
-                </a:solidFill>
-                <a:latin typeface="Segoe Script"/>
-              </a:rPr>
-              <a:t>Divine</a:t>
-            </a:r>
-          </a:p>
-        </p:txBody>
-      </p:sp>
+      <p:pic>
+        <p:nvPicPr>
+          <p:cNvPr id="4" name="Picture 3" descr="logo_wordmark.png"/>
+          <p:cNvPicPr>
+            <a:picLocks noChangeAspect="1"/>
+          </p:cNvPicPr>
+          <p:nvPr/>
+        </p:nvPicPr>
+        <p:blipFill>
+          <a:blip r:embed="rId3"/>
+          <a:stretch>
+            <a:fillRect/>
+          </a:stretch>
+        </p:blipFill>
+        <p:spPr>
+          <a:xfrm>
+            <a:off x="292608" y="201168"/>
+            <a:ext cx="1511559" cy="493776"/>
+          </a:xfrm>
+          <a:prstGeom prst="rect">
+            <a:avLst/>
+          </a:prstGeom>
+        </p:spPr>
+      </p:pic>
       <p:sp>
         <p:nvSpPr>
           <p:cNvPr id="5" name="TextBox 4"/>
@@ -7265,7 +7077,7 @@
         </p:nvSpPr>
         <p:spPr>
           <a:xfrm>
-            <a:off x="987552" y="141732"/>
+            <a:off x="1968759" y="141732"/>
             <a:ext cx="7315200" cy="228600"/>
           </a:xfrm>
           <a:prstGeom prst="rect">
@@ -7300,7 +7112,7 @@
         </p:nvSpPr>
         <p:spPr>
           <a:xfrm>
-            <a:off x="969264" y="342900"/>
+            <a:off x="1950471" y="342900"/>
             <a:ext cx="7315200" cy="502920"/>
           </a:xfrm>
           <a:prstGeom prst="rect">
@@ -8264,41 +8076,30 @@
           </a:p>
         </p:txBody>
       </p:sp>
-      <p:sp>
-        <p:nvSpPr>
-          <p:cNvPr id="28" name="TextBox 27"/>
-          <p:cNvSpPr txBox="1"/>
-          <p:nvPr/>
-        </p:nvSpPr>
-        <p:spPr>
-          <a:xfrm>
-            <a:off x="11109960" y="6597396"/>
-            <a:ext cx="868680" cy="237744"/>
+      <p:pic>
+        <p:nvPicPr>
+          <p:cNvPr id="28" name="Picture 27" descr="logo_wordmark.png"/>
+          <p:cNvPicPr>
+            <a:picLocks noChangeAspect="1"/>
+          </p:cNvPicPr>
+          <p:nvPr/>
+        </p:nvPicPr>
+        <p:blipFill>
+          <a:blip r:embed="rId3"/>
+          <a:stretch>
+            <a:fillRect/>
+          </a:stretch>
+        </p:blipFill>
+        <p:spPr>
+          <a:xfrm>
+            <a:off x="11225660" y="6611112"/>
+            <a:ext cx="615820" cy="201168"/>
           </a:xfrm>
           <a:prstGeom prst="rect">
             <a:avLst/>
           </a:prstGeom>
-          <a:noFill/>
-        </p:spPr>
-        <p:txBody>
-          <a:bodyPr wrap="none" anchor="t" lIns="0" rIns="0" tIns="0" bIns="0">
-            <a:spAutoFit/>
-          </a:bodyPr>
-          <a:lstStyle/>
-          <a:p>
-            <a:pPr algn="r"/>
-            <a:r>
-              <a:rPr sz="1100" b="1" i="1">
-                <a:solidFill>
-                  <a:srgbClr val="E0A53A"/>
-                </a:solidFill>
-                <a:latin typeface="Segoe Script"/>
-              </a:rPr>
-              <a:t>Divine</a:t>
-            </a:r>
-          </a:p>
-        </p:txBody>
-      </p:sp>
+        </p:spPr>
+      </p:pic>
     </p:spTree>
   </p:cSld>
   <p:clrMapOvr>
@@ -8325,12 +8126,20 @@
         <p:nvPr/>
       </p:nvGrpSpPr>
       <p:grpSpPr/>
-      <p:sp>
-        <p:nvSpPr>
-          <p:cNvPr id="2" name="Rectangle 1"/>
-          <p:cNvSpPr/>
-          <p:nvPr/>
-        </p:nvSpPr>
+      <p:pic>
+        <p:nvPicPr>
+          <p:cNvPr id="2" name="Picture 1" descr="header_bg.jpg"/>
+          <p:cNvPicPr>
+            <a:picLocks noChangeAspect="1"/>
+          </p:cNvPicPr>
+          <p:nvPr/>
+        </p:nvPicPr>
+        <p:blipFill>
+          <a:blip r:embed="rId2"/>
+          <a:stretch>
+            <a:fillRect/>
+          </a:stretch>
+        </p:blipFill>
         <p:spPr>
           <a:xfrm>
             <a:off x="0" y="0"/>
@@ -8339,36 +8148,8 @@
           <a:prstGeom prst="rect">
             <a:avLst/>
           </a:prstGeom>
-          <a:solidFill>
-            <a:srgbClr val="3E2419"/>
-          </a:solidFill>
-          <a:ln>
-            <a:noFill/>
-          </a:ln>
-          <a:effectLst/>
-        </p:spPr>
-        <p:style>
-          <a:lnRef idx="1">
-            <a:schemeClr val="accent1"/>
-          </a:lnRef>
-          <a:fillRef idx="3">
-            <a:schemeClr val="accent1"/>
-          </a:fillRef>
-          <a:effectRef idx="2">
-            <a:schemeClr val="accent1"/>
-          </a:effectRef>
-          <a:fontRef idx="minor">
-            <a:schemeClr val="lt1"/>
-          </a:fontRef>
-        </p:style>
-        <p:txBody>
-          <a:bodyPr rtlCol="0" anchor="ctr"/>
-          <a:lstStyle/>
-          <a:p>
-            <a:pPr algn="ctr"/>
-          </a:p>
-        </p:txBody>
-      </p:sp>
+        </p:spPr>
+      </p:pic>
       <p:sp>
         <p:nvSpPr>
           <p:cNvPr id="3" name="Rectangle 2"/>
@@ -8413,61 +8194,30 @@
           </a:p>
         </p:txBody>
       </p:sp>
-      <p:sp>
-        <p:nvSpPr>
-          <p:cNvPr id="4" name="Rounded Rectangle 3"/>
-          <p:cNvSpPr/>
-          <p:nvPr/>
-        </p:nvSpPr>
-        <p:spPr>
-          <a:xfrm>
-            <a:off x="274320" y="155448"/>
-            <a:ext cx="566928" cy="566928"/>
-          </a:xfrm>
-          <a:prstGeom prst="roundRect">
-            <a:avLst>
-              <a:gd name="adj" fmla="val 22000"/>
-            </a:avLst>
-          </a:prstGeom>
-          <a:solidFill>
-            <a:srgbClr val="A83224"/>
-          </a:solidFill>
-          <a:ln>
-            <a:noFill/>
-          </a:ln>
-          <a:effectLst/>
-        </p:spPr>
-        <p:style>
-          <a:lnRef idx="1">
-            <a:schemeClr val="accent1"/>
-          </a:lnRef>
-          <a:fillRef idx="3">
-            <a:schemeClr val="accent1"/>
-          </a:fillRef>
-          <a:effectRef idx="2">
-            <a:schemeClr val="accent1"/>
-          </a:effectRef>
-          <a:fontRef idx="minor">
-            <a:schemeClr val="lt1"/>
-          </a:fontRef>
-        </p:style>
-        <p:txBody>
-          <a:bodyPr rtlCol="0" anchor="ctr" lIns="0" rIns="0" tIns="0" bIns="0"/>
-          <a:lstStyle/>
-          <a:p>
-            <a:pPr algn="ctr"/>
-            <a:r>
-              <a:rPr sz="1000" b="1" i="1">
-                <a:solidFill>
-                  <a:srgbClr val="E0A53A"/>
-                </a:solidFill>
-                <a:latin typeface="Segoe Script"/>
-              </a:rPr>
-              <a:t>Divine</a:t>
-            </a:r>
-          </a:p>
-        </p:txBody>
-      </p:sp>
+      <p:pic>
+        <p:nvPicPr>
+          <p:cNvPr id="4" name="Picture 3" descr="logo_wordmark.png"/>
+          <p:cNvPicPr>
+            <a:picLocks noChangeAspect="1"/>
+          </p:cNvPicPr>
+          <p:nvPr/>
+        </p:nvPicPr>
+        <p:blipFill>
+          <a:blip r:embed="rId3"/>
+          <a:stretch>
+            <a:fillRect/>
+          </a:stretch>
+        </p:blipFill>
+        <p:spPr>
+          <a:xfrm>
+            <a:off x="292608" y="201168"/>
+            <a:ext cx="1511559" cy="493776"/>
+          </a:xfrm>
+          <a:prstGeom prst="rect">
+            <a:avLst/>
+          </a:prstGeom>
+        </p:spPr>
+      </p:pic>
       <p:sp>
         <p:nvSpPr>
           <p:cNvPr id="5" name="TextBox 4"/>
@@ -8476,7 +8226,7 @@
         </p:nvSpPr>
         <p:spPr>
           <a:xfrm>
-            <a:off x="987552" y="141732"/>
+            <a:off x="1968759" y="141732"/>
             <a:ext cx="7315200" cy="228600"/>
           </a:xfrm>
           <a:prstGeom prst="rect">
@@ -8511,7 +8261,7 @@
         </p:nvSpPr>
         <p:spPr>
           <a:xfrm>
-            <a:off x="969264" y="342900"/>
+            <a:off x="1950471" y="342900"/>
             <a:ext cx="7315200" cy="502920"/>
           </a:xfrm>
           <a:prstGeom prst="rect">
@@ -11113,41 +10863,30 @@
           </a:p>
         </p:txBody>
       </p:sp>
-      <p:sp>
-        <p:nvSpPr>
-          <p:cNvPr id="40" name="TextBox 39"/>
-          <p:cNvSpPr txBox="1"/>
-          <p:nvPr/>
-        </p:nvSpPr>
-        <p:spPr>
-          <a:xfrm>
-            <a:off x="11109960" y="6597396"/>
-            <a:ext cx="868680" cy="237744"/>
+      <p:pic>
+        <p:nvPicPr>
+          <p:cNvPr id="40" name="Picture 39" descr="logo_wordmark.png"/>
+          <p:cNvPicPr>
+            <a:picLocks noChangeAspect="1"/>
+          </p:cNvPicPr>
+          <p:nvPr/>
+        </p:nvPicPr>
+        <p:blipFill>
+          <a:blip r:embed="rId3"/>
+          <a:stretch>
+            <a:fillRect/>
+          </a:stretch>
+        </p:blipFill>
+        <p:spPr>
+          <a:xfrm>
+            <a:off x="11225660" y="6611112"/>
+            <a:ext cx="615820" cy="201168"/>
           </a:xfrm>
           <a:prstGeom prst="rect">
             <a:avLst/>
           </a:prstGeom>
-          <a:noFill/>
-        </p:spPr>
-        <p:txBody>
-          <a:bodyPr wrap="none" anchor="t" lIns="0" rIns="0" tIns="0" bIns="0">
-            <a:spAutoFit/>
-          </a:bodyPr>
-          <a:lstStyle/>
-          <a:p>
-            <a:pPr algn="r"/>
-            <a:r>
-              <a:rPr sz="1100" b="1" i="1">
-                <a:solidFill>
-                  <a:srgbClr val="E0A53A"/>
-                </a:solidFill>
-                <a:latin typeface="Segoe Script"/>
-              </a:rPr>
-              <a:t>Divine</a:t>
-            </a:r>
-          </a:p>
-        </p:txBody>
-      </p:sp>
+        </p:spPr>
+      </p:pic>
       <p:sp>
         <p:nvSpPr>
           <p:cNvPr id="41" name="Oval 40"/>
@@ -11923,12 +11662,20 @@
         <p:nvPr/>
       </p:nvGrpSpPr>
       <p:grpSpPr/>
-      <p:sp>
-        <p:nvSpPr>
-          <p:cNvPr id="2" name="Rectangle 1"/>
-          <p:cNvSpPr/>
-          <p:nvPr/>
-        </p:nvSpPr>
+      <p:pic>
+        <p:nvPicPr>
+          <p:cNvPr id="2" name="Picture 1" descr="header_bg.jpg"/>
+          <p:cNvPicPr>
+            <a:picLocks noChangeAspect="1"/>
+          </p:cNvPicPr>
+          <p:nvPr/>
+        </p:nvPicPr>
+        <p:blipFill>
+          <a:blip r:embed="rId2"/>
+          <a:stretch>
+            <a:fillRect/>
+          </a:stretch>
+        </p:blipFill>
         <p:spPr>
           <a:xfrm>
             <a:off x="0" y="0"/>
@@ -11937,36 +11684,8 @@
           <a:prstGeom prst="rect">
             <a:avLst/>
           </a:prstGeom>
-          <a:solidFill>
-            <a:srgbClr val="3E2419"/>
-          </a:solidFill>
-          <a:ln>
-            <a:noFill/>
-          </a:ln>
-          <a:effectLst/>
-        </p:spPr>
-        <p:style>
-          <a:lnRef idx="1">
-            <a:schemeClr val="accent1"/>
-          </a:lnRef>
-          <a:fillRef idx="3">
-            <a:schemeClr val="accent1"/>
-          </a:fillRef>
-          <a:effectRef idx="2">
-            <a:schemeClr val="accent1"/>
-          </a:effectRef>
-          <a:fontRef idx="minor">
-            <a:schemeClr val="lt1"/>
-          </a:fontRef>
-        </p:style>
-        <p:txBody>
-          <a:bodyPr rtlCol="0" anchor="ctr"/>
-          <a:lstStyle/>
-          <a:p>
-            <a:pPr algn="ctr"/>
-          </a:p>
-        </p:txBody>
-      </p:sp>
+        </p:spPr>
+      </p:pic>
       <p:sp>
         <p:nvSpPr>
           <p:cNvPr id="3" name="Rectangle 2"/>
@@ -12011,61 +11730,30 @@
           </a:p>
         </p:txBody>
       </p:sp>
-      <p:sp>
-        <p:nvSpPr>
-          <p:cNvPr id="4" name="Rounded Rectangle 3"/>
-          <p:cNvSpPr/>
-          <p:nvPr/>
-        </p:nvSpPr>
-        <p:spPr>
-          <a:xfrm>
-            <a:off x="274320" y="155448"/>
-            <a:ext cx="566928" cy="566928"/>
-          </a:xfrm>
-          <a:prstGeom prst="roundRect">
-            <a:avLst>
-              <a:gd name="adj" fmla="val 22000"/>
-            </a:avLst>
-          </a:prstGeom>
-          <a:solidFill>
-            <a:srgbClr val="A83224"/>
-          </a:solidFill>
-          <a:ln>
-            <a:noFill/>
-          </a:ln>
-          <a:effectLst/>
-        </p:spPr>
-        <p:style>
-          <a:lnRef idx="1">
-            <a:schemeClr val="accent1"/>
-          </a:lnRef>
-          <a:fillRef idx="3">
-            <a:schemeClr val="accent1"/>
-          </a:fillRef>
-          <a:effectRef idx="2">
-            <a:schemeClr val="accent1"/>
-          </a:effectRef>
-          <a:fontRef idx="minor">
-            <a:schemeClr val="lt1"/>
-          </a:fontRef>
-        </p:style>
-        <p:txBody>
-          <a:bodyPr rtlCol="0" anchor="ctr" lIns="0" rIns="0" tIns="0" bIns="0"/>
-          <a:lstStyle/>
-          <a:p>
-            <a:pPr algn="ctr"/>
-            <a:r>
-              <a:rPr sz="1000" b="1" i="1">
-                <a:solidFill>
-                  <a:srgbClr val="E0A53A"/>
-                </a:solidFill>
-                <a:latin typeface="Segoe Script"/>
-              </a:rPr>
-              <a:t>Divine</a:t>
-            </a:r>
-          </a:p>
-        </p:txBody>
-      </p:sp>
+      <p:pic>
+        <p:nvPicPr>
+          <p:cNvPr id="4" name="Picture 3" descr="logo_wordmark.png"/>
+          <p:cNvPicPr>
+            <a:picLocks noChangeAspect="1"/>
+          </p:cNvPicPr>
+          <p:nvPr/>
+        </p:nvPicPr>
+        <p:blipFill>
+          <a:blip r:embed="rId3"/>
+          <a:stretch>
+            <a:fillRect/>
+          </a:stretch>
+        </p:blipFill>
+        <p:spPr>
+          <a:xfrm>
+            <a:off x="292608" y="201168"/>
+            <a:ext cx="1511559" cy="493776"/>
+          </a:xfrm>
+          <a:prstGeom prst="rect">
+            <a:avLst/>
+          </a:prstGeom>
+        </p:spPr>
+      </p:pic>
       <p:sp>
         <p:nvSpPr>
           <p:cNvPr id="5" name="TextBox 4"/>
@@ -12074,7 +11762,7 @@
         </p:nvSpPr>
         <p:spPr>
           <a:xfrm>
-            <a:off x="987552" y="141732"/>
+            <a:off x="1968759" y="141732"/>
             <a:ext cx="7315200" cy="228600"/>
           </a:xfrm>
           <a:prstGeom prst="rect">
@@ -12109,7 +11797,7 @@
         </p:nvSpPr>
         <p:spPr>
           <a:xfrm>
-            <a:off x="969264" y="342900"/>
+            <a:off x="1950471" y="342900"/>
             <a:ext cx="7315200" cy="502920"/>
           </a:xfrm>
           <a:prstGeom prst="rect">
@@ -13073,41 +12761,30 @@
           </a:p>
         </p:txBody>
       </p:sp>
-      <p:sp>
-        <p:nvSpPr>
-          <p:cNvPr id="28" name="TextBox 27"/>
-          <p:cNvSpPr txBox="1"/>
-          <p:nvPr/>
-        </p:nvSpPr>
-        <p:spPr>
-          <a:xfrm>
-            <a:off x="11109960" y="6597396"/>
-            <a:ext cx="868680" cy="237744"/>
+      <p:pic>
+        <p:nvPicPr>
+          <p:cNvPr id="28" name="Picture 27" descr="logo_wordmark.png"/>
+          <p:cNvPicPr>
+            <a:picLocks noChangeAspect="1"/>
+          </p:cNvPicPr>
+          <p:nvPr/>
+        </p:nvPicPr>
+        <p:blipFill>
+          <a:blip r:embed="rId3"/>
+          <a:stretch>
+            <a:fillRect/>
+          </a:stretch>
+        </p:blipFill>
+        <p:spPr>
+          <a:xfrm>
+            <a:off x="11225660" y="6611112"/>
+            <a:ext cx="615820" cy="201168"/>
           </a:xfrm>
           <a:prstGeom prst="rect">
             <a:avLst/>
           </a:prstGeom>
-          <a:noFill/>
-        </p:spPr>
-        <p:txBody>
-          <a:bodyPr wrap="none" anchor="t" lIns="0" rIns="0" tIns="0" bIns="0">
-            <a:spAutoFit/>
-          </a:bodyPr>
-          <a:lstStyle/>
-          <a:p>
-            <a:pPr algn="r"/>
-            <a:r>
-              <a:rPr sz="1100" b="1" i="1">
-                <a:solidFill>
-                  <a:srgbClr val="E0A53A"/>
-                </a:solidFill>
-                <a:latin typeface="Segoe Script"/>
-              </a:rPr>
-              <a:t>Divine</a:t>
-            </a:r>
-          </a:p>
-        </p:txBody>
-      </p:sp>
+        </p:spPr>
+      </p:pic>
     </p:spTree>
   </p:cSld>
   <p:clrMapOvr>
@@ -13134,12 +12811,20 @@
         <p:nvPr/>
       </p:nvGrpSpPr>
       <p:grpSpPr/>
-      <p:sp>
-        <p:nvSpPr>
-          <p:cNvPr id="2" name="Rectangle 1"/>
-          <p:cNvSpPr/>
-          <p:nvPr/>
-        </p:nvSpPr>
+      <p:pic>
+        <p:nvPicPr>
+          <p:cNvPr id="2" name="Picture 1" descr="header_bg.jpg"/>
+          <p:cNvPicPr>
+            <a:picLocks noChangeAspect="1"/>
+          </p:cNvPicPr>
+          <p:nvPr/>
+        </p:nvPicPr>
+        <p:blipFill>
+          <a:blip r:embed="rId2"/>
+          <a:stretch>
+            <a:fillRect/>
+          </a:stretch>
+        </p:blipFill>
         <p:spPr>
           <a:xfrm>
             <a:off x="0" y="0"/>
@@ -13148,36 +12833,8 @@
           <a:prstGeom prst="rect">
             <a:avLst/>
           </a:prstGeom>
-          <a:solidFill>
-            <a:srgbClr val="3E2419"/>
-          </a:solidFill>
-          <a:ln>
-            <a:noFill/>
-          </a:ln>
-          <a:effectLst/>
-        </p:spPr>
-        <p:style>
-          <a:lnRef idx="1">
-            <a:schemeClr val="accent1"/>
-          </a:lnRef>
-          <a:fillRef idx="3">
-            <a:schemeClr val="accent1"/>
-          </a:fillRef>
-          <a:effectRef idx="2">
-            <a:schemeClr val="accent1"/>
-          </a:effectRef>
-          <a:fontRef idx="minor">
-            <a:schemeClr val="lt1"/>
-          </a:fontRef>
-        </p:style>
-        <p:txBody>
-          <a:bodyPr rtlCol="0" anchor="ctr"/>
-          <a:lstStyle/>
-          <a:p>
-            <a:pPr algn="ctr"/>
-          </a:p>
-        </p:txBody>
-      </p:sp>
+        </p:spPr>
+      </p:pic>
       <p:sp>
         <p:nvSpPr>
           <p:cNvPr id="3" name="Rectangle 2"/>
@@ -13222,61 +12879,30 @@
           </a:p>
         </p:txBody>
       </p:sp>
-      <p:sp>
-        <p:nvSpPr>
-          <p:cNvPr id="4" name="Rounded Rectangle 3"/>
-          <p:cNvSpPr/>
-          <p:nvPr/>
-        </p:nvSpPr>
-        <p:spPr>
-          <a:xfrm>
-            <a:off x="274320" y="155448"/>
-            <a:ext cx="566928" cy="566928"/>
-          </a:xfrm>
-          <a:prstGeom prst="roundRect">
-            <a:avLst>
-              <a:gd name="adj" fmla="val 22000"/>
-            </a:avLst>
-          </a:prstGeom>
-          <a:solidFill>
-            <a:srgbClr val="A83224"/>
-          </a:solidFill>
-          <a:ln>
-            <a:noFill/>
-          </a:ln>
-          <a:effectLst/>
-        </p:spPr>
-        <p:style>
-          <a:lnRef idx="1">
-            <a:schemeClr val="accent1"/>
-          </a:lnRef>
-          <a:fillRef idx="3">
-            <a:schemeClr val="accent1"/>
-          </a:fillRef>
-          <a:effectRef idx="2">
-            <a:schemeClr val="accent1"/>
-          </a:effectRef>
-          <a:fontRef idx="minor">
-            <a:schemeClr val="lt1"/>
-          </a:fontRef>
-        </p:style>
-        <p:txBody>
-          <a:bodyPr rtlCol="0" anchor="ctr" lIns="0" rIns="0" tIns="0" bIns="0"/>
-          <a:lstStyle/>
-          <a:p>
-            <a:pPr algn="ctr"/>
-            <a:r>
-              <a:rPr sz="1000" b="1" i="1">
-                <a:solidFill>
-                  <a:srgbClr val="E0A53A"/>
-                </a:solidFill>
-                <a:latin typeface="Segoe Script"/>
-              </a:rPr>
-              <a:t>Divine</a:t>
-            </a:r>
-          </a:p>
-        </p:txBody>
-      </p:sp>
+      <p:pic>
+        <p:nvPicPr>
+          <p:cNvPr id="4" name="Picture 3" descr="logo_wordmark.png"/>
+          <p:cNvPicPr>
+            <a:picLocks noChangeAspect="1"/>
+          </p:cNvPicPr>
+          <p:nvPr/>
+        </p:nvPicPr>
+        <p:blipFill>
+          <a:blip r:embed="rId3"/>
+          <a:stretch>
+            <a:fillRect/>
+          </a:stretch>
+        </p:blipFill>
+        <p:spPr>
+          <a:xfrm>
+            <a:off x="292608" y="201168"/>
+            <a:ext cx="1511559" cy="493776"/>
+          </a:xfrm>
+          <a:prstGeom prst="rect">
+            <a:avLst/>
+          </a:prstGeom>
+        </p:spPr>
+      </p:pic>
       <p:sp>
         <p:nvSpPr>
           <p:cNvPr id="5" name="TextBox 4"/>
@@ -13285,7 +12911,7 @@
         </p:nvSpPr>
         <p:spPr>
           <a:xfrm>
-            <a:off x="987552" y="141732"/>
+            <a:off x="1968759" y="141732"/>
             <a:ext cx="7315200" cy="228600"/>
           </a:xfrm>
           <a:prstGeom prst="rect">
@@ -13320,7 +12946,7 @@
         </p:nvSpPr>
         <p:spPr>
           <a:xfrm>
-            <a:off x="969264" y="342900"/>
+            <a:off x="1950471" y="342900"/>
             <a:ext cx="7315200" cy="502920"/>
           </a:xfrm>
           <a:prstGeom prst="rect">
@@ -14588,41 +14214,30 @@
           </a:p>
         </p:txBody>
       </p:sp>
-      <p:sp>
-        <p:nvSpPr>
-          <p:cNvPr id="31" name="TextBox 30"/>
-          <p:cNvSpPr txBox="1"/>
-          <p:nvPr/>
-        </p:nvSpPr>
-        <p:spPr>
-          <a:xfrm>
-            <a:off x="11109960" y="6597396"/>
-            <a:ext cx="868680" cy="237744"/>
+      <p:pic>
+        <p:nvPicPr>
+          <p:cNvPr id="31" name="Picture 30" descr="logo_wordmark.png"/>
+          <p:cNvPicPr>
+            <a:picLocks noChangeAspect="1"/>
+          </p:cNvPicPr>
+          <p:nvPr/>
+        </p:nvPicPr>
+        <p:blipFill>
+          <a:blip r:embed="rId3"/>
+          <a:stretch>
+            <a:fillRect/>
+          </a:stretch>
+        </p:blipFill>
+        <p:spPr>
+          <a:xfrm>
+            <a:off x="11225660" y="6611112"/>
+            <a:ext cx="615820" cy="201168"/>
           </a:xfrm>
           <a:prstGeom prst="rect">
             <a:avLst/>
           </a:prstGeom>
-          <a:noFill/>
-        </p:spPr>
-        <p:txBody>
-          <a:bodyPr wrap="none" anchor="t" lIns="0" rIns="0" tIns="0" bIns="0">
-            <a:spAutoFit/>
-          </a:bodyPr>
-          <a:lstStyle/>
-          <a:p>
-            <a:pPr algn="r"/>
-            <a:r>
-              <a:rPr sz="1100" b="1" i="1">
-                <a:solidFill>
-                  <a:srgbClr val="E0A53A"/>
-                </a:solidFill>
-                <a:latin typeface="Segoe Script"/>
-              </a:rPr>
-              <a:t>Divine</a:t>
-            </a:r>
-          </a:p>
-        </p:txBody>
-      </p:sp>
+        </p:spPr>
+      </p:pic>
     </p:spTree>
   </p:cSld>
   <p:clrMapOvr>

</xml_diff>

<commit_message>
Adiciona animações à apresentação (transições fade + entradas em cascata)
- Transição fade suave entre todos os slides (universal)
- Capa cinematográfica: eyebrow -> título -> subtítulo -> pílula -> logo
  entram em sequência
- Slides de conteúdo: Pendências -> Próximas Ações -> Observações em cascata;
  no slide de orçamento, imagens -> painel financeiro
- Editor: pós-processa o .pptx no navegador (JSZip) injetando transição+timing
  nas formas marcadas com objectName; renumera cNvPr para IDs únicos
  (corrige duplicidade do pptxgenjs)
- Modelo estático: mesma identidade via anim_lib.py (XML canônico do PowerPoint)

Co-Authored-By: Claude Opus 4.8 <noreply@anthropic.com>
Claude-Session: https://claude.ai/code/session_01J4WuzLuPWbPdpadmrD14Gs
</commit_message>
<xml_diff>
--- a/apresentacao/Divine_Acompanhamento_Projetos_MODELO.pptx
+++ b/apresentacao/Divine_Acompanhamento_Projetos_MODELO.pptx
@@ -3417,6 +3417,347 @@
   <p:clrMapOvr>
     <a:masterClrMapping/>
   </p:clrMapOvr>
+  <p:transition spd="med">
+    <p:fade/>
+  </p:transition>
+  <p:timing>
+    <p:tnLst>
+      <p:par>
+        <p:cTn id="1" dur="indefinite" restart="never" nodeType="tmRoot">
+          <p:childTnLst>
+            <p:seq concurrent="1" nextAc="seek">
+              <p:cTn id="2" dur="indefinite" nodeType="mainSeq">
+                <p:childTnLst>
+                  <p:par>
+                    <p:cTn id="3" fill="hold">
+                      <p:stCondLst>
+                        <p:cond delay="200"/>
+                      </p:stCondLst>
+                      <p:childTnLst>
+                        <p:par>
+                          <p:cTn id="4" fill="hold">
+                            <p:stCondLst>
+                              <p:cond delay="0"/>
+                            </p:stCondLst>
+                            <p:childTnLst>
+                              <p:par>
+                                <p:cTn id="5" presetID="10" presetClass="entr" presetSubtype="0" fill="hold" grpId="0" nodeType="afterEffect">
+                                  <p:stCondLst>
+                                    <p:cond delay="0"/>
+                                  </p:stCondLst>
+                                  <p:childTnLst>
+                                    <p:set>
+                                      <p:cBhvr>
+                                        <p:cTn id="6" dur="1" fill="hold">
+                                          <p:stCondLst>
+                                            <p:cond delay="0"/>
+                                          </p:stCondLst>
+                                        </p:cTn>
+                                        <p:tgtEl>
+                                          <p:spTgt spid="4"/>
+                                        </p:tgtEl>
+                                        <p:attrNameLst>
+                                          <p:attrName>style.visibility</p:attrName>
+                                        </p:attrNameLst>
+                                      </p:cBhvr>
+                                      <p:to>
+                                        <p:strVal val="visible"/>
+                                      </p:to>
+                                    </p:set>
+                                    <p:animEffect transition="in" filter="fade">
+                                      <p:cBhvr>
+                                        <p:cTn id="7" dur="420"/>
+                                        <p:tgtEl>
+                                          <p:spTgt spid="4"/>
+                                        </p:tgtEl>
+                                      </p:cBhvr>
+                                    </p:animEffect>
+                                  </p:childTnLst>
+                                </p:cTn>
+                              </p:par>
+                            </p:childTnLst>
+                          </p:cTn>
+                        </p:par>
+                      </p:childTnLst>
+                    </p:cTn>
+                  </p:par>
+                  <p:par>
+                    <p:cTn id="8" fill="hold">
+                      <p:stCondLst>
+                        <p:cond delay="350"/>
+                      </p:stCondLst>
+                      <p:childTnLst>
+                        <p:par>
+                          <p:cTn id="9" fill="hold">
+                            <p:stCondLst>
+                              <p:cond delay="0"/>
+                            </p:stCondLst>
+                            <p:childTnLst>
+                              <p:par>
+                                <p:cTn id="10" presetID="10" presetClass="entr" presetSubtype="0" fill="hold" grpId="0" nodeType="afterEffect">
+                                  <p:stCondLst>
+                                    <p:cond delay="0"/>
+                                  </p:stCondLst>
+                                  <p:childTnLst>
+                                    <p:set>
+                                      <p:cBhvr>
+                                        <p:cTn id="11" dur="1" fill="hold">
+                                          <p:stCondLst>
+                                            <p:cond delay="0"/>
+                                          </p:stCondLst>
+                                        </p:cTn>
+                                        <p:tgtEl>
+                                          <p:spTgt spid="5"/>
+                                        </p:tgtEl>
+                                        <p:attrNameLst>
+                                          <p:attrName>style.visibility</p:attrName>
+                                        </p:attrNameLst>
+                                      </p:cBhvr>
+                                      <p:to>
+                                        <p:strVal val="visible"/>
+                                      </p:to>
+                                    </p:set>
+                                    <p:animEffect transition="in" filter="fade">
+                                      <p:cBhvr>
+                                        <p:cTn id="12" dur="420"/>
+                                        <p:tgtEl>
+                                          <p:spTgt spid="5"/>
+                                        </p:tgtEl>
+                                      </p:cBhvr>
+                                    </p:animEffect>
+                                  </p:childTnLst>
+                                </p:cTn>
+                              </p:par>
+                            </p:childTnLst>
+                          </p:cTn>
+                        </p:par>
+                      </p:childTnLst>
+                    </p:cTn>
+                  </p:par>
+                  <p:par>
+                    <p:cTn id="13" fill="hold">
+                      <p:stCondLst>
+                        <p:cond delay="350"/>
+                      </p:stCondLst>
+                      <p:childTnLst>
+                        <p:par>
+                          <p:cTn id="14" fill="hold">
+                            <p:stCondLst>
+                              <p:cond delay="0"/>
+                            </p:stCondLst>
+                            <p:childTnLst>
+                              <p:par>
+                                <p:cTn id="15" presetID="10" presetClass="entr" presetSubtype="0" fill="hold" grpId="0" nodeType="afterEffect">
+                                  <p:stCondLst>
+                                    <p:cond delay="0"/>
+                                  </p:stCondLst>
+                                  <p:childTnLst>
+                                    <p:set>
+                                      <p:cBhvr>
+                                        <p:cTn id="16" dur="1" fill="hold">
+                                          <p:stCondLst>
+                                            <p:cond delay="0"/>
+                                          </p:stCondLst>
+                                        </p:cTn>
+                                        <p:tgtEl>
+                                          <p:spTgt spid="6"/>
+                                        </p:tgtEl>
+                                        <p:attrNameLst>
+                                          <p:attrName>style.visibility</p:attrName>
+                                        </p:attrNameLst>
+                                      </p:cBhvr>
+                                      <p:to>
+                                        <p:strVal val="visible"/>
+                                      </p:to>
+                                    </p:set>
+                                    <p:animEffect transition="in" filter="fade">
+                                      <p:cBhvr>
+                                        <p:cTn id="17" dur="420"/>
+                                        <p:tgtEl>
+                                          <p:spTgt spid="6"/>
+                                        </p:tgtEl>
+                                      </p:cBhvr>
+                                    </p:animEffect>
+                                  </p:childTnLst>
+                                </p:cTn>
+                              </p:par>
+                            </p:childTnLst>
+                          </p:cTn>
+                        </p:par>
+                      </p:childTnLst>
+                    </p:cTn>
+                  </p:par>
+                  <p:par>
+                    <p:cTn id="18" fill="hold">
+                      <p:stCondLst>
+                        <p:cond delay="350"/>
+                      </p:stCondLst>
+                      <p:childTnLst>
+                        <p:par>
+                          <p:cTn id="19" fill="hold">
+                            <p:stCondLst>
+                              <p:cond delay="0"/>
+                            </p:stCondLst>
+                            <p:childTnLst>
+                              <p:par>
+                                <p:cTn id="20" presetID="10" presetClass="entr" presetSubtype="0" fill="hold" grpId="0" nodeType="afterEffect">
+                                  <p:stCondLst>
+                                    <p:cond delay="0"/>
+                                  </p:stCondLst>
+                                  <p:childTnLst>
+                                    <p:set>
+                                      <p:cBhvr>
+                                        <p:cTn id="21" dur="1" fill="hold">
+                                          <p:stCondLst>
+                                            <p:cond delay="0"/>
+                                          </p:stCondLst>
+                                        </p:cTn>
+                                        <p:tgtEl>
+                                          <p:spTgt spid="7"/>
+                                        </p:tgtEl>
+                                        <p:attrNameLst>
+                                          <p:attrName>style.visibility</p:attrName>
+                                        </p:attrNameLst>
+                                      </p:cBhvr>
+                                      <p:to>
+                                        <p:strVal val="visible"/>
+                                      </p:to>
+                                    </p:set>
+                                    <p:animEffect transition="in" filter="fade">
+                                      <p:cBhvr>
+                                        <p:cTn id="22" dur="420"/>
+                                        <p:tgtEl>
+                                          <p:spTgt spid="7"/>
+                                        </p:tgtEl>
+                                      </p:cBhvr>
+                                    </p:animEffect>
+                                  </p:childTnLst>
+                                </p:cTn>
+                              </p:par>
+                            </p:childTnLst>
+                          </p:cTn>
+                        </p:par>
+                      </p:childTnLst>
+                    </p:cTn>
+                  </p:par>
+                  <p:par>
+                    <p:cTn id="23" fill="hold">
+                      <p:stCondLst>
+                        <p:cond delay="350"/>
+                      </p:stCondLst>
+                      <p:childTnLst>
+                        <p:par>
+                          <p:cTn id="24" fill="hold">
+                            <p:stCondLst>
+                              <p:cond delay="0"/>
+                            </p:stCondLst>
+                            <p:childTnLst>
+                              <p:par>
+                                <p:cTn id="25" presetID="10" presetClass="entr" presetSubtype="0" fill="hold" grpId="0" nodeType="afterEffect">
+                                  <p:stCondLst>
+                                    <p:cond delay="0"/>
+                                  </p:stCondLst>
+                                  <p:childTnLst>
+                                    <p:set>
+                                      <p:cBhvr>
+                                        <p:cTn id="26" dur="1" fill="hold">
+                                          <p:stCondLst>
+                                            <p:cond delay="0"/>
+                                          </p:stCondLst>
+                                        </p:cTn>
+                                        <p:tgtEl>
+                                          <p:spTgt spid="8"/>
+                                        </p:tgtEl>
+                                        <p:attrNameLst>
+                                          <p:attrName>style.visibility</p:attrName>
+                                        </p:attrNameLst>
+                                      </p:cBhvr>
+                                      <p:to>
+                                        <p:strVal val="visible"/>
+                                      </p:to>
+                                    </p:set>
+                                    <p:animEffect transition="in" filter="fade">
+                                      <p:cBhvr>
+                                        <p:cTn id="27" dur="420"/>
+                                        <p:tgtEl>
+                                          <p:spTgt spid="8"/>
+                                        </p:tgtEl>
+                                      </p:cBhvr>
+                                    </p:animEffect>
+                                  </p:childTnLst>
+                                </p:cTn>
+                              </p:par>
+                              <p:par>
+                                <p:cTn id="28" presetID="10" presetClass="entr" presetSubtype="0" fill="hold" grpId="0" nodeType="withEffect">
+                                  <p:stCondLst>
+                                    <p:cond delay="0"/>
+                                  </p:stCondLst>
+                                  <p:childTnLst>
+                                    <p:set>
+                                      <p:cBhvr>
+                                        <p:cTn id="29" dur="1" fill="hold">
+                                          <p:stCondLst>
+                                            <p:cond delay="0"/>
+                                          </p:stCondLst>
+                                        </p:cTn>
+                                        <p:tgtEl>
+                                          <p:spTgt spid="9"/>
+                                        </p:tgtEl>
+                                        <p:attrNameLst>
+                                          <p:attrName>style.visibility</p:attrName>
+                                        </p:attrNameLst>
+                                      </p:cBhvr>
+                                      <p:to>
+                                        <p:strVal val="visible"/>
+                                      </p:to>
+                                    </p:set>
+                                    <p:animEffect transition="in" filter="fade">
+                                      <p:cBhvr>
+                                        <p:cTn id="30" dur="420"/>
+                                        <p:tgtEl>
+                                          <p:spTgt spid="9"/>
+                                        </p:tgtEl>
+                                      </p:cBhvr>
+                                    </p:animEffect>
+                                  </p:childTnLst>
+                                </p:cTn>
+                              </p:par>
+                            </p:childTnLst>
+                          </p:cTn>
+                        </p:par>
+                      </p:childTnLst>
+                    </p:cTn>
+                  </p:par>
+                </p:childTnLst>
+              </p:cTn>
+              <p:prevCondLst>
+                <p:cond evt="onPrev" delay="0">
+                  <p:tgtEl>
+                    <p:sldTgt/>
+                  </p:tgtEl>
+                </p:cond>
+              </p:prevCondLst>
+              <p:nextCondLst>
+                <p:cond evt="onNext" delay="0">
+                  <p:tgtEl>
+                    <p:sldTgt/>
+                  </p:tgtEl>
+                </p:cond>
+              </p:nextCondLst>
+            </p:seq>
+          </p:childTnLst>
+        </p:cTn>
+      </p:par>
+    </p:tnLst>
+    <p:bldLst>
+      <p:bldP spid="4" grpId="0" animBg="1"/>
+      <p:bldP spid="5" grpId="0" animBg="1"/>
+      <p:bldP spid="6" grpId="0" animBg="1"/>
+      <p:bldP spid="7" grpId="0" animBg="1"/>
+      <p:bldP spid="8" grpId="0" animBg="1"/>
+      <p:bldP spid="9" grpId="0" animBg="1"/>
+    </p:bldLst>
+  </p:timing>
 </p:sld>
 </file>
 
@@ -6136,7 +6477,7 @@
       </p:sp>
       <p:sp>
         <p:nvSpPr>
-          <p:cNvPr id="39" name="Rectangle 38"/>
+          <p:cNvPr id="45" name="Rectangle 44"/>
           <p:cNvSpPr/>
           <p:nvPr/>
         </p:nvSpPr>
@@ -6180,7 +6521,7 @@
       </p:sp>
       <p:pic>
         <p:nvPicPr>
-          <p:cNvPr id="40" name="Picture 39" descr="logo_wordmark.png"/>
+          <p:cNvPr id="46" name="Picture 45" descr="logo_wordmark.png"/>
           <p:cNvPicPr>
             <a:picLocks noChangeAspect="1"/>
           </p:cNvPicPr>
@@ -6204,7 +6545,7 @@
       </p:pic>
       <p:sp>
         <p:nvSpPr>
-          <p:cNvPr id="41" name="Oval 40"/>
+          <p:cNvPr id="47" name="Oval 46"/>
           <p:cNvSpPr/>
           <p:nvPr/>
         </p:nvSpPr>
@@ -6248,7 +6589,7 @@
       </p:sp>
       <p:sp>
         <p:nvSpPr>
-          <p:cNvPr id="42" name="TextBox 41"/>
+          <p:cNvPr id="48" name="TextBox 47"/>
           <p:cNvSpPr txBox="1"/>
           <p:nvPr/>
         </p:nvSpPr>
@@ -6283,7 +6624,7 @@
       </p:sp>
       <p:sp>
         <p:nvSpPr>
-          <p:cNvPr id="43" name="Oval 42"/>
+          <p:cNvPr id="49" name="Oval 48"/>
           <p:cNvSpPr/>
           <p:nvPr/>
         </p:nvSpPr>
@@ -6327,7 +6668,7 @@
       </p:sp>
       <p:sp>
         <p:nvSpPr>
-          <p:cNvPr id="44" name="TextBox 43"/>
+          <p:cNvPr id="50" name="TextBox 49"/>
           <p:cNvSpPr txBox="1"/>
           <p:nvPr/>
         </p:nvSpPr>
@@ -6362,7 +6703,7 @@
       </p:sp>
       <p:sp>
         <p:nvSpPr>
-          <p:cNvPr id="45" name="Oval 44"/>
+          <p:cNvPr id="51" name="Oval 50"/>
           <p:cNvSpPr/>
           <p:nvPr/>
         </p:nvSpPr>
@@ -6408,7 +6749,7 @@
       </p:sp>
       <p:sp>
         <p:nvSpPr>
-          <p:cNvPr id="46" name="TextBox 45"/>
+          <p:cNvPr id="52" name="TextBox 51"/>
           <p:cNvSpPr txBox="1"/>
           <p:nvPr/>
         </p:nvSpPr>
@@ -6443,7 +6784,7 @@
       </p:sp>
       <p:sp>
         <p:nvSpPr>
-          <p:cNvPr id="47" name="Oval 46"/>
+          <p:cNvPr id="53" name="Oval 52"/>
           <p:cNvSpPr/>
           <p:nvPr/>
         </p:nvSpPr>
@@ -6487,7 +6828,7 @@
       </p:sp>
       <p:sp>
         <p:nvSpPr>
-          <p:cNvPr id="48" name="TextBox 47"/>
+          <p:cNvPr id="54" name="TextBox 53"/>
           <p:cNvSpPr txBox="1"/>
           <p:nvPr/>
         </p:nvSpPr>
@@ -6522,7 +6863,7 @@
       </p:sp>
       <p:sp>
         <p:nvSpPr>
-          <p:cNvPr id="49" name="Rounded Rectangle 48"/>
+          <p:cNvPr id="55" name="Rounded Rectangle 54"/>
           <p:cNvSpPr/>
           <p:nvPr/>
         </p:nvSpPr>
@@ -6570,7 +6911,7 @@
       </p:sp>
       <p:sp>
         <p:nvSpPr>
-          <p:cNvPr id="50" name="TextBox 49"/>
+          <p:cNvPr id="56" name="TextBox 55"/>
           <p:cNvSpPr txBox="1"/>
           <p:nvPr/>
         </p:nvSpPr>
@@ -6617,7 +6958,7 @@
       </p:sp>
       <p:sp>
         <p:nvSpPr>
-          <p:cNvPr id="51" name="Oval 50"/>
+          <p:cNvPr id="57" name="Oval 56"/>
           <p:cNvSpPr/>
           <p:nvPr/>
         </p:nvSpPr>
@@ -6670,7 +7011,7 @@
       </p:sp>
       <p:sp>
         <p:nvSpPr>
-          <p:cNvPr id="52" name="TextBox 51"/>
+          <p:cNvPr id="58" name="TextBox 57"/>
           <p:cNvSpPr txBox="1"/>
           <p:nvPr/>
         </p:nvSpPr>
@@ -6705,7 +7046,7 @@
       </p:sp>
       <p:sp>
         <p:nvSpPr>
-          <p:cNvPr id="53" name="Oval 52"/>
+          <p:cNvPr id="59" name="Oval 58"/>
           <p:cNvSpPr/>
           <p:nvPr/>
         </p:nvSpPr>
@@ -6749,7 +7090,7 @@
       </p:sp>
       <p:sp>
         <p:nvSpPr>
-          <p:cNvPr id="54" name="TextBox 53"/>
+          <p:cNvPr id="60" name="TextBox 59"/>
           <p:cNvSpPr txBox="1"/>
           <p:nvPr/>
         </p:nvSpPr>
@@ -6784,7 +7125,7 @@
       </p:sp>
       <p:sp>
         <p:nvSpPr>
-          <p:cNvPr id="55" name="Oval 54"/>
+          <p:cNvPr id="61" name="Oval 60"/>
           <p:cNvSpPr/>
           <p:nvPr/>
         </p:nvSpPr>
@@ -6837,7 +7178,7 @@
       </p:sp>
       <p:sp>
         <p:nvSpPr>
-          <p:cNvPr id="56" name="TextBox 55"/>
+          <p:cNvPr id="62" name="TextBox 61"/>
           <p:cNvSpPr txBox="1"/>
           <p:nvPr/>
         </p:nvSpPr>
@@ -6872,7 +7213,7 @@
       </p:sp>
       <p:sp>
         <p:nvSpPr>
-          <p:cNvPr id="57" name="Oval 56"/>
+          <p:cNvPr id="63" name="Oval 62"/>
           <p:cNvSpPr/>
           <p:nvPr/>
         </p:nvSpPr>
@@ -6918,7 +7259,7 @@
       </p:sp>
       <p:sp>
         <p:nvSpPr>
-          <p:cNvPr id="58" name="TextBox 57"/>
+          <p:cNvPr id="64" name="TextBox 63"/>
           <p:cNvSpPr txBox="1"/>
           <p:nvPr/>
         </p:nvSpPr>
@@ -6956,6 +7297,527 @@
   <p:clrMapOvr>
     <a:masterClrMapping/>
   </p:clrMapOvr>
+  <p:transition spd="med">
+    <p:fade/>
+  </p:transition>
+  <p:timing>
+    <p:tnLst>
+      <p:par>
+        <p:cTn id="1" dur="indefinite" restart="never" nodeType="tmRoot">
+          <p:childTnLst>
+            <p:seq concurrent="1" nextAc="seek">
+              <p:cTn id="2" dur="indefinite" nodeType="mainSeq">
+                <p:childTnLst>
+                  <p:par>
+                    <p:cTn id="3" fill="hold">
+                      <p:stCondLst>
+                        <p:cond delay="200"/>
+                      </p:stCondLst>
+                      <p:childTnLst>
+                        <p:par>
+                          <p:cTn id="4" fill="hold">
+                            <p:stCondLst>
+                              <p:cond delay="0"/>
+                            </p:stCondLst>
+                            <p:childTnLst>
+                              <p:par>
+                                <p:cTn id="5" presetID="10" presetClass="entr" presetSubtype="0" fill="hold" grpId="0" nodeType="afterEffect">
+                                  <p:stCondLst>
+                                    <p:cond delay="0"/>
+                                  </p:stCondLst>
+                                  <p:childTnLst>
+                                    <p:set>
+                                      <p:cBhvr>
+                                        <p:cTn id="6" dur="1" fill="hold">
+                                          <p:stCondLst>
+                                            <p:cond delay="0"/>
+                                          </p:stCondLst>
+                                        </p:cTn>
+                                        <p:tgtEl>
+                                          <p:spTgt spid="27"/>
+                                        </p:tgtEl>
+                                        <p:attrNameLst>
+                                          <p:attrName>style.visibility</p:attrName>
+                                        </p:attrNameLst>
+                                      </p:cBhvr>
+                                      <p:to>
+                                        <p:strVal val="visible"/>
+                                      </p:to>
+                                    </p:set>
+                                    <p:animEffect transition="in" filter="fade">
+                                      <p:cBhvr>
+                                        <p:cTn id="7" dur="420"/>
+                                        <p:tgtEl>
+                                          <p:spTgt spid="27"/>
+                                        </p:tgtEl>
+                                      </p:cBhvr>
+                                    </p:animEffect>
+                                  </p:childTnLst>
+                                </p:cTn>
+                              </p:par>
+                              <p:par>
+                                <p:cTn id="8" presetID="10" presetClass="entr" presetSubtype="0" fill="hold" grpId="0" nodeType="withEffect">
+                                  <p:stCondLst>
+                                    <p:cond delay="0"/>
+                                  </p:stCondLst>
+                                  <p:childTnLst>
+                                    <p:set>
+                                      <p:cBhvr>
+                                        <p:cTn id="9" dur="1" fill="hold">
+                                          <p:stCondLst>
+                                            <p:cond delay="0"/>
+                                          </p:stCondLst>
+                                        </p:cTn>
+                                        <p:tgtEl>
+                                          <p:spTgt spid="28"/>
+                                        </p:tgtEl>
+                                        <p:attrNameLst>
+                                          <p:attrName>style.visibility</p:attrName>
+                                        </p:attrNameLst>
+                                      </p:cBhvr>
+                                      <p:to>
+                                        <p:strVal val="visible"/>
+                                      </p:to>
+                                    </p:set>
+                                    <p:animEffect transition="in" filter="fade">
+                                      <p:cBhvr>
+                                        <p:cTn id="10" dur="420"/>
+                                        <p:tgtEl>
+                                          <p:spTgt spid="28"/>
+                                        </p:tgtEl>
+                                      </p:cBhvr>
+                                    </p:animEffect>
+                                  </p:childTnLst>
+                                </p:cTn>
+                              </p:par>
+                              <p:par>
+                                <p:cTn id="11" presetID="10" presetClass="entr" presetSubtype="0" fill="hold" grpId="0" nodeType="withEffect">
+                                  <p:stCondLst>
+                                    <p:cond delay="0"/>
+                                  </p:stCondLst>
+                                  <p:childTnLst>
+                                    <p:set>
+                                      <p:cBhvr>
+                                        <p:cTn id="12" dur="1" fill="hold">
+                                          <p:stCondLst>
+                                            <p:cond delay="0"/>
+                                          </p:stCondLst>
+                                        </p:cTn>
+                                        <p:tgtEl>
+                                          <p:spTgt spid="29"/>
+                                        </p:tgtEl>
+                                        <p:attrNameLst>
+                                          <p:attrName>style.visibility</p:attrName>
+                                        </p:attrNameLst>
+                                      </p:cBhvr>
+                                      <p:to>
+                                        <p:strVal val="visible"/>
+                                      </p:to>
+                                    </p:set>
+                                    <p:animEffect transition="in" filter="fade">
+                                      <p:cBhvr>
+                                        <p:cTn id="13" dur="420"/>
+                                        <p:tgtEl>
+                                          <p:spTgt spid="29"/>
+                                        </p:tgtEl>
+                                      </p:cBhvr>
+                                    </p:animEffect>
+                                  </p:childTnLst>
+                                </p:cTn>
+                              </p:par>
+                              <p:par>
+                                <p:cTn id="14" presetID="10" presetClass="entr" presetSubtype="0" fill="hold" grpId="0" nodeType="withEffect">
+                                  <p:stCondLst>
+                                    <p:cond delay="0"/>
+                                  </p:stCondLst>
+                                  <p:childTnLst>
+                                    <p:set>
+                                      <p:cBhvr>
+                                        <p:cTn id="15" dur="1" fill="hold">
+                                          <p:stCondLst>
+                                            <p:cond delay="0"/>
+                                          </p:stCondLst>
+                                        </p:cTn>
+                                        <p:tgtEl>
+                                          <p:spTgt spid="30"/>
+                                        </p:tgtEl>
+                                        <p:attrNameLst>
+                                          <p:attrName>style.visibility</p:attrName>
+                                        </p:attrNameLst>
+                                      </p:cBhvr>
+                                      <p:to>
+                                        <p:strVal val="visible"/>
+                                      </p:to>
+                                    </p:set>
+                                    <p:animEffect transition="in" filter="fade">
+                                      <p:cBhvr>
+                                        <p:cTn id="16" dur="420"/>
+                                        <p:tgtEl>
+                                          <p:spTgt spid="30"/>
+                                        </p:tgtEl>
+                                      </p:cBhvr>
+                                    </p:animEffect>
+                                  </p:childTnLst>
+                                </p:cTn>
+                              </p:par>
+                            </p:childTnLst>
+                          </p:cTn>
+                        </p:par>
+                      </p:childTnLst>
+                    </p:cTn>
+                  </p:par>
+                  <p:par>
+                    <p:cTn id="17" fill="hold">
+                      <p:stCondLst>
+                        <p:cond delay="350"/>
+                      </p:stCondLst>
+                      <p:childTnLst>
+                        <p:par>
+                          <p:cTn id="18" fill="hold">
+                            <p:stCondLst>
+                              <p:cond delay="0"/>
+                            </p:stCondLst>
+                            <p:childTnLst>
+                              <p:par>
+                                <p:cTn id="19" presetID="10" presetClass="entr" presetSubtype="0" fill="hold" grpId="0" nodeType="afterEffect">
+                                  <p:stCondLst>
+                                    <p:cond delay="0"/>
+                                  </p:stCondLst>
+                                  <p:childTnLst>
+                                    <p:set>
+                                      <p:cBhvr>
+                                        <p:cTn id="20" dur="1" fill="hold">
+                                          <p:stCondLst>
+                                            <p:cond delay="0"/>
+                                          </p:stCondLst>
+                                        </p:cTn>
+                                        <p:tgtEl>
+                                          <p:spTgt spid="31"/>
+                                        </p:tgtEl>
+                                        <p:attrNameLst>
+                                          <p:attrName>style.visibility</p:attrName>
+                                        </p:attrNameLst>
+                                      </p:cBhvr>
+                                      <p:to>
+                                        <p:strVal val="visible"/>
+                                      </p:to>
+                                    </p:set>
+                                    <p:animEffect transition="in" filter="fade">
+                                      <p:cBhvr>
+                                        <p:cTn id="21" dur="420"/>
+                                        <p:tgtEl>
+                                          <p:spTgt spid="31"/>
+                                        </p:tgtEl>
+                                      </p:cBhvr>
+                                    </p:animEffect>
+                                  </p:childTnLst>
+                                </p:cTn>
+                              </p:par>
+                              <p:par>
+                                <p:cTn id="22" presetID="10" presetClass="entr" presetSubtype="0" fill="hold" grpId="0" nodeType="withEffect">
+                                  <p:stCondLst>
+                                    <p:cond delay="0"/>
+                                  </p:stCondLst>
+                                  <p:childTnLst>
+                                    <p:set>
+                                      <p:cBhvr>
+                                        <p:cTn id="23" dur="1" fill="hold">
+                                          <p:stCondLst>
+                                            <p:cond delay="0"/>
+                                          </p:stCondLst>
+                                        </p:cTn>
+                                        <p:tgtEl>
+                                          <p:spTgt spid="32"/>
+                                        </p:tgtEl>
+                                        <p:attrNameLst>
+                                          <p:attrName>style.visibility</p:attrName>
+                                        </p:attrNameLst>
+                                      </p:cBhvr>
+                                      <p:to>
+                                        <p:strVal val="visible"/>
+                                      </p:to>
+                                    </p:set>
+                                    <p:animEffect transition="in" filter="fade">
+                                      <p:cBhvr>
+                                        <p:cTn id="24" dur="420"/>
+                                        <p:tgtEl>
+                                          <p:spTgt spid="32"/>
+                                        </p:tgtEl>
+                                      </p:cBhvr>
+                                    </p:animEffect>
+                                  </p:childTnLst>
+                                </p:cTn>
+                              </p:par>
+                              <p:par>
+                                <p:cTn id="25" presetID="10" presetClass="entr" presetSubtype="0" fill="hold" grpId="0" nodeType="withEffect">
+                                  <p:stCondLst>
+                                    <p:cond delay="0"/>
+                                  </p:stCondLst>
+                                  <p:childTnLst>
+                                    <p:set>
+                                      <p:cBhvr>
+                                        <p:cTn id="26" dur="1" fill="hold">
+                                          <p:stCondLst>
+                                            <p:cond delay="0"/>
+                                          </p:stCondLst>
+                                        </p:cTn>
+                                        <p:tgtEl>
+                                          <p:spTgt spid="33"/>
+                                        </p:tgtEl>
+                                        <p:attrNameLst>
+                                          <p:attrName>style.visibility</p:attrName>
+                                        </p:attrNameLst>
+                                      </p:cBhvr>
+                                      <p:to>
+                                        <p:strVal val="visible"/>
+                                      </p:to>
+                                    </p:set>
+                                    <p:animEffect transition="in" filter="fade">
+                                      <p:cBhvr>
+                                        <p:cTn id="27" dur="420"/>
+                                        <p:tgtEl>
+                                          <p:spTgt spid="33"/>
+                                        </p:tgtEl>
+                                      </p:cBhvr>
+                                    </p:animEffect>
+                                  </p:childTnLst>
+                                </p:cTn>
+                              </p:par>
+                              <p:par>
+                                <p:cTn id="28" presetID="10" presetClass="entr" presetSubtype="0" fill="hold" grpId="0" nodeType="withEffect">
+                                  <p:stCondLst>
+                                    <p:cond delay="0"/>
+                                  </p:stCondLst>
+                                  <p:childTnLst>
+                                    <p:set>
+                                      <p:cBhvr>
+                                        <p:cTn id="29" dur="1" fill="hold">
+                                          <p:stCondLst>
+                                            <p:cond delay="0"/>
+                                          </p:stCondLst>
+                                        </p:cTn>
+                                        <p:tgtEl>
+                                          <p:spTgt spid="34"/>
+                                        </p:tgtEl>
+                                        <p:attrNameLst>
+                                          <p:attrName>style.visibility</p:attrName>
+                                        </p:attrNameLst>
+                                      </p:cBhvr>
+                                      <p:to>
+                                        <p:strVal val="visible"/>
+                                      </p:to>
+                                    </p:set>
+                                    <p:animEffect transition="in" filter="fade">
+                                      <p:cBhvr>
+                                        <p:cTn id="30" dur="420"/>
+                                        <p:tgtEl>
+                                          <p:spTgt spid="34"/>
+                                        </p:tgtEl>
+                                      </p:cBhvr>
+                                    </p:animEffect>
+                                  </p:childTnLst>
+                                </p:cTn>
+                              </p:par>
+                            </p:childTnLst>
+                          </p:cTn>
+                        </p:par>
+                      </p:childTnLst>
+                    </p:cTn>
+                  </p:par>
+                  <p:par>
+                    <p:cTn id="31" fill="hold">
+                      <p:stCondLst>
+                        <p:cond delay="350"/>
+                      </p:stCondLst>
+                      <p:childTnLst>
+                        <p:par>
+                          <p:cTn id="32" fill="hold">
+                            <p:stCondLst>
+                              <p:cond delay="0"/>
+                            </p:stCondLst>
+                            <p:childTnLst>
+                              <p:par>
+                                <p:cTn id="33" presetID="10" presetClass="entr" presetSubtype="0" fill="hold" grpId="0" nodeType="afterEffect">
+                                  <p:stCondLst>
+                                    <p:cond delay="0"/>
+                                  </p:stCondLst>
+                                  <p:childTnLst>
+                                    <p:set>
+                                      <p:cBhvr>
+                                        <p:cTn id="34" dur="1" fill="hold">
+                                          <p:stCondLst>
+                                            <p:cond delay="0"/>
+                                          </p:stCondLst>
+                                        </p:cTn>
+                                        <p:tgtEl>
+                                          <p:spTgt spid="35"/>
+                                        </p:tgtEl>
+                                        <p:attrNameLst>
+                                          <p:attrName>style.visibility</p:attrName>
+                                        </p:attrNameLst>
+                                      </p:cBhvr>
+                                      <p:to>
+                                        <p:strVal val="visible"/>
+                                      </p:to>
+                                    </p:set>
+                                    <p:animEffect transition="in" filter="fade">
+                                      <p:cBhvr>
+                                        <p:cTn id="35" dur="420"/>
+                                        <p:tgtEl>
+                                          <p:spTgt spid="35"/>
+                                        </p:tgtEl>
+                                      </p:cBhvr>
+                                    </p:animEffect>
+                                  </p:childTnLst>
+                                </p:cTn>
+                              </p:par>
+                              <p:par>
+                                <p:cTn id="36" presetID="10" presetClass="entr" presetSubtype="0" fill="hold" grpId="0" nodeType="withEffect">
+                                  <p:stCondLst>
+                                    <p:cond delay="0"/>
+                                  </p:stCondLst>
+                                  <p:childTnLst>
+                                    <p:set>
+                                      <p:cBhvr>
+                                        <p:cTn id="37" dur="1" fill="hold">
+                                          <p:stCondLst>
+                                            <p:cond delay="0"/>
+                                          </p:stCondLst>
+                                        </p:cTn>
+                                        <p:tgtEl>
+                                          <p:spTgt spid="36"/>
+                                        </p:tgtEl>
+                                        <p:attrNameLst>
+                                          <p:attrName>style.visibility</p:attrName>
+                                        </p:attrNameLst>
+                                      </p:cBhvr>
+                                      <p:to>
+                                        <p:strVal val="visible"/>
+                                      </p:to>
+                                    </p:set>
+                                    <p:animEffect transition="in" filter="fade">
+                                      <p:cBhvr>
+                                        <p:cTn id="38" dur="420"/>
+                                        <p:tgtEl>
+                                          <p:spTgt spid="36"/>
+                                        </p:tgtEl>
+                                      </p:cBhvr>
+                                    </p:animEffect>
+                                  </p:childTnLst>
+                                </p:cTn>
+                              </p:par>
+                              <p:par>
+                                <p:cTn id="39" presetID="10" presetClass="entr" presetSubtype="0" fill="hold" grpId="0" nodeType="withEffect">
+                                  <p:stCondLst>
+                                    <p:cond delay="0"/>
+                                  </p:stCondLst>
+                                  <p:childTnLst>
+                                    <p:set>
+                                      <p:cBhvr>
+                                        <p:cTn id="40" dur="1" fill="hold">
+                                          <p:stCondLst>
+                                            <p:cond delay="0"/>
+                                          </p:stCondLst>
+                                        </p:cTn>
+                                        <p:tgtEl>
+                                          <p:spTgt spid="37"/>
+                                        </p:tgtEl>
+                                        <p:attrNameLst>
+                                          <p:attrName>style.visibility</p:attrName>
+                                        </p:attrNameLst>
+                                      </p:cBhvr>
+                                      <p:to>
+                                        <p:strVal val="visible"/>
+                                      </p:to>
+                                    </p:set>
+                                    <p:animEffect transition="in" filter="fade">
+                                      <p:cBhvr>
+                                        <p:cTn id="41" dur="420"/>
+                                        <p:tgtEl>
+                                          <p:spTgt spid="37"/>
+                                        </p:tgtEl>
+                                      </p:cBhvr>
+                                    </p:animEffect>
+                                  </p:childTnLst>
+                                </p:cTn>
+                              </p:par>
+                              <p:par>
+                                <p:cTn id="42" presetID="10" presetClass="entr" presetSubtype="0" fill="hold" grpId="0" nodeType="withEffect">
+                                  <p:stCondLst>
+                                    <p:cond delay="0"/>
+                                  </p:stCondLst>
+                                  <p:childTnLst>
+                                    <p:set>
+                                      <p:cBhvr>
+                                        <p:cTn id="43" dur="1" fill="hold">
+                                          <p:stCondLst>
+                                            <p:cond delay="0"/>
+                                          </p:stCondLst>
+                                        </p:cTn>
+                                        <p:tgtEl>
+                                          <p:spTgt spid="38"/>
+                                        </p:tgtEl>
+                                        <p:attrNameLst>
+                                          <p:attrName>style.visibility</p:attrName>
+                                        </p:attrNameLst>
+                                      </p:cBhvr>
+                                      <p:to>
+                                        <p:strVal val="visible"/>
+                                      </p:to>
+                                    </p:set>
+                                    <p:animEffect transition="in" filter="fade">
+                                      <p:cBhvr>
+                                        <p:cTn id="44" dur="420"/>
+                                        <p:tgtEl>
+                                          <p:spTgt spid="38"/>
+                                        </p:tgtEl>
+                                      </p:cBhvr>
+                                    </p:animEffect>
+                                  </p:childTnLst>
+                                </p:cTn>
+                              </p:par>
+                            </p:childTnLst>
+                          </p:cTn>
+                        </p:par>
+                      </p:childTnLst>
+                    </p:cTn>
+                  </p:par>
+                </p:childTnLst>
+              </p:cTn>
+              <p:prevCondLst>
+                <p:cond evt="onPrev" delay="0">
+                  <p:tgtEl>
+                    <p:sldTgt/>
+                  </p:tgtEl>
+                </p:cond>
+              </p:prevCondLst>
+              <p:nextCondLst>
+                <p:cond evt="onNext" delay="0">
+                  <p:tgtEl>
+                    <p:sldTgt/>
+                  </p:tgtEl>
+                </p:cond>
+              </p:nextCondLst>
+            </p:seq>
+          </p:childTnLst>
+        </p:cTn>
+      </p:par>
+    </p:tnLst>
+    <p:bldLst>
+      <p:bldP spid="27" grpId="0" animBg="1"/>
+      <p:bldP spid="28" grpId="0" animBg="1"/>
+      <p:bldP spid="29" grpId="0" animBg="1"/>
+      <p:bldP spid="30" grpId="0" animBg="1"/>
+      <p:bldP spid="31" grpId="0" animBg="1"/>
+      <p:bldP spid="32" grpId="0" animBg="1"/>
+      <p:bldP spid="33" grpId="0" animBg="1"/>
+      <p:bldP spid="34" grpId="0" animBg="1"/>
+      <p:bldP spid="35" grpId="0" animBg="1"/>
+      <p:bldP spid="36" grpId="0" animBg="1"/>
+      <p:bldP spid="37" grpId="0" animBg="1"/>
+      <p:bldP spid="38" grpId="0" animBg="1"/>
+    </p:bldLst>
+  </p:timing>
 </p:sld>
 </file>
 
@@ -8034,7 +8896,7 @@
       </p:sp>
       <p:sp>
         <p:nvSpPr>
-          <p:cNvPr id="27" name="Rectangle 26"/>
+          <p:cNvPr id="67" name="Rectangle 66"/>
           <p:cNvSpPr/>
           <p:nvPr/>
         </p:nvSpPr>
@@ -8078,7 +8940,7 @@
       </p:sp>
       <p:pic>
         <p:nvPicPr>
-          <p:cNvPr id="28" name="Picture 27" descr="logo_wordmark.png"/>
+          <p:cNvPr id="68" name="Picture 67" descr="logo_wordmark.png"/>
           <p:cNvPicPr>
             <a:picLocks noChangeAspect="1"/>
           </p:cNvPicPr>
@@ -8105,6 +8967,797 @@
   <p:clrMapOvr>
     <a:masterClrMapping/>
   </p:clrMapOvr>
+  <p:transition spd="med">
+    <p:fade/>
+  </p:transition>
+  <p:timing>
+    <p:tnLst>
+      <p:par>
+        <p:cTn id="1" dur="indefinite" restart="never" nodeType="tmRoot">
+          <p:childTnLst>
+            <p:seq concurrent="1" nextAc="seek">
+              <p:cTn id="2" dur="indefinite" nodeType="mainSeq">
+                <p:childTnLst>
+                  <p:par>
+                    <p:cTn id="3" fill="hold">
+                      <p:stCondLst>
+                        <p:cond delay="200"/>
+                      </p:stCondLst>
+                      <p:childTnLst>
+                        <p:par>
+                          <p:cTn id="4" fill="hold">
+                            <p:stCondLst>
+                              <p:cond delay="0"/>
+                            </p:stCondLst>
+                            <p:childTnLst>
+                              <p:par>
+                                <p:cTn id="5" presetID="10" presetClass="entr" presetSubtype="0" fill="hold" grpId="0" nodeType="afterEffect">
+                                  <p:stCondLst>
+                                    <p:cond delay="0"/>
+                                  </p:stCondLst>
+                                  <p:childTnLst>
+                                    <p:set>
+                                      <p:cBhvr>
+                                        <p:cTn id="6" dur="1" fill="hold">
+                                          <p:stCondLst>
+                                            <p:cond delay="0"/>
+                                          </p:stCondLst>
+                                        </p:cTn>
+                                        <p:tgtEl>
+                                          <p:spTgt spid="7"/>
+                                        </p:tgtEl>
+                                        <p:attrNameLst>
+                                          <p:attrName>style.visibility</p:attrName>
+                                        </p:attrNameLst>
+                                      </p:cBhvr>
+                                      <p:to>
+                                        <p:strVal val="visible"/>
+                                      </p:to>
+                                    </p:set>
+                                    <p:animEffect transition="in" filter="fade">
+                                      <p:cBhvr>
+                                        <p:cTn id="7" dur="420"/>
+                                        <p:tgtEl>
+                                          <p:spTgt spid="7"/>
+                                        </p:tgtEl>
+                                      </p:cBhvr>
+                                    </p:animEffect>
+                                  </p:childTnLst>
+                                </p:cTn>
+                              </p:par>
+                              <p:par>
+                                <p:cTn id="8" presetID="10" presetClass="entr" presetSubtype="0" fill="hold" grpId="0" nodeType="withEffect">
+                                  <p:stCondLst>
+                                    <p:cond delay="0"/>
+                                  </p:stCondLst>
+                                  <p:childTnLst>
+                                    <p:set>
+                                      <p:cBhvr>
+                                        <p:cTn id="9" dur="1" fill="hold">
+                                          <p:stCondLst>
+                                            <p:cond delay="0"/>
+                                          </p:stCondLst>
+                                        </p:cTn>
+                                        <p:tgtEl>
+                                          <p:spTgt spid="8"/>
+                                        </p:tgtEl>
+                                        <p:attrNameLst>
+                                          <p:attrName>style.visibility</p:attrName>
+                                        </p:attrNameLst>
+                                      </p:cBhvr>
+                                      <p:to>
+                                        <p:strVal val="visible"/>
+                                      </p:to>
+                                    </p:set>
+                                    <p:animEffect transition="in" filter="fade">
+                                      <p:cBhvr>
+                                        <p:cTn id="10" dur="420"/>
+                                        <p:tgtEl>
+                                          <p:spTgt spid="8"/>
+                                        </p:tgtEl>
+                                      </p:cBhvr>
+                                    </p:animEffect>
+                                  </p:childTnLst>
+                                </p:cTn>
+                              </p:par>
+                              <p:par>
+                                <p:cTn id="11" presetID="10" presetClass="entr" presetSubtype="0" fill="hold" grpId="0" nodeType="withEffect">
+                                  <p:stCondLst>
+                                    <p:cond delay="0"/>
+                                  </p:stCondLst>
+                                  <p:childTnLst>
+                                    <p:set>
+                                      <p:cBhvr>
+                                        <p:cTn id="12" dur="1" fill="hold">
+                                          <p:stCondLst>
+                                            <p:cond delay="0"/>
+                                          </p:stCondLst>
+                                        </p:cTn>
+                                        <p:tgtEl>
+                                          <p:spTgt spid="9"/>
+                                        </p:tgtEl>
+                                        <p:attrNameLst>
+                                          <p:attrName>style.visibility</p:attrName>
+                                        </p:attrNameLst>
+                                      </p:cBhvr>
+                                      <p:to>
+                                        <p:strVal val="visible"/>
+                                      </p:to>
+                                    </p:set>
+                                    <p:animEffect transition="in" filter="fade">
+                                      <p:cBhvr>
+                                        <p:cTn id="13" dur="420"/>
+                                        <p:tgtEl>
+                                          <p:spTgt spid="9"/>
+                                        </p:tgtEl>
+                                      </p:cBhvr>
+                                    </p:animEffect>
+                                  </p:childTnLst>
+                                </p:cTn>
+                              </p:par>
+                              <p:par>
+                                <p:cTn id="14" presetID="10" presetClass="entr" presetSubtype="0" fill="hold" grpId="0" nodeType="withEffect">
+                                  <p:stCondLst>
+                                    <p:cond delay="0"/>
+                                  </p:stCondLst>
+                                  <p:childTnLst>
+                                    <p:set>
+                                      <p:cBhvr>
+                                        <p:cTn id="15" dur="1" fill="hold">
+                                          <p:stCondLst>
+                                            <p:cond delay="0"/>
+                                          </p:stCondLst>
+                                        </p:cTn>
+                                        <p:tgtEl>
+                                          <p:spTgt spid="10"/>
+                                        </p:tgtEl>
+                                        <p:attrNameLst>
+                                          <p:attrName>style.visibility</p:attrName>
+                                        </p:attrNameLst>
+                                      </p:cBhvr>
+                                      <p:to>
+                                        <p:strVal val="visible"/>
+                                      </p:to>
+                                    </p:set>
+                                    <p:animEffect transition="in" filter="fade">
+                                      <p:cBhvr>
+                                        <p:cTn id="16" dur="420"/>
+                                        <p:tgtEl>
+                                          <p:spTgt spid="10"/>
+                                        </p:tgtEl>
+                                      </p:cBhvr>
+                                    </p:animEffect>
+                                  </p:childTnLst>
+                                </p:cTn>
+                              </p:par>
+                              <p:par>
+                                <p:cTn id="17" presetID="10" presetClass="entr" presetSubtype="0" fill="hold" grpId="0" nodeType="withEffect">
+                                  <p:stCondLst>
+                                    <p:cond delay="0"/>
+                                  </p:stCondLst>
+                                  <p:childTnLst>
+                                    <p:set>
+                                      <p:cBhvr>
+                                        <p:cTn id="18" dur="1" fill="hold">
+                                          <p:stCondLst>
+                                            <p:cond delay="0"/>
+                                          </p:stCondLst>
+                                        </p:cTn>
+                                        <p:tgtEl>
+                                          <p:spTgt spid="11"/>
+                                        </p:tgtEl>
+                                        <p:attrNameLst>
+                                          <p:attrName>style.visibility</p:attrName>
+                                        </p:attrNameLst>
+                                      </p:cBhvr>
+                                      <p:to>
+                                        <p:strVal val="visible"/>
+                                      </p:to>
+                                    </p:set>
+                                    <p:animEffect transition="in" filter="fade">
+                                      <p:cBhvr>
+                                        <p:cTn id="19" dur="420"/>
+                                        <p:tgtEl>
+                                          <p:spTgt spid="11"/>
+                                        </p:tgtEl>
+                                      </p:cBhvr>
+                                    </p:animEffect>
+                                  </p:childTnLst>
+                                </p:cTn>
+                              </p:par>
+                              <p:par>
+                                <p:cTn id="20" presetID="10" presetClass="entr" presetSubtype="0" fill="hold" grpId="0" nodeType="withEffect">
+                                  <p:stCondLst>
+                                    <p:cond delay="0"/>
+                                  </p:stCondLst>
+                                  <p:childTnLst>
+                                    <p:set>
+                                      <p:cBhvr>
+                                        <p:cTn id="21" dur="1" fill="hold">
+                                          <p:stCondLst>
+                                            <p:cond delay="0"/>
+                                          </p:stCondLst>
+                                        </p:cTn>
+                                        <p:tgtEl>
+                                          <p:spTgt spid="12"/>
+                                        </p:tgtEl>
+                                        <p:attrNameLst>
+                                          <p:attrName>style.visibility</p:attrName>
+                                        </p:attrNameLst>
+                                      </p:cBhvr>
+                                      <p:to>
+                                        <p:strVal val="visible"/>
+                                      </p:to>
+                                    </p:set>
+                                    <p:animEffect transition="in" filter="fade">
+                                      <p:cBhvr>
+                                        <p:cTn id="22" dur="420"/>
+                                        <p:tgtEl>
+                                          <p:spTgt spid="12"/>
+                                        </p:tgtEl>
+                                      </p:cBhvr>
+                                    </p:animEffect>
+                                  </p:childTnLst>
+                                </p:cTn>
+                              </p:par>
+                            </p:childTnLst>
+                          </p:cTn>
+                        </p:par>
+                      </p:childTnLst>
+                    </p:cTn>
+                  </p:par>
+                  <p:par>
+                    <p:cTn id="23" fill="hold">
+                      <p:stCondLst>
+                        <p:cond delay="350"/>
+                      </p:stCondLst>
+                      <p:childTnLst>
+                        <p:par>
+                          <p:cTn id="24" fill="hold">
+                            <p:stCondLst>
+                              <p:cond delay="0"/>
+                            </p:stCondLst>
+                            <p:childTnLst>
+                              <p:par>
+                                <p:cTn id="25" presetID="10" presetClass="entr" presetSubtype="0" fill="hold" grpId="0" nodeType="afterEffect">
+                                  <p:stCondLst>
+                                    <p:cond delay="0"/>
+                                  </p:stCondLst>
+                                  <p:childTnLst>
+                                    <p:set>
+                                      <p:cBhvr>
+                                        <p:cTn id="26" dur="1" fill="hold">
+                                          <p:stCondLst>
+                                            <p:cond delay="0"/>
+                                          </p:stCondLst>
+                                        </p:cTn>
+                                        <p:tgtEl>
+                                          <p:spTgt spid="13"/>
+                                        </p:tgtEl>
+                                        <p:attrNameLst>
+                                          <p:attrName>style.visibility</p:attrName>
+                                        </p:attrNameLst>
+                                      </p:cBhvr>
+                                      <p:to>
+                                        <p:strVal val="visible"/>
+                                      </p:to>
+                                    </p:set>
+                                    <p:animEffect transition="in" filter="fade">
+                                      <p:cBhvr>
+                                        <p:cTn id="27" dur="420"/>
+                                        <p:tgtEl>
+                                          <p:spTgt spid="13"/>
+                                        </p:tgtEl>
+                                      </p:cBhvr>
+                                    </p:animEffect>
+                                  </p:childTnLst>
+                                </p:cTn>
+                              </p:par>
+                              <p:par>
+                                <p:cTn id="28" presetID="10" presetClass="entr" presetSubtype="0" fill="hold" grpId="0" nodeType="withEffect">
+                                  <p:stCondLst>
+                                    <p:cond delay="0"/>
+                                  </p:stCondLst>
+                                  <p:childTnLst>
+                                    <p:set>
+                                      <p:cBhvr>
+                                        <p:cTn id="29" dur="1" fill="hold">
+                                          <p:stCondLst>
+                                            <p:cond delay="0"/>
+                                          </p:stCondLst>
+                                        </p:cTn>
+                                        <p:tgtEl>
+                                          <p:spTgt spid="14"/>
+                                        </p:tgtEl>
+                                        <p:attrNameLst>
+                                          <p:attrName>style.visibility</p:attrName>
+                                        </p:attrNameLst>
+                                      </p:cBhvr>
+                                      <p:to>
+                                        <p:strVal val="visible"/>
+                                      </p:to>
+                                    </p:set>
+                                    <p:animEffect transition="in" filter="fade">
+                                      <p:cBhvr>
+                                        <p:cTn id="30" dur="420"/>
+                                        <p:tgtEl>
+                                          <p:spTgt spid="14"/>
+                                        </p:tgtEl>
+                                      </p:cBhvr>
+                                    </p:animEffect>
+                                  </p:childTnLst>
+                                </p:cTn>
+                              </p:par>
+                              <p:par>
+                                <p:cTn id="31" presetID="10" presetClass="entr" presetSubtype="0" fill="hold" grpId="0" nodeType="withEffect">
+                                  <p:stCondLst>
+                                    <p:cond delay="0"/>
+                                  </p:stCondLst>
+                                  <p:childTnLst>
+                                    <p:set>
+                                      <p:cBhvr>
+                                        <p:cTn id="32" dur="1" fill="hold">
+                                          <p:stCondLst>
+                                            <p:cond delay="0"/>
+                                          </p:stCondLst>
+                                        </p:cTn>
+                                        <p:tgtEl>
+                                          <p:spTgt spid="15"/>
+                                        </p:tgtEl>
+                                        <p:attrNameLst>
+                                          <p:attrName>style.visibility</p:attrName>
+                                        </p:attrNameLst>
+                                      </p:cBhvr>
+                                      <p:to>
+                                        <p:strVal val="visible"/>
+                                      </p:to>
+                                    </p:set>
+                                    <p:animEffect transition="in" filter="fade">
+                                      <p:cBhvr>
+                                        <p:cTn id="33" dur="420"/>
+                                        <p:tgtEl>
+                                          <p:spTgt spid="15"/>
+                                        </p:tgtEl>
+                                      </p:cBhvr>
+                                    </p:animEffect>
+                                  </p:childTnLst>
+                                </p:cTn>
+                              </p:par>
+                              <p:par>
+                                <p:cTn id="34" presetID="10" presetClass="entr" presetSubtype="0" fill="hold" grpId="0" nodeType="withEffect">
+                                  <p:stCondLst>
+                                    <p:cond delay="0"/>
+                                  </p:stCondLst>
+                                  <p:childTnLst>
+                                    <p:set>
+                                      <p:cBhvr>
+                                        <p:cTn id="35" dur="1" fill="hold">
+                                          <p:stCondLst>
+                                            <p:cond delay="0"/>
+                                          </p:stCondLst>
+                                        </p:cTn>
+                                        <p:tgtEl>
+                                          <p:spTgt spid="16"/>
+                                        </p:tgtEl>
+                                        <p:attrNameLst>
+                                          <p:attrName>style.visibility</p:attrName>
+                                        </p:attrNameLst>
+                                      </p:cBhvr>
+                                      <p:to>
+                                        <p:strVal val="visible"/>
+                                      </p:to>
+                                    </p:set>
+                                    <p:animEffect transition="in" filter="fade">
+                                      <p:cBhvr>
+                                        <p:cTn id="36" dur="420"/>
+                                        <p:tgtEl>
+                                          <p:spTgt spid="16"/>
+                                        </p:tgtEl>
+                                      </p:cBhvr>
+                                    </p:animEffect>
+                                  </p:childTnLst>
+                                </p:cTn>
+                              </p:par>
+                              <p:par>
+                                <p:cTn id="37" presetID="10" presetClass="entr" presetSubtype="0" fill="hold" grpId="0" nodeType="withEffect">
+                                  <p:stCondLst>
+                                    <p:cond delay="0"/>
+                                  </p:stCondLst>
+                                  <p:childTnLst>
+                                    <p:set>
+                                      <p:cBhvr>
+                                        <p:cTn id="38" dur="1" fill="hold">
+                                          <p:stCondLst>
+                                            <p:cond delay="0"/>
+                                          </p:stCondLst>
+                                        </p:cTn>
+                                        <p:tgtEl>
+                                          <p:spTgt spid="17"/>
+                                        </p:tgtEl>
+                                        <p:attrNameLst>
+                                          <p:attrName>style.visibility</p:attrName>
+                                        </p:attrNameLst>
+                                      </p:cBhvr>
+                                      <p:to>
+                                        <p:strVal val="visible"/>
+                                      </p:to>
+                                    </p:set>
+                                    <p:animEffect transition="in" filter="fade">
+                                      <p:cBhvr>
+                                        <p:cTn id="39" dur="420"/>
+                                        <p:tgtEl>
+                                          <p:spTgt spid="17"/>
+                                        </p:tgtEl>
+                                      </p:cBhvr>
+                                    </p:animEffect>
+                                  </p:childTnLst>
+                                </p:cTn>
+                              </p:par>
+                              <p:par>
+                                <p:cTn id="40" presetID="10" presetClass="entr" presetSubtype="0" fill="hold" grpId="0" nodeType="withEffect">
+                                  <p:stCondLst>
+                                    <p:cond delay="0"/>
+                                  </p:stCondLst>
+                                  <p:childTnLst>
+                                    <p:set>
+                                      <p:cBhvr>
+                                        <p:cTn id="41" dur="1" fill="hold">
+                                          <p:stCondLst>
+                                            <p:cond delay="0"/>
+                                          </p:stCondLst>
+                                        </p:cTn>
+                                        <p:tgtEl>
+                                          <p:spTgt spid="18"/>
+                                        </p:tgtEl>
+                                        <p:attrNameLst>
+                                          <p:attrName>style.visibility</p:attrName>
+                                        </p:attrNameLst>
+                                      </p:cBhvr>
+                                      <p:to>
+                                        <p:strVal val="visible"/>
+                                      </p:to>
+                                    </p:set>
+                                    <p:animEffect transition="in" filter="fade">
+                                      <p:cBhvr>
+                                        <p:cTn id="42" dur="420"/>
+                                        <p:tgtEl>
+                                          <p:spTgt spid="18"/>
+                                        </p:tgtEl>
+                                      </p:cBhvr>
+                                    </p:animEffect>
+                                  </p:childTnLst>
+                                </p:cTn>
+                              </p:par>
+                              <p:par>
+                                <p:cTn id="43" presetID="10" presetClass="entr" presetSubtype="0" fill="hold" grpId="0" nodeType="withEffect">
+                                  <p:stCondLst>
+                                    <p:cond delay="0"/>
+                                  </p:stCondLst>
+                                  <p:childTnLst>
+                                    <p:set>
+                                      <p:cBhvr>
+                                        <p:cTn id="44" dur="1" fill="hold">
+                                          <p:stCondLst>
+                                            <p:cond delay="0"/>
+                                          </p:stCondLst>
+                                        </p:cTn>
+                                        <p:tgtEl>
+                                          <p:spTgt spid="19"/>
+                                        </p:tgtEl>
+                                        <p:attrNameLst>
+                                          <p:attrName>style.visibility</p:attrName>
+                                        </p:attrNameLst>
+                                      </p:cBhvr>
+                                      <p:to>
+                                        <p:strVal val="visible"/>
+                                      </p:to>
+                                    </p:set>
+                                    <p:animEffect transition="in" filter="fade">
+                                      <p:cBhvr>
+                                        <p:cTn id="45" dur="420"/>
+                                        <p:tgtEl>
+                                          <p:spTgt spid="19"/>
+                                        </p:tgtEl>
+                                      </p:cBhvr>
+                                    </p:animEffect>
+                                  </p:childTnLst>
+                                </p:cTn>
+                              </p:par>
+                              <p:par>
+                                <p:cTn id="46" presetID="10" presetClass="entr" presetSubtype="0" fill="hold" grpId="0" nodeType="withEffect">
+                                  <p:stCondLst>
+                                    <p:cond delay="0"/>
+                                  </p:stCondLst>
+                                  <p:childTnLst>
+                                    <p:set>
+                                      <p:cBhvr>
+                                        <p:cTn id="47" dur="1" fill="hold">
+                                          <p:stCondLst>
+                                            <p:cond delay="0"/>
+                                          </p:stCondLst>
+                                        </p:cTn>
+                                        <p:tgtEl>
+                                          <p:spTgt spid="20"/>
+                                        </p:tgtEl>
+                                        <p:attrNameLst>
+                                          <p:attrName>style.visibility</p:attrName>
+                                        </p:attrNameLst>
+                                      </p:cBhvr>
+                                      <p:to>
+                                        <p:strVal val="visible"/>
+                                      </p:to>
+                                    </p:set>
+                                    <p:animEffect transition="in" filter="fade">
+                                      <p:cBhvr>
+                                        <p:cTn id="48" dur="420"/>
+                                        <p:tgtEl>
+                                          <p:spTgt spid="20"/>
+                                        </p:tgtEl>
+                                      </p:cBhvr>
+                                    </p:animEffect>
+                                  </p:childTnLst>
+                                </p:cTn>
+                              </p:par>
+                              <p:par>
+                                <p:cTn id="49" presetID="10" presetClass="entr" presetSubtype="0" fill="hold" grpId="0" nodeType="withEffect">
+                                  <p:stCondLst>
+                                    <p:cond delay="0"/>
+                                  </p:stCondLst>
+                                  <p:childTnLst>
+                                    <p:set>
+                                      <p:cBhvr>
+                                        <p:cTn id="50" dur="1" fill="hold">
+                                          <p:stCondLst>
+                                            <p:cond delay="0"/>
+                                          </p:stCondLst>
+                                        </p:cTn>
+                                        <p:tgtEl>
+                                          <p:spTgt spid="21"/>
+                                        </p:tgtEl>
+                                        <p:attrNameLst>
+                                          <p:attrName>style.visibility</p:attrName>
+                                        </p:attrNameLst>
+                                      </p:cBhvr>
+                                      <p:to>
+                                        <p:strVal val="visible"/>
+                                      </p:to>
+                                    </p:set>
+                                    <p:animEffect transition="in" filter="fade">
+                                      <p:cBhvr>
+                                        <p:cTn id="51" dur="420"/>
+                                        <p:tgtEl>
+                                          <p:spTgt spid="21"/>
+                                        </p:tgtEl>
+                                      </p:cBhvr>
+                                    </p:animEffect>
+                                  </p:childTnLst>
+                                </p:cTn>
+                              </p:par>
+                              <p:par>
+                                <p:cTn id="52" presetID="10" presetClass="entr" presetSubtype="0" fill="hold" grpId="0" nodeType="withEffect">
+                                  <p:stCondLst>
+                                    <p:cond delay="0"/>
+                                  </p:stCondLst>
+                                  <p:childTnLst>
+                                    <p:set>
+                                      <p:cBhvr>
+                                        <p:cTn id="53" dur="1" fill="hold">
+                                          <p:stCondLst>
+                                            <p:cond delay="0"/>
+                                          </p:stCondLst>
+                                        </p:cTn>
+                                        <p:tgtEl>
+                                          <p:spTgt spid="22"/>
+                                        </p:tgtEl>
+                                        <p:attrNameLst>
+                                          <p:attrName>style.visibility</p:attrName>
+                                        </p:attrNameLst>
+                                      </p:cBhvr>
+                                      <p:to>
+                                        <p:strVal val="visible"/>
+                                      </p:to>
+                                    </p:set>
+                                    <p:animEffect transition="in" filter="fade">
+                                      <p:cBhvr>
+                                        <p:cTn id="54" dur="420"/>
+                                        <p:tgtEl>
+                                          <p:spTgt spid="22"/>
+                                        </p:tgtEl>
+                                      </p:cBhvr>
+                                    </p:animEffect>
+                                  </p:childTnLst>
+                                </p:cTn>
+                              </p:par>
+                              <p:par>
+                                <p:cTn id="55" presetID="10" presetClass="entr" presetSubtype="0" fill="hold" grpId="0" nodeType="withEffect">
+                                  <p:stCondLst>
+                                    <p:cond delay="0"/>
+                                  </p:stCondLst>
+                                  <p:childTnLst>
+                                    <p:set>
+                                      <p:cBhvr>
+                                        <p:cTn id="56" dur="1" fill="hold">
+                                          <p:stCondLst>
+                                            <p:cond delay="0"/>
+                                          </p:stCondLst>
+                                        </p:cTn>
+                                        <p:tgtEl>
+                                          <p:spTgt spid="23"/>
+                                        </p:tgtEl>
+                                        <p:attrNameLst>
+                                          <p:attrName>style.visibility</p:attrName>
+                                        </p:attrNameLst>
+                                      </p:cBhvr>
+                                      <p:to>
+                                        <p:strVal val="visible"/>
+                                      </p:to>
+                                    </p:set>
+                                    <p:animEffect transition="in" filter="fade">
+                                      <p:cBhvr>
+                                        <p:cTn id="57" dur="420"/>
+                                        <p:tgtEl>
+                                          <p:spTgt spid="23"/>
+                                        </p:tgtEl>
+                                      </p:cBhvr>
+                                    </p:animEffect>
+                                  </p:childTnLst>
+                                </p:cTn>
+                              </p:par>
+                              <p:par>
+                                <p:cTn id="58" presetID="10" presetClass="entr" presetSubtype="0" fill="hold" grpId="0" nodeType="withEffect">
+                                  <p:stCondLst>
+                                    <p:cond delay="0"/>
+                                  </p:stCondLst>
+                                  <p:childTnLst>
+                                    <p:set>
+                                      <p:cBhvr>
+                                        <p:cTn id="59" dur="1" fill="hold">
+                                          <p:stCondLst>
+                                            <p:cond delay="0"/>
+                                          </p:stCondLst>
+                                        </p:cTn>
+                                        <p:tgtEl>
+                                          <p:spTgt spid="24"/>
+                                        </p:tgtEl>
+                                        <p:attrNameLst>
+                                          <p:attrName>style.visibility</p:attrName>
+                                        </p:attrNameLst>
+                                      </p:cBhvr>
+                                      <p:to>
+                                        <p:strVal val="visible"/>
+                                      </p:to>
+                                    </p:set>
+                                    <p:animEffect transition="in" filter="fade">
+                                      <p:cBhvr>
+                                        <p:cTn id="60" dur="420"/>
+                                        <p:tgtEl>
+                                          <p:spTgt spid="24"/>
+                                        </p:tgtEl>
+                                      </p:cBhvr>
+                                    </p:animEffect>
+                                  </p:childTnLst>
+                                </p:cTn>
+                              </p:par>
+                              <p:par>
+                                <p:cTn id="61" presetID="10" presetClass="entr" presetSubtype="0" fill="hold" grpId="0" nodeType="withEffect">
+                                  <p:stCondLst>
+                                    <p:cond delay="0"/>
+                                  </p:stCondLst>
+                                  <p:childTnLst>
+                                    <p:set>
+                                      <p:cBhvr>
+                                        <p:cTn id="62" dur="1" fill="hold">
+                                          <p:stCondLst>
+                                            <p:cond delay="0"/>
+                                          </p:stCondLst>
+                                        </p:cTn>
+                                        <p:tgtEl>
+                                          <p:spTgt spid="25"/>
+                                        </p:tgtEl>
+                                        <p:attrNameLst>
+                                          <p:attrName>style.visibility</p:attrName>
+                                        </p:attrNameLst>
+                                      </p:cBhvr>
+                                      <p:to>
+                                        <p:strVal val="visible"/>
+                                      </p:to>
+                                    </p:set>
+                                    <p:animEffect transition="in" filter="fade">
+                                      <p:cBhvr>
+                                        <p:cTn id="63" dur="420"/>
+                                        <p:tgtEl>
+                                          <p:spTgt spid="25"/>
+                                        </p:tgtEl>
+                                      </p:cBhvr>
+                                    </p:animEffect>
+                                  </p:childTnLst>
+                                </p:cTn>
+                              </p:par>
+                              <p:par>
+                                <p:cTn id="64" presetID="10" presetClass="entr" presetSubtype="0" fill="hold" grpId="0" nodeType="withEffect">
+                                  <p:stCondLst>
+                                    <p:cond delay="0"/>
+                                  </p:stCondLst>
+                                  <p:childTnLst>
+                                    <p:set>
+                                      <p:cBhvr>
+                                        <p:cTn id="65" dur="1" fill="hold">
+                                          <p:stCondLst>
+                                            <p:cond delay="0"/>
+                                          </p:stCondLst>
+                                        </p:cTn>
+                                        <p:tgtEl>
+                                          <p:spTgt spid="26"/>
+                                        </p:tgtEl>
+                                        <p:attrNameLst>
+                                          <p:attrName>style.visibility</p:attrName>
+                                        </p:attrNameLst>
+                                      </p:cBhvr>
+                                      <p:to>
+                                        <p:strVal val="visible"/>
+                                      </p:to>
+                                    </p:set>
+                                    <p:animEffect transition="in" filter="fade">
+                                      <p:cBhvr>
+                                        <p:cTn id="66" dur="420"/>
+                                        <p:tgtEl>
+                                          <p:spTgt spid="26"/>
+                                        </p:tgtEl>
+                                      </p:cBhvr>
+                                    </p:animEffect>
+                                  </p:childTnLst>
+                                </p:cTn>
+                              </p:par>
+                            </p:childTnLst>
+                          </p:cTn>
+                        </p:par>
+                      </p:childTnLst>
+                    </p:cTn>
+                  </p:par>
+                </p:childTnLst>
+              </p:cTn>
+              <p:prevCondLst>
+                <p:cond evt="onPrev" delay="0">
+                  <p:tgtEl>
+                    <p:sldTgt/>
+                  </p:tgtEl>
+                </p:cond>
+              </p:prevCondLst>
+              <p:nextCondLst>
+                <p:cond evt="onNext" delay="0">
+                  <p:tgtEl>
+                    <p:sldTgt/>
+                  </p:tgtEl>
+                </p:cond>
+              </p:nextCondLst>
+            </p:seq>
+          </p:childTnLst>
+        </p:cTn>
+      </p:par>
+    </p:tnLst>
+    <p:bldLst>
+      <p:bldP spid="7" grpId="0" animBg="1"/>
+      <p:bldP spid="8" grpId="0" animBg="1"/>
+      <p:bldP spid="9" grpId="0" animBg="1"/>
+      <p:bldP spid="10" grpId="0" animBg="1"/>
+      <p:bldP spid="11" grpId="0" animBg="1"/>
+      <p:bldP spid="12" grpId="0" animBg="1"/>
+      <p:bldP spid="13" grpId="0" animBg="1"/>
+      <p:bldP spid="14" grpId="0" animBg="1"/>
+      <p:bldP spid="15" grpId="0" animBg="1"/>
+      <p:bldP spid="16" grpId="0" animBg="1"/>
+      <p:bldP spid="17" grpId="0" animBg="1"/>
+      <p:bldP spid="18" grpId="0" animBg="1"/>
+      <p:bldP spid="19" grpId="0" animBg="1"/>
+      <p:bldP spid="20" grpId="0" animBg="1"/>
+      <p:bldP spid="21" grpId="0" animBg="1"/>
+      <p:bldP spid="22" grpId="0" animBg="1"/>
+      <p:bldP spid="23" grpId="0" animBg="1"/>
+      <p:bldP spid="24" grpId="0" animBg="1"/>
+      <p:bldP spid="25" grpId="0" animBg="1"/>
+      <p:bldP spid="26" grpId="0" animBg="1"/>
+    </p:bldLst>
+  </p:timing>
 </p:sld>
 </file>
 
@@ -10821,7 +12474,7 @@
       </p:sp>
       <p:sp>
         <p:nvSpPr>
-          <p:cNvPr id="39" name="Rectangle 38"/>
+          <p:cNvPr id="45" name="Rectangle 44"/>
           <p:cNvSpPr/>
           <p:nvPr/>
         </p:nvSpPr>
@@ -10865,7 +12518,7 @@
       </p:sp>
       <p:pic>
         <p:nvPicPr>
-          <p:cNvPr id="40" name="Picture 39" descr="logo_wordmark.png"/>
+          <p:cNvPr id="46" name="Picture 45" descr="logo_wordmark.png"/>
           <p:cNvPicPr>
             <a:picLocks noChangeAspect="1"/>
           </p:cNvPicPr>
@@ -10889,7 +12542,7 @@
       </p:pic>
       <p:sp>
         <p:nvSpPr>
-          <p:cNvPr id="41" name="Oval 40"/>
+          <p:cNvPr id="47" name="Oval 46"/>
           <p:cNvSpPr/>
           <p:nvPr/>
         </p:nvSpPr>
@@ -10933,7 +12586,7 @@
       </p:sp>
       <p:sp>
         <p:nvSpPr>
-          <p:cNvPr id="42" name="TextBox 41"/>
+          <p:cNvPr id="48" name="TextBox 47"/>
           <p:cNvSpPr txBox="1"/>
           <p:nvPr/>
         </p:nvSpPr>
@@ -10968,7 +12621,7 @@
       </p:sp>
       <p:sp>
         <p:nvSpPr>
-          <p:cNvPr id="43" name="Oval 42"/>
+          <p:cNvPr id="49" name="Oval 48"/>
           <p:cNvSpPr/>
           <p:nvPr/>
         </p:nvSpPr>
@@ -11012,7 +12665,7 @@
       </p:sp>
       <p:sp>
         <p:nvSpPr>
-          <p:cNvPr id="44" name="TextBox 43"/>
+          <p:cNvPr id="50" name="TextBox 49"/>
           <p:cNvSpPr txBox="1"/>
           <p:nvPr/>
         </p:nvSpPr>
@@ -11047,7 +12700,7 @@
       </p:sp>
       <p:sp>
         <p:nvSpPr>
-          <p:cNvPr id="45" name="Oval 44"/>
+          <p:cNvPr id="51" name="Oval 50"/>
           <p:cNvSpPr/>
           <p:nvPr/>
         </p:nvSpPr>
@@ -11093,7 +12746,7 @@
       </p:sp>
       <p:sp>
         <p:nvSpPr>
-          <p:cNvPr id="46" name="TextBox 45"/>
+          <p:cNvPr id="52" name="TextBox 51"/>
           <p:cNvSpPr txBox="1"/>
           <p:nvPr/>
         </p:nvSpPr>
@@ -11128,7 +12781,7 @@
       </p:sp>
       <p:sp>
         <p:nvSpPr>
-          <p:cNvPr id="47" name="Oval 46"/>
+          <p:cNvPr id="53" name="Oval 52"/>
           <p:cNvSpPr/>
           <p:nvPr/>
         </p:nvSpPr>
@@ -11172,7 +12825,7 @@
       </p:sp>
       <p:sp>
         <p:nvSpPr>
-          <p:cNvPr id="48" name="TextBox 47"/>
+          <p:cNvPr id="54" name="TextBox 53"/>
           <p:cNvSpPr txBox="1"/>
           <p:nvPr/>
         </p:nvSpPr>
@@ -11207,7 +12860,7 @@
       </p:sp>
       <p:sp>
         <p:nvSpPr>
-          <p:cNvPr id="49" name="Rounded Rectangle 48"/>
+          <p:cNvPr id="55" name="Rounded Rectangle 54"/>
           <p:cNvSpPr/>
           <p:nvPr/>
         </p:nvSpPr>
@@ -11255,7 +12908,7 @@
       </p:sp>
       <p:sp>
         <p:nvSpPr>
-          <p:cNvPr id="50" name="TextBox 49"/>
+          <p:cNvPr id="56" name="TextBox 55"/>
           <p:cNvSpPr txBox="1"/>
           <p:nvPr/>
         </p:nvSpPr>
@@ -11302,7 +12955,7 @@
       </p:sp>
       <p:sp>
         <p:nvSpPr>
-          <p:cNvPr id="51" name="Oval 50"/>
+          <p:cNvPr id="57" name="Oval 56"/>
           <p:cNvSpPr/>
           <p:nvPr/>
         </p:nvSpPr>
@@ -11355,7 +13008,7 @@
       </p:sp>
       <p:sp>
         <p:nvSpPr>
-          <p:cNvPr id="52" name="TextBox 51"/>
+          <p:cNvPr id="58" name="TextBox 57"/>
           <p:cNvSpPr txBox="1"/>
           <p:nvPr/>
         </p:nvSpPr>
@@ -11390,7 +13043,7 @@
       </p:sp>
       <p:sp>
         <p:nvSpPr>
-          <p:cNvPr id="53" name="Oval 52"/>
+          <p:cNvPr id="59" name="Oval 58"/>
           <p:cNvSpPr/>
           <p:nvPr/>
         </p:nvSpPr>
@@ -11434,7 +13087,7 @@
       </p:sp>
       <p:sp>
         <p:nvSpPr>
-          <p:cNvPr id="54" name="TextBox 53"/>
+          <p:cNvPr id="60" name="TextBox 59"/>
           <p:cNvSpPr txBox="1"/>
           <p:nvPr/>
         </p:nvSpPr>
@@ -11469,7 +13122,7 @@
       </p:sp>
       <p:sp>
         <p:nvSpPr>
-          <p:cNvPr id="55" name="Oval 54"/>
+          <p:cNvPr id="61" name="Oval 60"/>
           <p:cNvSpPr/>
           <p:nvPr/>
         </p:nvSpPr>
@@ -11522,7 +13175,7 @@
       </p:sp>
       <p:sp>
         <p:nvSpPr>
-          <p:cNvPr id="56" name="TextBox 55"/>
+          <p:cNvPr id="62" name="TextBox 61"/>
           <p:cNvSpPr txBox="1"/>
           <p:nvPr/>
         </p:nvSpPr>
@@ -11557,7 +13210,7 @@
       </p:sp>
       <p:sp>
         <p:nvSpPr>
-          <p:cNvPr id="57" name="Oval 56"/>
+          <p:cNvPr id="63" name="Oval 62"/>
           <p:cNvSpPr/>
           <p:nvPr/>
         </p:nvSpPr>
@@ -11603,7 +13256,7 @@
       </p:sp>
       <p:sp>
         <p:nvSpPr>
-          <p:cNvPr id="58" name="TextBox 57"/>
+          <p:cNvPr id="64" name="TextBox 63"/>
           <p:cNvSpPr txBox="1"/>
           <p:nvPr/>
         </p:nvSpPr>
@@ -11641,6 +13294,527 @@
   <p:clrMapOvr>
     <a:masterClrMapping/>
   </p:clrMapOvr>
+  <p:transition spd="med">
+    <p:fade/>
+  </p:transition>
+  <p:timing>
+    <p:tnLst>
+      <p:par>
+        <p:cTn id="1" dur="indefinite" restart="never" nodeType="tmRoot">
+          <p:childTnLst>
+            <p:seq concurrent="1" nextAc="seek">
+              <p:cTn id="2" dur="indefinite" nodeType="mainSeq">
+                <p:childTnLst>
+                  <p:par>
+                    <p:cTn id="3" fill="hold">
+                      <p:stCondLst>
+                        <p:cond delay="200"/>
+                      </p:stCondLst>
+                      <p:childTnLst>
+                        <p:par>
+                          <p:cTn id="4" fill="hold">
+                            <p:stCondLst>
+                              <p:cond delay="0"/>
+                            </p:stCondLst>
+                            <p:childTnLst>
+                              <p:par>
+                                <p:cTn id="5" presetID="10" presetClass="entr" presetSubtype="0" fill="hold" grpId="0" nodeType="afterEffect">
+                                  <p:stCondLst>
+                                    <p:cond delay="0"/>
+                                  </p:stCondLst>
+                                  <p:childTnLst>
+                                    <p:set>
+                                      <p:cBhvr>
+                                        <p:cTn id="6" dur="1" fill="hold">
+                                          <p:stCondLst>
+                                            <p:cond delay="0"/>
+                                          </p:stCondLst>
+                                        </p:cTn>
+                                        <p:tgtEl>
+                                          <p:spTgt spid="27"/>
+                                        </p:tgtEl>
+                                        <p:attrNameLst>
+                                          <p:attrName>style.visibility</p:attrName>
+                                        </p:attrNameLst>
+                                      </p:cBhvr>
+                                      <p:to>
+                                        <p:strVal val="visible"/>
+                                      </p:to>
+                                    </p:set>
+                                    <p:animEffect transition="in" filter="fade">
+                                      <p:cBhvr>
+                                        <p:cTn id="7" dur="420"/>
+                                        <p:tgtEl>
+                                          <p:spTgt spid="27"/>
+                                        </p:tgtEl>
+                                      </p:cBhvr>
+                                    </p:animEffect>
+                                  </p:childTnLst>
+                                </p:cTn>
+                              </p:par>
+                              <p:par>
+                                <p:cTn id="8" presetID="10" presetClass="entr" presetSubtype="0" fill="hold" grpId="0" nodeType="withEffect">
+                                  <p:stCondLst>
+                                    <p:cond delay="0"/>
+                                  </p:stCondLst>
+                                  <p:childTnLst>
+                                    <p:set>
+                                      <p:cBhvr>
+                                        <p:cTn id="9" dur="1" fill="hold">
+                                          <p:stCondLst>
+                                            <p:cond delay="0"/>
+                                          </p:stCondLst>
+                                        </p:cTn>
+                                        <p:tgtEl>
+                                          <p:spTgt spid="28"/>
+                                        </p:tgtEl>
+                                        <p:attrNameLst>
+                                          <p:attrName>style.visibility</p:attrName>
+                                        </p:attrNameLst>
+                                      </p:cBhvr>
+                                      <p:to>
+                                        <p:strVal val="visible"/>
+                                      </p:to>
+                                    </p:set>
+                                    <p:animEffect transition="in" filter="fade">
+                                      <p:cBhvr>
+                                        <p:cTn id="10" dur="420"/>
+                                        <p:tgtEl>
+                                          <p:spTgt spid="28"/>
+                                        </p:tgtEl>
+                                      </p:cBhvr>
+                                    </p:animEffect>
+                                  </p:childTnLst>
+                                </p:cTn>
+                              </p:par>
+                              <p:par>
+                                <p:cTn id="11" presetID="10" presetClass="entr" presetSubtype="0" fill="hold" grpId="0" nodeType="withEffect">
+                                  <p:stCondLst>
+                                    <p:cond delay="0"/>
+                                  </p:stCondLst>
+                                  <p:childTnLst>
+                                    <p:set>
+                                      <p:cBhvr>
+                                        <p:cTn id="12" dur="1" fill="hold">
+                                          <p:stCondLst>
+                                            <p:cond delay="0"/>
+                                          </p:stCondLst>
+                                        </p:cTn>
+                                        <p:tgtEl>
+                                          <p:spTgt spid="29"/>
+                                        </p:tgtEl>
+                                        <p:attrNameLst>
+                                          <p:attrName>style.visibility</p:attrName>
+                                        </p:attrNameLst>
+                                      </p:cBhvr>
+                                      <p:to>
+                                        <p:strVal val="visible"/>
+                                      </p:to>
+                                    </p:set>
+                                    <p:animEffect transition="in" filter="fade">
+                                      <p:cBhvr>
+                                        <p:cTn id="13" dur="420"/>
+                                        <p:tgtEl>
+                                          <p:spTgt spid="29"/>
+                                        </p:tgtEl>
+                                      </p:cBhvr>
+                                    </p:animEffect>
+                                  </p:childTnLst>
+                                </p:cTn>
+                              </p:par>
+                              <p:par>
+                                <p:cTn id="14" presetID="10" presetClass="entr" presetSubtype="0" fill="hold" grpId="0" nodeType="withEffect">
+                                  <p:stCondLst>
+                                    <p:cond delay="0"/>
+                                  </p:stCondLst>
+                                  <p:childTnLst>
+                                    <p:set>
+                                      <p:cBhvr>
+                                        <p:cTn id="15" dur="1" fill="hold">
+                                          <p:stCondLst>
+                                            <p:cond delay="0"/>
+                                          </p:stCondLst>
+                                        </p:cTn>
+                                        <p:tgtEl>
+                                          <p:spTgt spid="30"/>
+                                        </p:tgtEl>
+                                        <p:attrNameLst>
+                                          <p:attrName>style.visibility</p:attrName>
+                                        </p:attrNameLst>
+                                      </p:cBhvr>
+                                      <p:to>
+                                        <p:strVal val="visible"/>
+                                      </p:to>
+                                    </p:set>
+                                    <p:animEffect transition="in" filter="fade">
+                                      <p:cBhvr>
+                                        <p:cTn id="16" dur="420"/>
+                                        <p:tgtEl>
+                                          <p:spTgt spid="30"/>
+                                        </p:tgtEl>
+                                      </p:cBhvr>
+                                    </p:animEffect>
+                                  </p:childTnLst>
+                                </p:cTn>
+                              </p:par>
+                            </p:childTnLst>
+                          </p:cTn>
+                        </p:par>
+                      </p:childTnLst>
+                    </p:cTn>
+                  </p:par>
+                  <p:par>
+                    <p:cTn id="17" fill="hold">
+                      <p:stCondLst>
+                        <p:cond delay="350"/>
+                      </p:stCondLst>
+                      <p:childTnLst>
+                        <p:par>
+                          <p:cTn id="18" fill="hold">
+                            <p:stCondLst>
+                              <p:cond delay="0"/>
+                            </p:stCondLst>
+                            <p:childTnLst>
+                              <p:par>
+                                <p:cTn id="19" presetID="10" presetClass="entr" presetSubtype="0" fill="hold" grpId="0" nodeType="afterEffect">
+                                  <p:stCondLst>
+                                    <p:cond delay="0"/>
+                                  </p:stCondLst>
+                                  <p:childTnLst>
+                                    <p:set>
+                                      <p:cBhvr>
+                                        <p:cTn id="20" dur="1" fill="hold">
+                                          <p:stCondLst>
+                                            <p:cond delay="0"/>
+                                          </p:stCondLst>
+                                        </p:cTn>
+                                        <p:tgtEl>
+                                          <p:spTgt spid="31"/>
+                                        </p:tgtEl>
+                                        <p:attrNameLst>
+                                          <p:attrName>style.visibility</p:attrName>
+                                        </p:attrNameLst>
+                                      </p:cBhvr>
+                                      <p:to>
+                                        <p:strVal val="visible"/>
+                                      </p:to>
+                                    </p:set>
+                                    <p:animEffect transition="in" filter="fade">
+                                      <p:cBhvr>
+                                        <p:cTn id="21" dur="420"/>
+                                        <p:tgtEl>
+                                          <p:spTgt spid="31"/>
+                                        </p:tgtEl>
+                                      </p:cBhvr>
+                                    </p:animEffect>
+                                  </p:childTnLst>
+                                </p:cTn>
+                              </p:par>
+                              <p:par>
+                                <p:cTn id="22" presetID="10" presetClass="entr" presetSubtype="0" fill="hold" grpId="0" nodeType="withEffect">
+                                  <p:stCondLst>
+                                    <p:cond delay="0"/>
+                                  </p:stCondLst>
+                                  <p:childTnLst>
+                                    <p:set>
+                                      <p:cBhvr>
+                                        <p:cTn id="23" dur="1" fill="hold">
+                                          <p:stCondLst>
+                                            <p:cond delay="0"/>
+                                          </p:stCondLst>
+                                        </p:cTn>
+                                        <p:tgtEl>
+                                          <p:spTgt spid="32"/>
+                                        </p:tgtEl>
+                                        <p:attrNameLst>
+                                          <p:attrName>style.visibility</p:attrName>
+                                        </p:attrNameLst>
+                                      </p:cBhvr>
+                                      <p:to>
+                                        <p:strVal val="visible"/>
+                                      </p:to>
+                                    </p:set>
+                                    <p:animEffect transition="in" filter="fade">
+                                      <p:cBhvr>
+                                        <p:cTn id="24" dur="420"/>
+                                        <p:tgtEl>
+                                          <p:spTgt spid="32"/>
+                                        </p:tgtEl>
+                                      </p:cBhvr>
+                                    </p:animEffect>
+                                  </p:childTnLst>
+                                </p:cTn>
+                              </p:par>
+                              <p:par>
+                                <p:cTn id="25" presetID="10" presetClass="entr" presetSubtype="0" fill="hold" grpId="0" nodeType="withEffect">
+                                  <p:stCondLst>
+                                    <p:cond delay="0"/>
+                                  </p:stCondLst>
+                                  <p:childTnLst>
+                                    <p:set>
+                                      <p:cBhvr>
+                                        <p:cTn id="26" dur="1" fill="hold">
+                                          <p:stCondLst>
+                                            <p:cond delay="0"/>
+                                          </p:stCondLst>
+                                        </p:cTn>
+                                        <p:tgtEl>
+                                          <p:spTgt spid="33"/>
+                                        </p:tgtEl>
+                                        <p:attrNameLst>
+                                          <p:attrName>style.visibility</p:attrName>
+                                        </p:attrNameLst>
+                                      </p:cBhvr>
+                                      <p:to>
+                                        <p:strVal val="visible"/>
+                                      </p:to>
+                                    </p:set>
+                                    <p:animEffect transition="in" filter="fade">
+                                      <p:cBhvr>
+                                        <p:cTn id="27" dur="420"/>
+                                        <p:tgtEl>
+                                          <p:spTgt spid="33"/>
+                                        </p:tgtEl>
+                                      </p:cBhvr>
+                                    </p:animEffect>
+                                  </p:childTnLst>
+                                </p:cTn>
+                              </p:par>
+                              <p:par>
+                                <p:cTn id="28" presetID="10" presetClass="entr" presetSubtype="0" fill="hold" grpId="0" nodeType="withEffect">
+                                  <p:stCondLst>
+                                    <p:cond delay="0"/>
+                                  </p:stCondLst>
+                                  <p:childTnLst>
+                                    <p:set>
+                                      <p:cBhvr>
+                                        <p:cTn id="29" dur="1" fill="hold">
+                                          <p:stCondLst>
+                                            <p:cond delay="0"/>
+                                          </p:stCondLst>
+                                        </p:cTn>
+                                        <p:tgtEl>
+                                          <p:spTgt spid="34"/>
+                                        </p:tgtEl>
+                                        <p:attrNameLst>
+                                          <p:attrName>style.visibility</p:attrName>
+                                        </p:attrNameLst>
+                                      </p:cBhvr>
+                                      <p:to>
+                                        <p:strVal val="visible"/>
+                                      </p:to>
+                                    </p:set>
+                                    <p:animEffect transition="in" filter="fade">
+                                      <p:cBhvr>
+                                        <p:cTn id="30" dur="420"/>
+                                        <p:tgtEl>
+                                          <p:spTgt spid="34"/>
+                                        </p:tgtEl>
+                                      </p:cBhvr>
+                                    </p:animEffect>
+                                  </p:childTnLst>
+                                </p:cTn>
+                              </p:par>
+                            </p:childTnLst>
+                          </p:cTn>
+                        </p:par>
+                      </p:childTnLst>
+                    </p:cTn>
+                  </p:par>
+                  <p:par>
+                    <p:cTn id="31" fill="hold">
+                      <p:stCondLst>
+                        <p:cond delay="350"/>
+                      </p:stCondLst>
+                      <p:childTnLst>
+                        <p:par>
+                          <p:cTn id="32" fill="hold">
+                            <p:stCondLst>
+                              <p:cond delay="0"/>
+                            </p:stCondLst>
+                            <p:childTnLst>
+                              <p:par>
+                                <p:cTn id="33" presetID="10" presetClass="entr" presetSubtype="0" fill="hold" grpId="0" nodeType="afterEffect">
+                                  <p:stCondLst>
+                                    <p:cond delay="0"/>
+                                  </p:stCondLst>
+                                  <p:childTnLst>
+                                    <p:set>
+                                      <p:cBhvr>
+                                        <p:cTn id="34" dur="1" fill="hold">
+                                          <p:stCondLst>
+                                            <p:cond delay="0"/>
+                                          </p:stCondLst>
+                                        </p:cTn>
+                                        <p:tgtEl>
+                                          <p:spTgt spid="35"/>
+                                        </p:tgtEl>
+                                        <p:attrNameLst>
+                                          <p:attrName>style.visibility</p:attrName>
+                                        </p:attrNameLst>
+                                      </p:cBhvr>
+                                      <p:to>
+                                        <p:strVal val="visible"/>
+                                      </p:to>
+                                    </p:set>
+                                    <p:animEffect transition="in" filter="fade">
+                                      <p:cBhvr>
+                                        <p:cTn id="35" dur="420"/>
+                                        <p:tgtEl>
+                                          <p:spTgt spid="35"/>
+                                        </p:tgtEl>
+                                      </p:cBhvr>
+                                    </p:animEffect>
+                                  </p:childTnLst>
+                                </p:cTn>
+                              </p:par>
+                              <p:par>
+                                <p:cTn id="36" presetID="10" presetClass="entr" presetSubtype="0" fill="hold" grpId="0" nodeType="withEffect">
+                                  <p:stCondLst>
+                                    <p:cond delay="0"/>
+                                  </p:stCondLst>
+                                  <p:childTnLst>
+                                    <p:set>
+                                      <p:cBhvr>
+                                        <p:cTn id="37" dur="1" fill="hold">
+                                          <p:stCondLst>
+                                            <p:cond delay="0"/>
+                                          </p:stCondLst>
+                                        </p:cTn>
+                                        <p:tgtEl>
+                                          <p:spTgt spid="36"/>
+                                        </p:tgtEl>
+                                        <p:attrNameLst>
+                                          <p:attrName>style.visibility</p:attrName>
+                                        </p:attrNameLst>
+                                      </p:cBhvr>
+                                      <p:to>
+                                        <p:strVal val="visible"/>
+                                      </p:to>
+                                    </p:set>
+                                    <p:animEffect transition="in" filter="fade">
+                                      <p:cBhvr>
+                                        <p:cTn id="38" dur="420"/>
+                                        <p:tgtEl>
+                                          <p:spTgt spid="36"/>
+                                        </p:tgtEl>
+                                      </p:cBhvr>
+                                    </p:animEffect>
+                                  </p:childTnLst>
+                                </p:cTn>
+                              </p:par>
+                              <p:par>
+                                <p:cTn id="39" presetID="10" presetClass="entr" presetSubtype="0" fill="hold" grpId="0" nodeType="withEffect">
+                                  <p:stCondLst>
+                                    <p:cond delay="0"/>
+                                  </p:stCondLst>
+                                  <p:childTnLst>
+                                    <p:set>
+                                      <p:cBhvr>
+                                        <p:cTn id="40" dur="1" fill="hold">
+                                          <p:stCondLst>
+                                            <p:cond delay="0"/>
+                                          </p:stCondLst>
+                                        </p:cTn>
+                                        <p:tgtEl>
+                                          <p:spTgt spid="37"/>
+                                        </p:tgtEl>
+                                        <p:attrNameLst>
+                                          <p:attrName>style.visibility</p:attrName>
+                                        </p:attrNameLst>
+                                      </p:cBhvr>
+                                      <p:to>
+                                        <p:strVal val="visible"/>
+                                      </p:to>
+                                    </p:set>
+                                    <p:animEffect transition="in" filter="fade">
+                                      <p:cBhvr>
+                                        <p:cTn id="41" dur="420"/>
+                                        <p:tgtEl>
+                                          <p:spTgt spid="37"/>
+                                        </p:tgtEl>
+                                      </p:cBhvr>
+                                    </p:animEffect>
+                                  </p:childTnLst>
+                                </p:cTn>
+                              </p:par>
+                              <p:par>
+                                <p:cTn id="42" presetID="10" presetClass="entr" presetSubtype="0" fill="hold" grpId="0" nodeType="withEffect">
+                                  <p:stCondLst>
+                                    <p:cond delay="0"/>
+                                  </p:stCondLst>
+                                  <p:childTnLst>
+                                    <p:set>
+                                      <p:cBhvr>
+                                        <p:cTn id="43" dur="1" fill="hold">
+                                          <p:stCondLst>
+                                            <p:cond delay="0"/>
+                                          </p:stCondLst>
+                                        </p:cTn>
+                                        <p:tgtEl>
+                                          <p:spTgt spid="38"/>
+                                        </p:tgtEl>
+                                        <p:attrNameLst>
+                                          <p:attrName>style.visibility</p:attrName>
+                                        </p:attrNameLst>
+                                      </p:cBhvr>
+                                      <p:to>
+                                        <p:strVal val="visible"/>
+                                      </p:to>
+                                    </p:set>
+                                    <p:animEffect transition="in" filter="fade">
+                                      <p:cBhvr>
+                                        <p:cTn id="44" dur="420"/>
+                                        <p:tgtEl>
+                                          <p:spTgt spid="38"/>
+                                        </p:tgtEl>
+                                      </p:cBhvr>
+                                    </p:animEffect>
+                                  </p:childTnLst>
+                                </p:cTn>
+                              </p:par>
+                            </p:childTnLst>
+                          </p:cTn>
+                        </p:par>
+                      </p:childTnLst>
+                    </p:cTn>
+                  </p:par>
+                </p:childTnLst>
+              </p:cTn>
+              <p:prevCondLst>
+                <p:cond evt="onPrev" delay="0">
+                  <p:tgtEl>
+                    <p:sldTgt/>
+                  </p:tgtEl>
+                </p:cond>
+              </p:prevCondLst>
+              <p:nextCondLst>
+                <p:cond evt="onNext" delay="0">
+                  <p:tgtEl>
+                    <p:sldTgt/>
+                  </p:tgtEl>
+                </p:cond>
+              </p:nextCondLst>
+            </p:seq>
+          </p:childTnLst>
+        </p:cTn>
+      </p:par>
+    </p:tnLst>
+    <p:bldLst>
+      <p:bldP spid="27" grpId="0" animBg="1"/>
+      <p:bldP spid="28" grpId="0" animBg="1"/>
+      <p:bldP spid="29" grpId="0" animBg="1"/>
+      <p:bldP spid="30" grpId="0" animBg="1"/>
+      <p:bldP spid="31" grpId="0" animBg="1"/>
+      <p:bldP spid="32" grpId="0" animBg="1"/>
+      <p:bldP spid="33" grpId="0" animBg="1"/>
+      <p:bldP spid="34" grpId="0" animBg="1"/>
+      <p:bldP spid="35" grpId="0" animBg="1"/>
+      <p:bldP spid="36" grpId="0" animBg="1"/>
+      <p:bldP spid="37" grpId="0" animBg="1"/>
+      <p:bldP spid="38" grpId="0" animBg="1"/>
+    </p:bldLst>
+  </p:timing>
 </p:sld>
 </file>
 
@@ -12719,7 +14893,7 @@
       </p:sp>
       <p:sp>
         <p:nvSpPr>
-          <p:cNvPr id="27" name="Rectangle 26"/>
+          <p:cNvPr id="67" name="Rectangle 66"/>
           <p:cNvSpPr/>
           <p:nvPr/>
         </p:nvSpPr>
@@ -12763,7 +14937,7 @@
       </p:sp>
       <p:pic>
         <p:nvPicPr>
-          <p:cNvPr id="28" name="Picture 27" descr="logo_wordmark.png"/>
+          <p:cNvPr id="68" name="Picture 67" descr="logo_wordmark.png"/>
           <p:cNvPicPr>
             <a:picLocks noChangeAspect="1"/>
           </p:cNvPicPr>
@@ -12790,6 +14964,797 @@
   <p:clrMapOvr>
     <a:masterClrMapping/>
   </p:clrMapOvr>
+  <p:transition spd="med">
+    <p:fade/>
+  </p:transition>
+  <p:timing>
+    <p:tnLst>
+      <p:par>
+        <p:cTn id="1" dur="indefinite" restart="never" nodeType="tmRoot">
+          <p:childTnLst>
+            <p:seq concurrent="1" nextAc="seek">
+              <p:cTn id="2" dur="indefinite" nodeType="mainSeq">
+                <p:childTnLst>
+                  <p:par>
+                    <p:cTn id="3" fill="hold">
+                      <p:stCondLst>
+                        <p:cond delay="200"/>
+                      </p:stCondLst>
+                      <p:childTnLst>
+                        <p:par>
+                          <p:cTn id="4" fill="hold">
+                            <p:stCondLst>
+                              <p:cond delay="0"/>
+                            </p:stCondLst>
+                            <p:childTnLst>
+                              <p:par>
+                                <p:cTn id="5" presetID="10" presetClass="entr" presetSubtype="0" fill="hold" grpId="0" nodeType="afterEffect">
+                                  <p:stCondLst>
+                                    <p:cond delay="0"/>
+                                  </p:stCondLst>
+                                  <p:childTnLst>
+                                    <p:set>
+                                      <p:cBhvr>
+                                        <p:cTn id="6" dur="1" fill="hold">
+                                          <p:stCondLst>
+                                            <p:cond delay="0"/>
+                                          </p:stCondLst>
+                                        </p:cTn>
+                                        <p:tgtEl>
+                                          <p:spTgt spid="7"/>
+                                        </p:tgtEl>
+                                        <p:attrNameLst>
+                                          <p:attrName>style.visibility</p:attrName>
+                                        </p:attrNameLst>
+                                      </p:cBhvr>
+                                      <p:to>
+                                        <p:strVal val="visible"/>
+                                      </p:to>
+                                    </p:set>
+                                    <p:animEffect transition="in" filter="fade">
+                                      <p:cBhvr>
+                                        <p:cTn id="7" dur="420"/>
+                                        <p:tgtEl>
+                                          <p:spTgt spid="7"/>
+                                        </p:tgtEl>
+                                      </p:cBhvr>
+                                    </p:animEffect>
+                                  </p:childTnLst>
+                                </p:cTn>
+                              </p:par>
+                              <p:par>
+                                <p:cTn id="8" presetID="10" presetClass="entr" presetSubtype="0" fill="hold" grpId="0" nodeType="withEffect">
+                                  <p:stCondLst>
+                                    <p:cond delay="0"/>
+                                  </p:stCondLst>
+                                  <p:childTnLst>
+                                    <p:set>
+                                      <p:cBhvr>
+                                        <p:cTn id="9" dur="1" fill="hold">
+                                          <p:stCondLst>
+                                            <p:cond delay="0"/>
+                                          </p:stCondLst>
+                                        </p:cTn>
+                                        <p:tgtEl>
+                                          <p:spTgt spid="8"/>
+                                        </p:tgtEl>
+                                        <p:attrNameLst>
+                                          <p:attrName>style.visibility</p:attrName>
+                                        </p:attrNameLst>
+                                      </p:cBhvr>
+                                      <p:to>
+                                        <p:strVal val="visible"/>
+                                      </p:to>
+                                    </p:set>
+                                    <p:animEffect transition="in" filter="fade">
+                                      <p:cBhvr>
+                                        <p:cTn id="10" dur="420"/>
+                                        <p:tgtEl>
+                                          <p:spTgt spid="8"/>
+                                        </p:tgtEl>
+                                      </p:cBhvr>
+                                    </p:animEffect>
+                                  </p:childTnLst>
+                                </p:cTn>
+                              </p:par>
+                              <p:par>
+                                <p:cTn id="11" presetID="10" presetClass="entr" presetSubtype="0" fill="hold" grpId="0" nodeType="withEffect">
+                                  <p:stCondLst>
+                                    <p:cond delay="0"/>
+                                  </p:stCondLst>
+                                  <p:childTnLst>
+                                    <p:set>
+                                      <p:cBhvr>
+                                        <p:cTn id="12" dur="1" fill="hold">
+                                          <p:stCondLst>
+                                            <p:cond delay="0"/>
+                                          </p:stCondLst>
+                                        </p:cTn>
+                                        <p:tgtEl>
+                                          <p:spTgt spid="9"/>
+                                        </p:tgtEl>
+                                        <p:attrNameLst>
+                                          <p:attrName>style.visibility</p:attrName>
+                                        </p:attrNameLst>
+                                      </p:cBhvr>
+                                      <p:to>
+                                        <p:strVal val="visible"/>
+                                      </p:to>
+                                    </p:set>
+                                    <p:animEffect transition="in" filter="fade">
+                                      <p:cBhvr>
+                                        <p:cTn id="13" dur="420"/>
+                                        <p:tgtEl>
+                                          <p:spTgt spid="9"/>
+                                        </p:tgtEl>
+                                      </p:cBhvr>
+                                    </p:animEffect>
+                                  </p:childTnLst>
+                                </p:cTn>
+                              </p:par>
+                              <p:par>
+                                <p:cTn id="14" presetID="10" presetClass="entr" presetSubtype="0" fill="hold" grpId="0" nodeType="withEffect">
+                                  <p:stCondLst>
+                                    <p:cond delay="0"/>
+                                  </p:stCondLst>
+                                  <p:childTnLst>
+                                    <p:set>
+                                      <p:cBhvr>
+                                        <p:cTn id="15" dur="1" fill="hold">
+                                          <p:stCondLst>
+                                            <p:cond delay="0"/>
+                                          </p:stCondLst>
+                                        </p:cTn>
+                                        <p:tgtEl>
+                                          <p:spTgt spid="10"/>
+                                        </p:tgtEl>
+                                        <p:attrNameLst>
+                                          <p:attrName>style.visibility</p:attrName>
+                                        </p:attrNameLst>
+                                      </p:cBhvr>
+                                      <p:to>
+                                        <p:strVal val="visible"/>
+                                      </p:to>
+                                    </p:set>
+                                    <p:animEffect transition="in" filter="fade">
+                                      <p:cBhvr>
+                                        <p:cTn id="16" dur="420"/>
+                                        <p:tgtEl>
+                                          <p:spTgt spid="10"/>
+                                        </p:tgtEl>
+                                      </p:cBhvr>
+                                    </p:animEffect>
+                                  </p:childTnLst>
+                                </p:cTn>
+                              </p:par>
+                              <p:par>
+                                <p:cTn id="17" presetID="10" presetClass="entr" presetSubtype="0" fill="hold" grpId="0" nodeType="withEffect">
+                                  <p:stCondLst>
+                                    <p:cond delay="0"/>
+                                  </p:stCondLst>
+                                  <p:childTnLst>
+                                    <p:set>
+                                      <p:cBhvr>
+                                        <p:cTn id="18" dur="1" fill="hold">
+                                          <p:stCondLst>
+                                            <p:cond delay="0"/>
+                                          </p:stCondLst>
+                                        </p:cTn>
+                                        <p:tgtEl>
+                                          <p:spTgt spid="11"/>
+                                        </p:tgtEl>
+                                        <p:attrNameLst>
+                                          <p:attrName>style.visibility</p:attrName>
+                                        </p:attrNameLst>
+                                      </p:cBhvr>
+                                      <p:to>
+                                        <p:strVal val="visible"/>
+                                      </p:to>
+                                    </p:set>
+                                    <p:animEffect transition="in" filter="fade">
+                                      <p:cBhvr>
+                                        <p:cTn id="19" dur="420"/>
+                                        <p:tgtEl>
+                                          <p:spTgt spid="11"/>
+                                        </p:tgtEl>
+                                      </p:cBhvr>
+                                    </p:animEffect>
+                                  </p:childTnLst>
+                                </p:cTn>
+                              </p:par>
+                              <p:par>
+                                <p:cTn id="20" presetID="10" presetClass="entr" presetSubtype="0" fill="hold" grpId="0" nodeType="withEffect">
+                                  <p:stCondLst>
+                                    <p:cond delay="0"/>
+                                  </p:stCondLst>
+                                  <p:childTnLst>
+                                    <p:set>
+                                      <p:cBhvr>
+                                        <p:cTn id="21" dur="1" fill="hold">
+                                          <p:stCondLst>
+                                            <p:cond delay="0"/>
+                                          </p:stCondLst>
+                                        </p:cTn>
+                                        <p:tgtEl>
+                                          <p:spTgt spid="12"/>
+                                        </p:tgtEl>
+                                        <p:attrNameLst>
+                                          <p:attrName>style.visibility</p:attrName>
+                                        </p:attrNameLst>
+                                      </p:cBhvr>
+                                      <p:to>
+                                        <p:strVal val="visible"/>
+                                      </p:to>
+                                    </p:set>
+                                    <p:animEffect transition="in" filter="fade">
+                                      <p:cBhvr>
+                                        <p:cTn id="22" dur="420"/>
+                                        <p:tgtEl>
+                                          <p:spTgt spid="12"/>
+                                        </p:tgtEl>
+                                      </p:cBhvr>
+                                    </p:animEffect>
+                                  </p:childTnLst>
+                                </p:cTn>
+                              </p:par>
+                            </p:childTnLst>
+                          </p:cTn>
+                        </p:par>
+                      </p:childTnLst>
+                    </p:cTn>
+                  </p:par>
+                  <p:par>
+                    <p:cTn id="23" fill="hold">
+                      <p:stCondLst>
+                        <p:cond delay="350"/>
+                      </p:stCondLst>
+                      <p:childTnLst>
+                        <p:par>
+                          <p:cTn id="24" fill="hold">
+                            <p:stCondLst>
+                              <p:cond delay="0"/>
+                            </p:stCondLst>
+                            <p:childTnLst>
+                              <p:par>
+                                <p:cTn id="25" presetID="10" presetClass="entr" presetSubtype="0" fill="hold" grpId="0" nodeType="afterEffect">
+                                  <p:stCondLst>
+                                    <p:cond delay="0"/>
+                                  </p:stCondLst>
+                                  <p:childTnLst>
+                                    <p:set>
+                                      <p:cBhvr>
+                                        <p:cTn id="26" dur="1" fill="hold">
+                                          <p:stCondLst>
+                                            <p:cond delay="0"/>
+                                          </p:stCondLst>
+                                        </p:cTn>
+                                        <p:tgtEl>
+                                          <p:spTgt spid="13"/>
+                                        </p:tgtEl>
+                                        <p:attrNameLst>
+                                          <p:attrName>style.visibility</p:attrName>
+                                        </p:attrNameLst>
+                                      </p:cBhvr>
+                                      <p:to>
+                                        <p:strVal val="visible"/>
+                                      </p:to>
+                                    </p:set>
+                                    <p:animEffect transition="in" filter="fade">
+                                      <p:cBhvr>
+                                        <p:cTn id="27" dur="420"/>
+                                        <p:tgtEl>
+                                          <p:spTgt spid="13"/>
+                                        </p:tgtEl>
+                                      </p:cBhvr>
+                                    </p:animEffect>
+                                  </p:childTnLst>
+                                </p:cTn>
+                              </p:par>
+                              <p:par>
+                                <p:cTn id="28" presetID="10" presetClass="entr" presetSubtype="0" fill="hold" grpId="0" nodeType="withEffect">
+                                  <p:stCondLst>
+                                    <p:cond delay="0"/>
+                                  </p:stCondLst>
+                                  <p:childTnLst>
+                                    <p:set>
+                                      <p:cBhvr>
+                                        <p:cTn id="29" dur="1" fill="hold">
+                                          <p:stCondLst>
+                                            <p:cond delay="0"/>
+                                          </p:stCondLst>
+                                        </p:cTn>
+                                        <p:tgtEl>
+                                          <p:spTgt spid="14"/>
+                                        </p:tgtEl>
+                                        <p:attrNameLst>
+                                          <p:attrName>style.visibility</p:attrName>
+                                        </p:attrNameLst>
+                                      </p:cBhvr>
+                                      <p:to>
+                                        <p:strVal val="visible"/>
+                                      </p:to>
+                                    </p:set>
+                                    <p:animEffect transition="in" filter="fade">
+                                      <p:cBhvr>
+                                        <p:cTn id="30" dur="420"/>
+                                        <p:tgtEl>
+                                          <p:spTgt spid="14"/>
+                                        </p:tgtEl>
+                                      </p:cBhvr>
+                                    </p:animEffect>
+                                  </p:childTnLst>
+                                </p:cTn>
+                              </p:par>
+                              <p:par>
+                                <p:cTn id="31" presetID="10" presetClass="entr" presetSubtype="0" fill="hold" grpId="0" nodeType="withEffect">
+                                  <p:stCondLst>
+                                    <p:cond delay="0"/>
+                                  </p:stCondLst>
+                                  <p:childTnLst>
+                                    <p:set>
+                                      <p:cBhvr>
+                                        <p:cTn id="32" dur="1" fill="hold">
+                                          <p:stCondLst>
+                                            <p:cond delay="0"/>
+                                          </p:stCondLst>
+                                        </p:cTn>
+                                        <p:tgtEl>
+                                          <p:spTgt spid="15"/>
+                                        </p:tgtEl>
+                                        <p:attrNameLst>
+                                          <p:attrName>style.visibility</p:attrName>
+                                        </p:attrNameLst>
+                                      </p:cBhvr>
+                                      <p:to>
+                                        <p:strVal val="visible"/>
+                                      </p:to>
+                                    </p:set>
+                                    <p:animEffect transition="in" filter="fade">
+                                      <p:cBhvr>
+                                        <p:cTn id="33" dur="420"/>
+                                        <p:tgtEl>
+                                          <p:spTgt spid="15"/>
+                                        </p:tgtEl>
+                                      </p:cBhvr>
+                                    </p:animEffect>
+                                  </p:childTnLst>
+                                </p:cTn>
+                              </p:par>
+                              <p:par>
+                                <p:cTn id="34" presetID="10" presetClass="entr" presetSubtype="0" fill="hold" grpId="0" nodeType="withEffect">
+                                  <p:stCondLst>
+                                    <p:cond delay="0"/>
+                                  </p:stCondLst>
+                                  <p:childTnLst>
+                                    <p:set>
+                                      <p:cBhvr>
+                                        <p:cTn id="35" dur="1" fill="hold">
+                                          <p:stCondLst>
+                                            <p:cond delay="0"/>
+                                          </p:stCondLst>
+                                        </p:cTn>
+                                        <p:tgtEl>
+                                          <p:spTgt spid="16"/>
+                                        </p:tgtEl>
+                                        <p:attrNameLst>
+                                          <p:attrName>style.visibility</p:attrName>
+                                        </p:attrNameLst>
+                                      </p:cBhvr>
+                                      <p:to>
+                                        <p:strVal val="visible"/>
+                                      </p:to>
+                                    </p:set>
+                                    <p:animEffect transition="in" filter="fade">
+                                      <p:cBhvr>
+                                        <p:cTn id="36" dur="420"/>
+                                        <p:tgtEl>
+                                          <p:spTgt spid="16"/>
+                                        </p:tgtEl>
+                                      </p:cBhvr>
+                                    </p:animEffect>
+                                  </p:childTnLst>
+                                </p:cTn>
+                              </p:par>
+                              <p:par>
+                                <p:cTn id="37" presetID="10" presetClass="entr" presetSubtype="0" fill="hold" grpId="0" nodeType="withEffect">
+                                  <p:stCondLst>
+                                    <p:cond delay="0"/>
+                                  </p:stCondLst>
+                                  <p:childTnLst>
+                                    <p:set>
+                                      <p:cBhvr>
+                                        <p:cTn id="38" dur="1" fill="hold">
+                                          <p:stCondLst>
+                                            <p:cond delay="0"/>
+                                          </p:stCondLst>
+                                        </p:cTn>
+                                        <p:tgtEl>
+                                          <p:spTgt spid="17"/>
+                                        </p:tgtEl>
+                                        <p:attrNameLst>
+                                          <p:attrName>style.visibility</p:attrName>
+                                        </p:attrNameLst>
+                                      </p:cBhvr>
+                                      <p:to>
+                                        <p:strVal val="visible"/>
+                                      </p:to>
+                                    </p:set>
+                                    <p:animEffect transition="in" filter="fade">
+                                      <p:cBhvr>
+                                        <p:cTn id="39" dur="420"/>
+                                        <p:tgtEl>
+                                          <p:spTgt spid="17"/>
+                                        </p:tgtEl>
+                                      </p:cBhvr>
+                                    </p:animEffect>
+                                  </p:childTnLst>
+                                </p:cTn>
+                              </p:par>
+                              <p:par>
+                                <p:cTn id="40" presetID="10" presetClass="entr" presetSubtype="0" fill="hold" grpId="0" nodeType="withEffect">
+                                  <p:stCondLst>
+                                    <p:cond delay="0"/>
+                                  </p:stCondLst>
+                                  <p:childTnLst>
+                                    <p:set>
+                                      <p:cBhvr>
+                                        <p:cTn id="41" dur="1" fill="hold">
+                                          <p:stCondLst>
+                                            <p:cond delay="0"/>
+                                          </p:stCondLst>
+                                        </p:cTn>
+                                        <p:tgtEl>
+                                          <p:spTgt spid="18"/>
+                                        </p:tgtEl>
+                                        <p:attrNameLst>
+                                          <p:attrName>style.visibility</p:attrName>
+                                        </p:attrNameLst>
+                                      </p:cBhvr>
+                                      <p:to>
+                                        <p:strVal val="visible"/>
+                                      </p:to>
+                                    </p:set>
+                                    <p:animEffect transition="in" filter="fade">
+                                      <p:cBhvr>
+                                        <p:cTn id="42" dur="420"/>
+                                        <p:tgtEl>
+                                          <p:spTgt spid="18"/>
+                                        </p:tgtEl>
+                                      </p:cBhvr>
+                                    </p:animEffect>
+                                  </p:childTnLst>
+                                </p:cTn>
+                              </p:par>
+                              <p:par>
+                                <p:cTn id="43" presetID="10" presetClass="entr" presetSubtype="0" fill="hold" grpId="0" nodeType="withEffect">
+                                  <p:stCondLst>
+                                    <p:cond delay="0"/>
+                                  </p:stCondLst>
+                                  <p:childTnLst>
+                                    <p:set>
+                                      <p:cBhvr>
+                                        <p:cTn id="44" dur="1" fill="hold">
+                                          <p:stCondLst>
+                                            <p:cond delay="0"/>
+                                          </p:stCondLst>
+                                        </p:cTn>
+                                        <p:tgtEl>
+                                          <p:spTgt spid="19"/>
+                                        </p:tgtEl>
+                                        <p:attrNameLst>
+                                          <p:attrName>style.visibility</p:attrName>
+                                        </p:attrNameLst>
+                                      </p:cBhvr>
+                                      <p:to>
+                                        <p:strVal val="visible"/>
+                                      </p:to>
+                                    </p:set>
+                                    <p:animEffect transition="in" filter="fade">
+                                      <p:cBhvr>
+                                        <p:cTn id="45" dur="420"/>
+                                        <p:tgtEl>
+                                          <p:spTgt spid="19"/>
+                                        </p:tgtEl>
+                                      </p:cBhvr>
+                                    </p:animEffect>
+                                  </p:childTnLst>
+                                </p:cTn>
+                              </p:par>
+                              <p:par>
+                                <p:cTn id="46" presetID="10" presetClass="entr" presetSubtype="0" fill="hold" grpId="0" nodeType="withEffect">
+                                  <p:stCondLst>
+                                    <p:cond delay="0"/>
+                                  </p:stCondLst>
+                                  <p:childTnLst>
+                                    <p:set>
+                                      <p:cBhvr>
+                                        <p:cTn id="47" dur="1" fill="hold">
+                                          <p:stCondLst>
+                                            <p:cond delay="0"/>
+                                          </p:stCondLst>
+                                        </p:cTn>
+                                        <p:tgtEl>
+                                          <p:spTgt spid="20"/>
+                                        </p:tgtEl>
+                                        <p:attrNameLst>
+                                          <p:attrName>style.visibility</p:attrName>
+                                        </p:attrNameLst>
+                                      </p:cBhvr>
+                                      <p:to>
+                                        <p:strVal val="visible"/>
+                                      </p:to>
+                                    </p:set>
+                                    <p:animEffect transition="in" filter="fade">
+                                      <p:cBhvr>
+                                        <p:cTn id="48" dur="420"/>
+                                        <p:tgtEl>
+                                          <p:spTgt spid="20"/>
+                                        </p:tgtEl>
+                                      </p:cBhvr>
+                                    </p:animEffect>
+                                  </p:childTnLst>
+                                </p:cTn>
+                              </p:par>
+                              <p:par>
+                                <p:cTn id="49" presetID="10" presetClass="entr" presetSubtype="0" fill="hold" grpId="0" nodeType="withEffect">
+                                  <p:stCondLst>
+                                    <p:cond delay="0"/>
+                                  </p:stCondLst>
+                                  <p:childTnLst>
+                                    <p:set>
+                                      <p:cBhvr>
+                                        <p:cTn id="50" dur="1" fill="hold">
+                                          <p:stCondLst>
+                                            <p:cond delay="0"/>
+                                          </p:stCondLst>
+                                        </p:cTn>
+                                        <p:tgtEl>
+                                          <p:spTgt spid="21"/>
+                                        </p:tgtEl>
+                                        <p:attrNameLst>
+                                          <p:attrName>style.visibility</p:attrName>
+                                        </p:attrNameLst>
+                                      </p:cBhvr>
+                                      <p:to>
+                                        <p:strVal val="visible"/>
+                                      </p:to>
+                                    </p:set>
+                                    <p:animEffect transition="in" filter="fade">
+                                      <p:cBhvr>
+                                        <p:cTn id="51" dur="420"/>
+                                        <p:tgtEl>
+                                          <p:spTgt spid="21"/>
+                                        </p:tgtEl>
+                                      </p:cBhvr>
+                                    </p:animEffect>
+                                  </p:childTnLst>
+                                </p:cTn>
+                              </p:par>
+                              <p:par>
+                                <p:cTn id="52" presetID="10" presetClass="entr" presetSubtype="0" fill="hold" grpId="0" nodeType="withEffect">
+                                  <p:stCondLst>
+                                    <p:cond delay="0"/>
+                                  </p:stCondLst>
+                                  <p:childTnLst>
+                                    <p:set>
+                                      <p:cBhvr>
+                                        <p:cTn id="53" dur="1" fill="hold">
+                                          <p:stCondLst>
+                                            <p:cond delay="0"/>
+                                          </p:stCondLst>
+                                        </p:cTn>
+                                        <p:tgtEl>
+                                          <p:spTgt spid="22"/>
+                                        </p:tgtEl>
+                                        <p:attrNameLst>
+                                          <p:attrName>style.visibility</p:attrName>
+                                        </p:attrNameLst>
+                                      </p:cBhvr>
+                                      <p:to>
+                                        <p:strVal val="visible"/>
+                                      </p:to>
+                                    </p:set>
+                                    <p:animEffect transition="in" filter="fade">
+                                      <p:cBhvr>
+                                        <p:cTn id="54" dur="420"/>
+                                        <p:tgtEl>
+                                          <p:spTgt spid="22"/>
+                                        </p:tgtEl>
+                                      </p:cBhvr>
+                                    </p:animEffect>
+                                  </p:childTnLst>
+                                </p:cTn>
+                              </p:par>
+                              <p:par>
+                                <p:cTn id="55" presetID="10" presetClass="entr" presetSubtype="0" fill="hold" grpId="0" nodeType="withEffect">
+                                  <p:stCondLst>
+                                    <p:cond delay="0"/>
+                                  </p:stCondLst>
+                                  <p:childTnLst>
+                                    <p:set>
+                                      <p:cBhvr>
+                                        <p:cTn id="56" dur="1" fill="hold">
+                                          <p:stCondLst>
+                                            <p:cond delay="0"/>
+                                          </p:stCondLst>
+                                        </p:cTn>
+                                        <p:tgtEl>
+                                          <p:spTgt spid="23"/>
+                                        </p:tgtEl>
+                                        <p:attrNameLst>
+                                          <p:attrName>style.visibility</p:attrName>
+                                        </p:attrNameLst>
+                                      </p:cBhvr>
+                                      <p:to>
+                                        <p:strVal val="visible"/>
+                                      </p:to>
+                                    </p:set>
+                                    <p:animEffect transition="in" filter="fade">
+                                      <p:cBhvr>
+                                        <p:cTn id="57" dur="420"/>
+                                        <p:tgtEl>
+                                          <p:spTgt spid="23"/>
+                                        </p:tgtEl>
+                                      </p:cBhvr>
+                                    </p:animEffect>
+                                  </p:childTnLst>
+                                </p:cTn>
+                              </p:par>
+                              <p:par>
+                                <p:cTn id="58" presetID="10" presetClass="entr" presetSubtype="0" fill="hold" grpId="0" nodeType="withEffect">
+                                  <p:stCondLst>
+                                    <p:cond delay="0"/>
+                                  </p:stCondLst>
+                                  <p:childTnLst>
+                                    <p:set>
+                                      <p:cBhvr>
+                                        <p:cTn id="59" dur="1" fill="hold">
+                                          <p:stCondLst>
+                                            <p:cond delay="0"/>
+                                          </p:stCondLst>
+                                        </p:cTn>
+                                        <p:tgtEl>
+                                          <p:spTgt spid="24"/>
+                                        </p:tgtEl>
+                                        <p:attrNameLst>
+                                          <p:attrName>style.visibility</p:attrName>
+                                        </p:attrNameLst>
+                                      </p:cBhvr>
+                                      <p:to>
+                                        <p:strVal val="visible"/>
+                                      </p:to>
+                                    </p:set>
+                                    <p:animEffect transition="in" filter="fade">
+                                      <p:cBhvr>
+                                        <p:cTn id="60" dur="420"/>
+                                        <p:tgtEl>
+                                          <p:spTgt spid="24"/>
+                                        </p:tgtEl>
+                                      </p:cBhvr>
+                                    </p:animEffect>
+                                  </p:childTnLst>
+                                </p:cTn>
+                              </p:par>
+                              <p:par>
+                                <p:cTn id="61" presetID="10" presetClass="entr" presetSubtype="0" fill="hold" grpId="0" nodeType="withEffect">
+                                  <p:stCondLst>
+                                    <p:cond delay="0"/>
+                                  </p:stCondLst>
+                                  <p:childTnLst>
+                                    <p:set>
+                                      <p:cBhvr>
+                                        <p:cTn id="62" dur="1" fill="hold">
+                                          <p:stCondLst>
+                                            <p:cond delay="0"/>
+                                          </p:stCondLst>
+                                        </p:cTn>
+                                        <p:tgtEl>
+                                          <p:spTgt spid="25"/>
+                                        </p:tgtEl>
+                                        <p:attrNameLst>
+                                          <p:attrName>style.visibility</p:attrName>
+                                        </p:attrNameLst>
+                                      </p:cBhvr>
+                                      <p:to>
+                                        <p:strVal val="visible"/>
+                                      </p:to>
+                                    </p:set>
+                                    <p:animEffect transition="in" filter="fade">
+                                      <p:cBhvr>
+                                        <p:cTn id="63" dur="420"/>
+                                        <p:tgtEl>
+                                          <p:spTgt spid="25"/>
+                                        </p:tgtEl>
+                                      </p:cBhvr>
+                                    </p:animEffect>
+                                  </p:childTnLst>
+                                </p:cTn>
+                              </p:par>
+                              <p:par>
+                                <p:cTn id="64" presetID="10" presetClass="entr" presetSubtype="0" fill="hold" grpId="0" nodeType="withEffect">
+                                  <p:stCondLst>
+                                    <p:cond delay="0"/>
+                                  </p:stCondLst>
+                                  <p:childTnLst>
+                                    <p:set>
+                                      <p:cBhvr>
+                                        <p:cTn id="65" dur="1" fill="hold">
+                                          <p:stCondLst>
+                                            <p:cond delay="0"/>
+                                          </p:stCondLst>
+                                        </p:cTn>
+                                        <p:tgtEl>
+                                          <p:spTgt spid="26"/>
+                                        </p:tgtEl>
+                                        <p:attrNameLst>
+                                          <p:attrName>style.visibility</p:attrName>
+                                        </p:attrNameLst>
+                                      </p:cBhvr>
+                                      <p:to>
+                                        <p:strVal val="visible"/>
+                                      </p:to>
+                                    </p:set>
+                                    <p:animEffect transition="in" filter="fade">
+                                      <p:cBhvr>
+                                        <p:cTn id="66" dur="420"/>
+                                        <p:tgtEl>
+                                          <p:spTgt spid="26"/>
+                                        </p:tgtEl>
+                                      </p:cBhvr>
+                                    </p:animEffect>
+                                  </p:childTnLst>
+                                </p:cTn>
+                              </p:par>
+                            </p:childTnLst>
+                          </p:cTn>
+                        </p:par>
+                      </p:childTnLst>
+                    </p:cTn>
+                  </p:par>
+                </p:childTnLst>
+              </p:cTn>
+              <p:prevCondLst>
+                <p:cond evt="onPrev" delay="0">
+                  <p:tgtEl>
+                    <p:sldTgt/>
+                  </p:tgtEl>
+                </p:cond>
+              </p:prevCondLst>
+              <p:nextCondLst>
+                <p:cond evt="onNext" delay="0">
+                  <p:tgtEl>
+                    <p:sldTgt/>
+                  </p:tgtEl>
+                </p:cond>
+              </p:nextCondLst>
+            </p:seq>
+          </p:childTnLst>
+        </p:cTn>
+      </p:par>
+    </p:tnLst>
+    <p:bldLst>
+      <p:bldP spid="7" grpId="0" animBg="1"/>
+      <p:bldP spid="8" grpId="0" animBg="1"/>
+      <p:bldP spid="9" grpId="0" animBg="1"/>
+      <p:bldP spid="10" grpId="0" animBg="1"/>
+      <p:bldP spid="11" grpId="0" animBg="1"/>
+      <p:bldP spid="12" grpId="0" animBg="1"/>
+      <p:bldP spid="13" grpId="0" animBg="1"/>
+      <p:bldP spid="14" grpId="0" animBg="1"/>
+      <p:bldP spid="15" grpId="0" animBg="1"/>
+      <p:bldP spid="16" grpId="0" animBg="1"/>
+      <p:bldP spid="17" grpId="0" animBg="1"/>
+      <p:bldP spid="18" grpId="0" animBg="1"/>
+      <p:bldP spid="19" grpId="0" animBg="1"/>
+      <p:bldP spid="20" grpId="0" animBg="1"/>
+      <p:bldP spid="21" grpId="0" animBg="1"/>
+      <p:bldP spid="22" grpId="0" animBg="1"/>
+      <p:bldP spid="23" grpId="0" animBg="1"/>
+      <p:bldP spid="24" grpId="0" animBg="1"/>
+      <p:bldP spid="25" grpId="0" animBg="1"/>
+      <p:bldP spid="26" grpId="0" animBg="1"/>
+    </p:bldLst>
+  </p:timing>
 </p:sld>
 </file>
 
@@ -14243,6 +17208,9 @@
   <p:clrMapOvr>
     <a:masterClrMapping/>
   </p:clrMapOvr>
+  <p:transition spd="med">
+    <p:fade/>
+  </p:transition>
 </p:sld>
 </file>
 

</xml_diff>

<commit_message>
Melhorias pós-feedback dos gerentes (branch de revisão)
Editor:
- Reordenar projetos e etapas arrastando (drag-and-drop) com preservação da seleção
- Numeração automática das etapas (o número segue a ordem; texto guarda só o nome)
- Campo 'link da pesquisa de mercado' por projeto -> chip clicável no slide
- Slide final 'Muito obrigada!'
- Etapas padrão atualizadas (13): +Compras (9), +Produção (11), Custo->Custo e
  preço de venda, Lançamento->Campanha de lançamento
- migrate() tira números antigos do texto e adiciona o campo de link (idempotente)

Modelo estático: mesmas etapas, numeração automática, chip de link, slide de
agradecimento e tabela com altura/fonte adaptativas (cabem 13 etapas).

editor/migra_dados.py: migra um .json antigo para o formato novo preservando
status, responsáveis e prazos.

Co-Authored-By: Claude Opus 4.8 <noreply@anthropic.com>
Claude-Session: https://claude.ai/code/session_01J4WuzLuPWbPdpadmrD14Gs
</commit_message>
<xml_diff>
--- a/apresentacao/Divine_Acompanhamento_Projetos_MODELO.pptx
+++ b/apresentacao/Divine_Acompanhamento_Projetos_MODELO.pptx
@@ -11,6 +11,7 @@
     <p:sldId id="259" r:id="rId10"/>
     <p:sldId id="260" r:id="rId11"/>
     <p:sldId id="261" r:id="rId12"/>
+    <p:sldId id="262" r:id="rId13"/>
   </p:sldIdLst>
   <p:sldSz cx="12191695" cy="6858000" type="screen4x3"/>
   <p:notesSz cx="6858000" cy="9144000"/>
@@ -4083,7 +4084,7 @@
             </a:avLst>
           </a:prstGeom>
           <a:solidFill>
-            <a:srgbClr val="E0A53A"/>
+            <a:srgbClr val="FBEFD3"/>
           </a:solidFill>
           <a:ln>
             <a:noFill/>
@@ -4112,11 +4113,11 @@
             <a:r>
               <a:rPr sz="1150" b="1">
                 <a:solidFill>
-                  <a:srgbClr val="2A1B12"/>
+                  <a:srgbClr val="9A6A12"/>
                 </a:solidFill>
                 <a:latin typeface="Segoe UI"/>
               </a:rPr>
-              <a:t>EM ANDAMENTO</a:t>
+              <a:t>EM TESTE</a:t>
             </a:r>
           </a:p>
         </p:txBody>
@@ -4174,7 +4175,7 @@
         <p:spPr>
           <a:xfrm>
             <a:off x="347472" y="982980"/>
-            <a:ext cx="8686800" cy="256032"/>
+            <a:ext cx="5303520" cy="256032"/>
           </a:xfrm>
           <a:prstGeom prst="rect">
             <a:avLst/>
@@ -4229,7 +4230,65 @@
       </p:sp>
       <p:sp>
         <p:nvSpPr>
-          <p:cNvPr id="13" name="TextBox 12"/>
+          <p:cNvPr id="13" name="Rounded Rectangle 12"/>
+          <p:cNvSpPr/>
+          <p:nvPr/>
+        </p:nvSpPr>
+        <p:spPr>
+          <a:xfrm>
+            <a:off x="5806440" y="955547"/>
+            <a:ext cx="3063240" cy="292608"/>
+          </a:xfrm>
+          <a:prstGeom prst="roundRect">
+            <a:avLst>
+              <a:gd name="adj" fmla="val 50000"/>
+            </a:avLst>
+          </a:prstGeom>
+          <a:solidFill>
+            <a:srgbClr val="FFFFFF"/>
+          </a:solidFill>
+          <a:ln w="9525">
+            <a:solidFill>
+              <a:srgbClr val="C9932E"/>
+            </a:solidFill>
+          </a:ln>
+          <a:effectLst/>
+        </p:spPr>
+        <p:style>
+          <a:lnRef idx="1">
+            <a:schemeClr val="accent1"/>
+          </a:lnRef>
+          <a:fillRef idx="3">
+            <a:schemeClr val="accent1"/>
+          </a:fillRef>
+          <a:effectRef idx="2">
+            <a:schemeClr val="accent1"/>
+          </a:effectRef>
+          <a:fontRef idx="minor">
+            <a:schemeClr val="lt1"/>
+          </a:fontRef>
+        </p:style>
+        <p:txBody>
+          <a:bodyPr rtlCol="0" anchor="ctr" lIns="36576" rIns="36576" tIns="0" bIns="0" wrap="none"/>
+          <a:lstStyle/>
+          <a:p>
+            <a:pPr algn="ctr"/>
+            <a:r>
+              <a:rPr sz="950" b="1">
+                <a:solidFill>
+                  <a:srgbClr val="3E2419"/>
+                </a:solidFill>
+                <a:latin typeface="Segoe UI"/>
+                <a:hlinkClick r:id="rId4"/>
+              </a:rPr>
+              <a:t>🔎  Pesquisa de mercado  ↗</a:t>
+            </a:r>
+          </a:p>
+        </p:txBody>
+      </p:sp>
+      <p:sp>
+        <p:nvSpPr>
+          <p:cNvPr id="14" name="TextBox 13"/>
           <p:cNvSpPr txBox="1"/>
           <p:nvPr/>
         </p:nvSpPr>
@@ -4264,7 +4323,7 @@
       </p:sp>
       <p:sp>
         <p:nvSpPr>
-          <p:cNvPr id="14" name="Rounded Rectangle 13"/>
+          <p:cNvPr id="15" name="Rounded Rectangle 14"/>
           <p:cNvSpPr/>
           <p:nvPr/>
         </p:nvSpPr>
@@ -4312,7 +4371,7 @@
       </p:sp>
       <p:sp>
         <p:nvSpPr>
-          <p:cNvPr id="15" name="TextBox 14"/>
+          <p:cNvPr id="16" name="TextBox 15"/>
           <p:cNvSpPr txBox="1"/>
           <p:nvPr/>
         </p:nvSpPr>
@@ -4347,7 +4406,7 @@
       </p:sp>
       <p:graphicFrame>
         <p:nvGraphicFramePr>
-          <p:cNvPr id="16" name="Table 15"/>
+          <p:cNvPr id="17" name="Table 16"/>
           <p:cNvGraphicFramePr>
             <a:graphicFrameLocks noGrp="1"/>
           </p:cNvGraphicFramePr>
@@ -4355,7 +4414,7 @@
         </p:nvGraphicFramePr>
         <p:xfrm>
           <a:off x="566928" y="1993392"/>
-          <a:ext cx="5504688" cy="4334248"/>
+          <a:ext cx="5504688" cy="4334256"/>
         </p:xfrm>
         <a:graphic>
           <a:graphicData uri="http://schemas.openxmlformats.org/drawingml/2006/table">
@@ -4463,7 +4522,7 @@
                   </a:tcPr>
                 </a:tc>
               </a:tr>
-              <a:tr h="404164">
+              <a:tr h="310896">
                 <a:tc>
                   <a:txBody>
                     <a:bodyPr/>
@@ -4471,7 +4530,7 @@
                     <a:p>
                       <a:pPr algn="l"/>
                       <a:r>
-                        <a:rPr sz="950" b="1">
+                        <a:rPr sz="850" b="1">
                           <a:solidFill>
                             <a:srgbClr val="3E2419"/>
                           </a:solidFill>
@@ -4517,7 +4576,7 @@
                     <a:p>
                       <a:pPr algn="l"/>
                       <a:r>
-                        <a:rPr sz="950" b="0">
+                        <a:rPr sz="850" b="0">
                           <a:solidFill>
                             <a:srgbClr val="5A3A2A"/>
                           </a:solidFill>
@@ -4540,13 +4599,13 @@
                     <a:p>
                       <a:pPr algn="ctr"/>
                       <a:r>
-                        <a:rPr sz="950" b="0">
+                        <a:rPr sz="850" b="0">
                           <a:solidFill>
                             <a:srgbClr val="5A3A2A"/>
                           </a:solidFill>
                           <a:latin typeface="Segoe UI"/>
                         </a:rPr>
-                        <a:t>20/06</a:t>
+                        <a:t>08/06</a:t>
                       </a:r>
                     </a:p>
                   </a:txBody>
@@ -4557,7 +4616,7 @@
                   </a:tcPr>
                 </a:tc>
               </a:tr>
-              <a:tr h="404164">
+              <a:tr h="310896">
                 <a:tc>
                   <a:txBody>
                     <a:bodyPr/>
@@ -4565,7 +4624,7 @@
                     <a:p>
                       <a:pPr algn="l"/>
                       <a:r>
-                        <a:rPr sz="950" b="1">
+                        <a:rPr sz="850" b="1">
                           <a:solidFill>
                             <a:srgbClr val="3E2419"/>
                           </a:solidFill>
@@ -4611,7 +4670,7 @@
                     <a:p>
                       <a:pPr algn="l"/>
                       <a:r>
-                        <a:rPr sz="950" b="0">
+                        <a:rPr sz="850" b="0">
                           <a:solidFill>
                             <a:srgbClr val="5A3A2A"/>
                           </a:solidFill>
@@ -4634,13 +4693,13 @@
                     <a:p>
                       <a:pPr algn="ctr"/>
                       <a:r>
-                        <a:rPr sz="950" b="0">
+                        <a:rPr sz="850" b="0">
                           <a:solidFill>
                             <a:srgbClr val="5A3A2A"/>
                           </a:solidFill>
                           <a:latin typeface="Segoe UI"/>
                         </a:rPr>
-                        <a:t>10/07</a:t>
+                        <a:t>24/07</a:t>
                       </a:r>
                     </a:p>
                   </a:txBody>
@@ -4651,7 +4710,7 @@
                   </a:tcPr>
                 </a:tc>
               </a:tr>
-              <a:tr h="404164">
+              <a:tr h="310896">
                 <a:tc>
                   <a:txBody>
                     <a:bodyPr/>
@@ -4659,13 +4718,13 @@
                     <a:p>
                       <a:pPr algn="l"/>
                       <a:r>
-                        <a:rPr sz="950" b="1">
+                        <a:rPr sz="850" b="1">
                           <a:solidFill>
                             <a:srgbClr val="3E2419"/>
                           </a:solidFill>
                           <a:latin typeface="Segoe UI"/>
                         </a:rPr>
-                        <a:t>3. Custo</a:t>
+                        <a:t>3. Custo e preço de venda</a:t>
                       </a:r>
                     </a:p>
                   </a:txBody>
@@ -4705,7 +4764,7 @@
                     <a:p>
                       <a:pPr algn="l"/>
                       <a:r>
-                        <a:rPr sz="950" b="0">
+                        <a:rPr sz="850" b="0">
                           <a:solidFill>
                             <a:srgbClr val="5A3A2A"/>
                           </a:solidFill>
@@ -4728,13 +4787,13 @@
                     <a:p>
                       <a:pPr algn="ctr"/>
                       <a:r>
-                        <a:rPr sz="950" b="0">
+                        <a:rPr sz="850" b="0">
                           <a:solidFill>
                             <a:srgbClr val="5A3A2A"/>
                           </a:solidFill>
                           <a:latin typeface="Segoe UI"/>
                         </a:rPr>
-                        <a:t>—</a:t>
+                        <a:t>24/07</a:t>
                       </a:r>
                     </a:p>
                   </a:txBody>
@@ -4745,7 +4804,7 @@
                   </a:tcPr>
                 </a:tc>
               </a:tr>
-              <a:tr h="404164">
+              <a:tr h="310896">
                 <a:tc>
                   <a:txBody>
                     <a:bodyPr/>
@@ -4753,13 +4812,13 @@
                     <a:p>
                       <a:pPr algn="l"/>
                       <a:r>
-                        <a:rPr sz="950" b="1">
+                        <a:rPr sz="850" b="1">
                           <a:solidFill>
                             <a:srgbClr val="3E2419"/>
                           </a:solidFill>
                           <a:latin typeface="Segoe UI"/>
                         </a:rPr>
-                        <a:t>4. Homologação</a:t>
+                        <a:t>4. Viabilidade produtiva/teste em linha</a:t>
                       </a:r>
                     </a:p>
                   </a:txBody>
@@ -4799,13 +4858,13 @@
                     <a:p>
                       <a:pPr algn="l"/>
                       <a:r>
-                        <a:rPr sz="950" b="0">
+                        <a:rPr sz="850" b="0">
                           <a:solidFill>
                             <a:srgbClr val="5A3A2A"/>
                           </a:solidFill>
                           <a:latin typeface="Segoe UI"/>
                         </a:rPr>
-                        <a:t>CQ</a:t>
+                        <a:t>Carla e Samuel</a:t>
                       </a:r>
                     </a:p>
                   </a:txBody>
@@ -4822,13 +4881,13 @@
                     <a:p>
                       <a:pPr algn="ctr"/>
                       <a:r>
-                        <a:rPr sz="950" b="0">
+                        <a:rPr sz="850" b="0">
                           <a:solidFill>
                             <a:srgbClr val="5A3A2A"/>
                           </a:solidFill>
                           <a:latin typeface="Segoe UI"/>
                         </a:rPr>
-                        <a:t>—</a:t>
+                        <a:t>03/08</a:t>
                       </a:r>
                     </a:p>
                   </a:txBody>
@@ -4839,7 +4898,7 @@
                   </a:tcPr>
                 </a:tc>
               </a:tr>
-              <a:tr h="404164">
+              <a:tr h="310896">
                 <a:tc>
                   <a:txBody>
                     <a:bodyPr/>
@@ -4847,13 +4906,13 @@
                     <a:p>
                       <a:pPr algn="l"/>
                       <a:r>
-                        <a:rPr sz="950" b="1">
+                        <a:rPr sz="850" b="1">
                           <a:solidFill>
                             <a:srgbClr val="3E2419"/>
                           </a:solidFill>
                           <a:latin typeface="Segoe UI"/>
                         </a:rPr>
-                        <a:t>5. Volume (comercial)</a:t>
+                        <a:t>5. Homologação</a:t>
                       </a:r>
                     </a:p>
                   </a:txBody>
@@ -4893,13 +4952,13 @@
                     <a:p>
                       <a:pPr algn="l"/>
                       <a:r>
-                        <a:rPr sz="950" b="0">
+                        <a:rPr sz="850" b="0">
                           <a:solidFill>
                             <a:srgbClr val="5A3A2A"/>
                           </a:solidFill>
                           <a:latin typeface="Segoe UI"/>
                         </a:rPr>
-                        <a:t>Mateus</a:t>
+                        <a:t>CQ</a:t>
                       </a:r>
                     </a:p>
                   </a:txBody>
@@ -4916,13 +4975,13 @@
                     <a:p>
                       <a:pPr algn="ctr"/>
                       <a:r>
-                        <a:rPr sz="950" b="0">
+                        <a:rPr sz="850" b="0">
                           <a:solidFill>
                             <a:srgbClr val="5A3A2A"/>
                           </a:solidFill>
                           <a:latin typeface="Segoe UI"/>
                         </a:rPr>
-                        <a:t>—</a:t>
+                        <a:t>17/07</a:t>
                       </a:r>
                     </a:p>
                   </a:txBody>
@@ -4933,7 +4992,7 @@
                   </a:tcPr>
                 </a:tc>
               </a:tr>
-              <a:tr h="404164">
+              <a:tr h="310896">
                 <a:tc>
                   <a:txBody>
                     <a:bodyPr/>
@@ -4941,13 +5000,13 @@
                     <a:p>
                       <a:pPr algn="l"/>
                       <a:r>
-                        <a:rPr sz="950" b="1">
+                        <a:rPr sz="850" b="1">
                           <a:solidFill>
                             <a:srgbClr val="3E2419"/>
                           </a:solidFill>
                           <a:latin typeface="Segoe UI"/>
                         </a:rPr>
-                        <a:t>6. Engenharias e FTs</a:t>
+                        <a:t>6. Volume (comercial)</a:t>
                       </a:r>
                     </a:p>
                   </a:txBody>
@@ -4987,13 +5046,13 @@
                     <a:p>
                       <a:pPr algn="l"/>
                       <a:r>
-                        <a:rPr sz="950" b="0">
+                        <a:rPr sz="850" b="0">
                           <a:solidFill>
                             <a:srgbClr val="5A3A2A"/>
                           </a:solidFill>
                           <a:latin typeface="Segoe UI"/>
                         </a:rPr>
-                        <a:t>P&amp;D</a:t>
+                        <a:t>Mateus</a:t>
                       </a:r>
                     </a:p>
                   </a:txBody>
@@ -5010,13 +5069,13 @@
                     <a:p>
                       <a:pPr algn="ctr"/>
                       <a:r>
-                        <a:rPr sz="950" b="0">
+                        <a:rPr sz="850" b="0">
                           <a:solidFill>
                             <a:srgbClr val="5A3A2A"/>
                           </a:solidFill>
                           <a:latin typeface="Segoe UI"/>
                         </a:rPr>
-                        <a:t>15/07</a:t>
+                        <a:t>—</a:t>
                       </a:r>
                     </a:p>
                   </a:txBody>
@@ -5027,7 +5086,7 @@
                   </a:tcPr>
                 </a:tc>
               </a:tr>
-              <a:tr h="404164">
+              <a:tr h="310896">
                 <a:tc>
                   <a:txBody>
                     <a:bodyPr/>
@@ -5035,13 +5094,13 @@
                     <a:p>
                       <a:pPr algn="l"/>
                       <a:r>
-                        <a:rPr sz="950" b="1">
+                        <a:rPr sz="850" b="1">
                           <a:solidFill>
                             <a:srgbClr val="3E2419"/>
                           </a:solidFill>
                           <a:latin typeface="Segoe UI"/>
                         </a:rPr>
-                        <a:t>7. Criação da arte e etiquetas</a:t>
+                        <a:t>7. Engenharias e FTs</a:t>
                       </a:r>
                     </a:p>
                   </a:txBody>
@@ -5081,13 +5140,13 @@
                     <a:p>
                       <a:pPr algn="l"/>
                       <a:r>
-                        <a:rPr sz="950" b="0">
+                        <a:rPr sz="850" b="0">
                           <a:solidFill>
                             <a:srgbClr val="5A3A2A"/>
                           </a:solidFill>
                           <a:latin typeface="Segoe UI"/>
                         </a:rPr>
-                        <a:t>Marketing</a:t>
+                        <a:t>P&amp;D</a:t>
                       </a:r>
                     </a:p>
                   </a:txBody>
@@ -5104,13 +5163,13 @@
                     <a:p>
                       <a:pPr algn="ctr"/>
                       <a:r>
-                        <a:rPr sz="950" b="0">
+                        <a:rPr sz="850" b="0">
                           <a:solidFill>
                             <a:srgbClr val="5A3A2A"/>
                           </a:solidFill>
                           <a:latin typeface="Segoe UI"/>
                         </a:rPr>
-                        <a:t>—</a:t>
+                        <a:t>24/07</a:t>
                       </a:r>
                     </a:p>
                   </a:txBody>
@@ -5121,7 +5180,7 @@
                   </a:tcPr>
                 </a:tc>
               </a:tr>
-              <a:tr h="404164">
+              <a:tr h="310896">
                 <a:tc>
                   <a:txBody>
                     <a:bodyPr/>
@@ -5129,13 +5188,13 @@
                     <a:p>
                       <a:pPr algn="l"/>
                       <a:r>
-                        <a:rPr sz="950" b="1">
+                        <a:rPr sz="850" b="1">
                           <a:solidFill>
                             <a:srgbClr val="3E2419"/>
                           </a:solidFill>
                           <a:latin typeface="Segoe UI"/>
                         </a:rPr>
-                        <a:t>8. Tabela comercial</a:t>
+                        <a:t>8. Criação da arte e etiquetas</a:t>
                       </a:r>
                     </a:p>
                   </a:txBody>
@@ -5175,13 +5234,13 @@
                     <a:p>
                       <a:pPr algn="l"/>
                       <a:r>
-                        <a:rPr sz="950" b="0">
+                        <a:rPr sz="850" b="0">
                           <a:solidFill>
                             <a:srgbClr val="5A3A2A"/>
                           </a:solidFill>
                           <a:latin typeface="Segoe UI"/>
                         </a:rPr>
-                        <a:t>P&amp;D</a:t>
+                        <a:t>Marketing</a:t>
                       </a:r>
                     </a:p>
                   </a:txBody>
@@ -5198,13 +5257,13 @@
                     <a:p>
                       <a:pPr algn="ctr"/>
                       <a:r>
-                        <a:rPr sz="950" b="0">
+                        <a:rPr sz="850" b="0">
                           <a:solidFill>
                             <a:srgbClr val="5A3A2A"/>
                           </a:solidFill>
                           <a:latin typeface="Segoe UI"/>
                         </a:rPr>
-                        <a:t>—</a:t>
+                        <a:t>24/07</a:t>
                       </a:r>
                     </a:p>
                   </a:txBody>
@@ -5215,7 +5274,7 @@
                   </a:tcPr>
                 </a:tc>
               </a:tr>
-              <a:tr h="404164">
+              <a:tr h="310896">
                 <a:tc>
                   <a:txBody>
                     <a:bodyPr/>
@@ -5223,13 +5282,13 @@
                     <a:p>
                       <a:pPr algn="l"/>
                       <a:r>
-                        <a:rPr sz="950" b="1">
+                        <a:rPr sz="850" b="1">
                           <a:solidFill>
                             <a:srgbClr val="3E2419"/>
                           </a:solidFill>
                           <a:latin typeface="Segoe UI"/>
                         </a:rPr>
-                        <a:t>9. Comunicado vendedores</a:t>
+                        <a:t>9. Compras</a:t>
                       </a:r>
                     </a:p>
                   </a:txBody>
@@ -5269,13 +5328,13 @@
                     <a:p>
                       <a:pPr algn="l"/>
                       <a:r>
-                        <a:rPr sz="950" b="0">
+                        <a:rPr sz="850" b="0">
                           <a:solidFill>
                             <a:srgbClr val="5A3A2A"/>
                           </a:solidFill>
                           <a:latin typeface="Segoe UI"/>
                         </a:rPr>
-                        <a:t>Marketing</a:t>
+                        <a:t>—</a:t>
                       </a:r>
                     </a:p>
                   </a:txBody>
@@ -5292,7 +5351,7 @@
                     <a:p>
                       <a:pPr algn="ctr"/>
                       <a:r>
-                        <a:rPr sz="950" b="0">
+                        <a:rPr sz="850" b="0">
                           <a:solidFill>
                             <a:srgbClr val="5A3A2A"/>
                           </a:solidFill>
@@ -5309,7 +5368,7 @@
                   </a:tcPr>
                 </a:tc>
               </a:tr>
-              <a:tr h="404164">
+              <a:tr h="310896">
                 <a:tc>
                   <a:txBody>
                     <a:bodyPr/>
@@ -5317,13 +5376,13 @@
                     <a:p>
                       <a:pPr algn="l"/>
                       <a:r>
-                        <a:rPr sz="950" b="1">
+                        <a:rPr sz="850" b="1">
                           <a:solidFill>
                             <a:srgbClr val="3E2419"/>
                           </a:solidFill>
                           <a:latin typeface="Segoe UI"/>
                         </a:rPr>
-                        <a:t>10. Lançamento</a:t>
+                        <a:t>10. Tabela comercial</a:t>
                       </a:r>
                     </a:p>
                   </a:txBody>
@@ -5363,7 +5422,195 @@
                     <a:p>
                       <a:pPr algn="l"/>
                       <a:r>
-                        <a:rPr sz="950" b="0">
+                        <a:rPr sz="850" b="0">
+                          <a:solidFill>
+                            <a:srgbClr val="5A3A2A"/>
+                          </a:solidFill>
+                          <a:latin typeface="Segoe UI"/>
+                        </a:rPr>
+                        <a:t>P&amp;D</a:t>
+                      </a:r>
+                    </a:p>
+                  </a:txBody>
+                  <a:tcPr anchor="ctr" marL="64008" marR="27432" marT="9144" marB="9144">
+                    <a:solidFill>
+                      <a:srgbClr val="F9F3E4"/>
+                    </a:solidFill>
+                  </a:tcPr>
+                </a:tc>
+                <a:tc>
+                  <a:txBody>
+                    <a:bodyPr/>
+                    <a:lstStyle/>
+                    <a:p>
+                      <a:pPr algn="ctr"/>
+                      <a:r>
+                        <a:rPr sz="850" b="0">
+                          <a:solidFill>
+                            <a:srgbClr val="5A3A2A"/>
+                          </a:solidFill>
+                          <a:latin typeface="Segoe UI"/>
+                        </a:rPr>
+                        <a:t>17/07</a:t>
+                      </a:r>
+                    </a:p>
+                  </a:txBody>
+                  <a:tcPr anchor="ctr" marL="64008" marR="27432" marT="9144" marB="9144">
+                    <a:solidFill>
+                      <a:srgbClr val="F9F3E4"/>
+                    </a:solidFill>
+                  </a:tcPr>
+                </a:tc>
+              </a:tr>
+              <a:tr h="310896">
+                <a:tc>
+                  <a:txBody>
+                    <a:bodyPr/>
+                    <a:lstStyle/>
+                    <a:p>
+                      <a:pPr algn="l"/>
+                      <a:r>
+                        <a:rPr sz="850" b="1">
+                          <a:solidFill>
+                            <a:srgbClr val="3E2419"/>
+                          </a:solidFill>
+                          <a:latin typeface="Segoe UI"/>
+                        </a:rPr>
+                        <a:t>11. Produção</a:t>
+                      </a:r>
+                    </a:p>
+                  </a:txBody>
+                  <a:tcPr anchor="ctr" marL="64008" marR="27432" marT="9144" marB="9144">
+                    <a:solidFill>
+                      <a:srgbClr val="FFFFFF"/>
+                    </a:solidFill>
+                  </a:tcPr>
+                </a:tc>
+                <a:tc>
+                  <a:txBody>
+                    <a:bodyPr/>
+                    <a:lstStyle/>
+                    <a:p>
+                      <a:pPr algn="ctr"/>
+                      <a:r>
+                        <a:rPr sz="900" b="0">
+                          <a:solidFill>
+                            <a:srgbClr val="3E2419"/>
+                          </a:solidFill>
+                          <a:latin typeface="Segoe UI"/>
+                        </a:rPr>
+                        <a:t/>
+                      </a:r>
+                    </a:p>
+                  </a:txBody>
+                  <a:tcPr anchor="ctr" marL="64008" marR="27432" marT="9144" marB="9144">
+                    <a:solidFill>
+                      <a:srgbClr val="FFFFFF"/>
+                    </a:solidFill>
+                  </a:tcPr>
+                </a:tc>
+                <a:tc>
+                  <a:txBody>
+                    <a:bodyPr/>
+                    <a:lstStyle/>
+                    <a:p>
+                      <a:pPr algn="l"/>
+                      <a:r>
+                        <a:rPr sz="850" b="0">
+                          <a:solidFill>
+                            <a:srgbClr val="5A3A2A"/>
+                          </a:solidFill>
+                          <a:latin typeface="Segoe UI"/>
+                        </a:rPr>
+                        <a:t>—</a:t>
+                      </a:r>
+                    </a:p>
+                  </a:txBody>
+                  <a:tcPr anchor="ctr" marL="64008" marR="27432" marT="9144" marB="9144">
+                    <a:solidFill>
+                      <a:srgbClr val="FFFFFF"/>
+                    </a:solidFill>
+                  </a:tcPr>
+                </a:tc>
+                <a:tc>
+                  <a:txBody>
+                    <a:bodyPr/>
+                    <a:lstStyle/>
+                    <a:p>
+                      <a:pPr algn="ctr"/>
+                      <a:r>
+                        <a:rPr sz="850" b="0">
+                          <a:solidFill>
+                            <a:srgbClr val="5A3A2A"/>
+                          </a:solidFill>
+                          <a:latin typeface="Segoe UI"/>
+                        </a:rPr>
+                        <a:t>—</a:t>
+                      </a:r>
+                    </a:p>
+                  </a:txBody>
+                  <a:tcPr anchor="ctr" marL="64008" marR="27432" marT="9144" marB="9144">
+                    <a:solidFill>
+                      <a:srgbClr val="FFFFFF"/>
+                    </a:solidFill>
+                  </a:tcPr>
+                </a:tc>
+              </a:tr>
+              <a:tr h="310896">
+                <a:tc>
+                  <a:txBody>
+                    <a:bodyPr/>
+                    <a:lstStyle/>
+                    <a:p>
+                      <a:pPr algn="l"/>
+                      <a:r>
+                        <a:rPr sz="850" b="1">
+                          <a:solidFill>
+                            <a:srgbClr val="3E2419"/>
+                          </a:solidFill>
+                          <a:latin typeface="Segoe UI"/>
+                        </a:rPr>
+                        <a:t>12. Comunicado vendedores</a:t>
+                      </a:r>
+                    </a:p>
+                  </a:txBody>
+                  <a:tcPr anchor="ctr" marL="64008" marR="27432" marT="9144" marB="9144">
+                    <a:solidFill>
+                      <a:srgbClr val="F9F3E4"/>
+                    </a:solidFill>
+                  </a:tcPr>
+                </a:tc>
+                <a:tc>
+                  <a:txBody>
+                    <a:bodyPr/>
+                    <a:lstStyle/>
+                    <a:p>
+                      <a:pPr algn="ctr"/>
+                      <a:r>
+                        <a:rPr sz="900" b="0">
+                          <a:solidFill>
+                            <a:srgbClr val="3E2419"/>
+                          </a:solidFill>
+                          <a:latin typeface="Segoe UI"/>
+                        </a:rPr>
+                        <a:t/>
+                      </a:r>
+                    </a:p>
+                  </a:txBody>
+                  <a:tcPr anchor="ctr" marL="64008" marR="27432" marT="9144" marB="9144">
+                    <a:solidFill>
+                      <a:srgbClr val="F9F3E4"/>
+                    </a:solidFill>
+                  </a:tcPr>
+                </a:tc>
+                <a:tc>
+                  <a:txBody>
+                    <a:bodyPr/>
+                    <a:lstStyle/>
+                    <a:p>
+                      <a:pPr algn="l"/>
+                      <a:r>
+                        <a:rPr sz="850" b="0">
                           <a:solidFill>
                             <a:srgbClr val="5A3A2A"/>
                           </a:solidFill>
@@ -5386,7 +5633,7 @@
                     <a:p>
                       <a:pPr algn="ctr"/>
                       <a:r>
-                        <a:rPr sz="950" b="0">
+                        <a:rPr sz="850" b="0">
                           <a:solidFill>
                             <a:srgbClr val="5A3A2A"/>
                           </a:solidFill>
@@ -5403,19 +5650,113 @@
                   </a:tcPr>
                 </a:tc>
               </a:tr>
+              <a:tr h="310896">
+                <a:tc>
+                  <a:txBody>
+                    <a:bodyPr/>
+                    <a:lstStyle/>
+                    <a:p>
+                      <a:pPr algn="l"/>
+                      <a:r>
+                        <a:rPr sz="850" b="1">
+                          <a:solidFill>
+                            <a:srgbClr val="3E2419"/>
+                          </a:solidFill>
+                          <a:latin typeface="Segoe UI"/>
+                        </a:rPr>
+                        <a:t>13. Campanha de lançamento</a:t>
+                      </a:r>
+                    </a:p>
+                  </a:txBody>
+                  <a:tcPr anchor="ctr" marL="64008" marR="27432" marT="9144" marB="9144">
+                    <a:solidFill>
+                      <a:srgbClr val="FFFFFF"/>
+                    </a:solidFill>
+                  </a:tcPr>
+                </a:tc>
+                <a:tc>
+                  <a:txBody>
+                    <a:bodyPr/>
+                    <a:lstStyle/>
+                    <a:p>
+                      <a:pPr algn="ctr"/>
+                      <a:r>
+                        <a:rPr sz="900" b="0">
+                          <a:solidFill>
+                            <a:srgbClr val="3E2419"/>
+                          </a:solidFill>
+                          <a:latin typeface="Segoe UI"/>
+                        </a:rPr>
+                        <a:t/>
+                      </a:r>
+                    </a:p>
+                  </a:txBody>
+                  <a:tcPr anchor="ctr" marL="64008" marR="27432" marT="9144" marB="9144">
+                    <a:solidFill>
+                      <a:srgbClr val="FFFFFF"/>
+                    </a:solidFill>
+                  </a:tcPr>
+                </a:tc>
+                <a:tc>
+                  <a:txBody>
+                    <a:bodyPr/>
+                    <a:lstStyle/>
+                    <a:p>
+                      <a:pPr algn="l"/>
+                      <a:r>
+                        <a:rPr sz="850" b="0">
+                          <a:solidFill>
+                            <a:srgbClr val="5A3A2A"/>
+                          </a:solidFill>
+                          <a:latin typeface="Segoe UI"/>
+                        </a:rPr>
+                        <a:t>Marketing</a:t>
+                      </a:r>
+                    </a:p>
+                  </a:txBody>
+                  <a:tcPr anchor="ctr" marL="64008" marR="27432" marT="9144" marB="9144">
+                    <a:solidFill>
+                      <a:srgbClr val="FFFFFF"/>
+                    </a:solidFill>
+                  </a:tcPr>
+                </a:tc>
+                <a:tc>
+                  <a:txBody>
+                    <a:bodyPr/>
+                    <a:lstStyle/>
+                    <a:p>
+                      <a:pPr algn="ctr"/>
+                      <a:r>
+                        <a:rPr sz="850" b="0">
+                          <a:solidFill>
+                            <a:srgbClr val="5A3A2A"/>
+                          </a:solidFill>
+                          <a:latin typeface="Segoe UI"/>
+                        </a:rPr>
+                        <a:t>—</a:t>
+                      </a:r>
+                    </a:p>
+                  </a:txBody>
+                  <a:tcPr anchor="ctr" marL="64008" marR="27432" marT="9144" marB="9144">
+                    <a:solidFill>
+                      <a:srgbClr val="FFFFFF"/>
+                    </a:solidFill>
+                  </a:tcPr>
+                </a:tc>
+              </a:tr>
             </a:tbl>
           </a:graphicData>
         </a:graphic>
       </p:graphicFrame>
       <p:sp>
         <p:nvSpPr>
-          <p:cNvPr id="17" name="Oval 16"/>
+          <p:cNvPr id="18" name="Oval 17"/>
           <p:cNvSpPr/>
           <p:nvPr/>
         </p:nvSpPr>
         <p:spPr>
           <a:xfrm>
-            <a:off x="3394710" y="2380640"/>
+            <a:off x="3394710" y="2334006"/>
             <a:ext cx="214884" cy="214884"/>
           </a:xfrm>
           <a:prstGeom prst="ellipse">
@@ -5462,13 +5803,13 @@
       </p:sp>
       <p:sp>
         <p:nvSpPr>
-          <p:cNvPr id="18" name="Oval 17"/>
+          <p:cNvPr id="19" name="Oval 18"/>
           <p:cNvSpPr/>
           <p:nvPr/>
         </p:nvSpPr>
         <p:spPr>
           <a:xfrm>
-            <a:off x="3394710" y="2784805"/>
+            <a:off x="3394710" y="2644901"/>
             <a:ext cx="214884" cy="214884"/>
           </a:xfrm>
           <a:prstGeom prst="ellipse">
@@ -5506,13 +5847,163 @@
       </p:sp>
       <p:sp>
         <p:nvSpPr>
-          <p:cNvPr id="19" name="Oval 18"/>
+          <p:cNvPr id="20" name="Oval 19"/>
           <p:cNvSpPr/>
           <p:nvPr/>
         </p:nvSpPr>
         <p:spPr>
           <a:xfrm>
-            <a:off x="3394710" y="3188970"/>
+            <a:off x="3394710" y="2955797"/>
+            <a:ext cx="214884" cy="214884"/>
+          </a:xfrm>
+          <a:prstGeom prst="ellipse">
+            <a:avLst/>
+          </a:prstGeom>
+          <a:solidFill>
+            <a:srgbClr val="E0A53A"/>
+          </a:solidFill>
+          <a:ln>
+            <a:noFill/>
+          </a:ln>
+          <a:effectLst/>
+        </p:spPr>
+        <p:style>
+          <a:lnRef idx="1">
+            <a:schemeClr val="accent1"/>
+          </a:lnRef>
+          <a:fillRef idx="3">
+            <a:schemeClr val="accent1"/>
+          </a:fillRef>
+          <a:effectRef idx="2">
+            <a:schemeClr val="accent1"/>
+          </a:effectRef>
+          <a:fontRef idx="minor">
+            <a:schemeClr val="lt1"/>
+          </a:fontRef>
+        </p:style>
+        <p:txBody>
+          <a:bodyPr rtlCol="0" anchor="ctr"/>
+          <a:lstStyle/>
+          <a:p>
+            <a:pPr algn="ctr"/>
+          </a:p>
+        </p:txBody>
+      </p:sp>
+      <p:sp>
+        <p:nvSpPr>
+          <p:cNvPr id="21" name="Oval 20"/>
+          <p:cNvSpPr/>
+          <p:nvPr/>
+        </p:nvSpPr>
+        <p:spPr>
+          <a:xfrm>
+            <a:off x="3394710" y="3266694"/>
+            <a:ext cx="214884" cy="214884"/>
+          </a:xfrm>
+          <a:prstGeom prst="ellipse">
+            <a:avLst/>
+          </a:prstGeom>
+          <a:solidFill>
+            <a:srgbClr val="C0392F"/>
+          </a:solidFill>
+          <a:ln>
+            <a:noFill/>
+          </a:ln>
+          <a:effectLst/>
+        </p:spPr>
+        <p:style>
+          <a:lnRef idx="1">
+            <a:schemeClr val="accent1"/>
+          </a:lnRef>
+          <a:fillRef idx="3">
+            <a:schemeClr val="accent1"/>
+          </a:fillRef>
+          <a:effectRef idx="2">
+            <a:schemeClr val="accent1"/>
+          </a:effectRef>
+          <a:fontRef idx="minor">
+            <a:schemeClr val="lt1"/>
+          </a:fontRef>
+        </p:style>
+        <p:txBody>
+          <a:bodyPr rtlCol="0" anchor="ctr" lIns="0" rIns="0" tIns="0" bIns="0"/>
+          <a:lstStyle/>
+          <a:p>
+            <a:pPr algn="ctr"/>
+            <a:r>
+              <a:rPr sz="1100" b="1">
+                <a:solidFill>
+                  <a:srgbClr val="FFFFFF"/>
+                </a:solidFill>
+                <a:latin typeface="Segoe UI"/>
+              </a:rPr>
+              <a:t>!</a:t>
+            </a:r>
+          </a:p>
+        </p:txBody>
+      </p:sp>
+      <p:sp>
+        <p:nvSpPr>
+          <p:cNvPr id="22" name="Oval 21"/>
+          <p:cNvSpPr/>
+          <p:nvPr/>
+        </p:nvSpPr>
+        <p:spPr>
+          <a:xfrm>
+            <a:off x="3394710" y="3577590"/>
+            <a:ext cx="214884" cy="214884"/>
+          </a:xfrm>
+          <a:prstGeom prst="ellipse">
+            <a:avLst/>
+          </a:prstGeom>
+          <a:solidFill>
+            <a:srgbClr val="43A047"/>
+          </a:solidFill>
+          <a:ln>
+            <a:noFill/>
+          </a:ln>
+          <a:effectLst/>
+        </p:spPr>
+        <p:style>
+          <a:lnRef idx="1">
+            <a:schemeClr val="accent1"/>
+          </a:lnRef>
+          <a:fillRef idx="3">
+            <a:schemeClr val="accent1"/>
+          </a:fillRef>
+          <a:effectRef idx="2">
+            <a:schemeClr val="accent1"/>
+          </a:effectRef>
+          <a:fontRef idx="minor">
+            <a:schemeClr val="lt1"/>
+          </a:fontRef>
+        </p:style>
+        <p:txBody>
+          <a:bodyPr rtlCol="0" anchor="ctr" lIns="0" rIns="0" tIns="0" bIns="0"/>
+          <a:lstStyle/>
+          <a:p>
+            <a:pPr algn="ctr"/>
+            <a:r>
+              <a:rPr sz="1100" b="1">
+                <a:solidFill>
+                  <a:srgbClr val="FFFFFF"/>
+                </a:solidFill>
+                <a:latin typeface="Segoe UI"/>
+              </a:rPr>
+              <a:t>✓</a:t>
+            </a:r>
+          </a:p>
+        </p:txBody>
+      </p:sp>
+      <p:sp>
+        <p:nvSpPr>
+          <p:cNvPr id="23" name="Oval 22"/>
+          <p:cNvSpPr/>
+          <p:nvPr/>
+        </p:nvSpPr>
+        <p:spPr>
+          <a:xfrm>
+            <a:off x="3394710" y="3888485"/>
             <a:ext cx="214884" cy="214884"/>
           </a:xfrm>
           <a:prstGeom prst="ellipse">
@@ -5552,13 +6043,110 @@
       </p:sp>
       <p:sp>
         <p:nvSpPr>
-          <p:cNvPr id="20" name="Oval 19"/>
+          <p:cNvPr id="24" name="Oval 23"/>
           <p:cNvSpPr/>
           <p:nvPr/>
         </p:nvSpPr>
         <p:spPr>
           <a:xfrm>
-            <a:off x="3394710" y="3593134"/>
+            <a:off x="3394710" y="4199382"/>
+            <a:ext cx="214884" cy="214884"/>
+          </a:xfrm>
+          <a:prstGeom prst="ellipse">
+            <a:avLst/>
+          </a:prstGeom>
+          <a:solidFill>
+            <a:srgbClr val="E0A53A"/>
+          </a:solidFill>
+          <a:ln>
+            <a:noFill/>
+          </a:ln>
+          <a:effectLst/>
+        </p:spPr>
+        <p:style>
+          <a:lnRef idx="1">
+            <a:schemeClr val="accent1"/>
+          </a:lnRef>
+          <a:fillRef idx="3">
+            <a:schemeClr val="accent1"/>
+          </a:fillRef>
+          <a:effectRef idx="2">
+            <a:schemeClr val="accent1"/>
+          </a:effectRef>
+          <a:fontRef idx="minor">
+            <a:schemeClr val="lt1"/>
+          </a:fontRef>
+        </p:style>
+        <p:txBody>
+          <a:bodyPr rtlCol="0" anchor="ctr"/>
+          <a:lstStyle/>
+          <a:p>
+            <a:pPr algn="ctr"/>
+          </a:p>
+        </p:txBody>
+      </p:sp>
+      <p:sp>
+        <p:nvSpPr>
+          <p:cNvPr id="25" name="Oval 24"/>
+          <p:cNvSpPr/>
+          <p:nvPr/>
+        </p:nvSpPr>
+        <p:spPr>
+          <a:xfrm>
+            <a:off x="3394710" y="4510278"/>
+            <a:ext cx="214884" cy="214884"/>
+          </a:xfrm>
+          <a:prstGeom prst="ellipse">
+            <a:avLst/>
+          </a:prstGeom>
+          <a:solidFill>
+            <a:srgbClr val="43A047"/>
+          </a:solidFill>
+          <a:ln>
+            <a:noFill/>
+          </a:ln>
+          <a:effectLst/>
+        </p:spPr>
+        <p:style>
+          <a:lnRef idx="1">
+            <a:schemeClr val="accent1"/>
+          </a:lnRef>
+          <a:fillRef idx="3">
+            <a:schemeClr val="accent1"/>
+          </a:fillRef>
+          <a:effectRef idx="2">
+            <a:schemeClr val="accent1"/>
+          </a:effectRef>
+          <a:fontRef idx="minor">
+            <a:schemeClr val="lt1"/>
+          </a:fontRef>
+        </p:style>
+        <p:txBody>
+          <a:bodyPr rtlCol="0" anchor="ctr" lIns="0" rIns="0" tIns="0" bIns="0"/>
+          <a:lstStyle/>
+          <a:p>
+            <a:pPr algn="ctr"/>
+            <a:r>
+              <a:rPr sz="1100" b="1">
+                <a:solidFill>
+                  <a:srgbClr val="FFFFFF"/>
+                </a:solidFill>
+                <a:latin typeface="Segoe UI"/>
+              </a:rPr>
+              <a:t>✓</a:t>
+            </a:r>
+          </a:p>
+        </p:txBody>
+      </p:sp>
+      <p:sp>
+        <p:nvSpPr>
+          <p:cNvPr id="26" name="Oval 25"/>
+          <p:cNvSpPr/>
+          <p:nvPr/>
+        </p:nvSpPr>
+        <p:spPr>
+          <a:xfrm>
+            <a:off x="3394710" y="4821174"/>
             <a:ext cx="214884" cy="214884"/>
           </a:xfrm>
           <a:prstGeom prst="ellipse">
@@ -5598,13 +6186,57 @@
       </p:sp>
       <p:sp>
         <p:nvSpPr>
-          <p:cNvPr id="21" name="Oval 20"/>
+          <p:cNvPr id="27" name="Oval 26"/>
           <p:cNvSpPr/>
           <p:nvPr/>
         </p:nvSpPr>
         <p:spPr>
           <a:xfrm>
-            <a:off x="3394710" y="3997299"/>
+            <a:off x="3394710" y="5132070"/>
+            <a:ext cx="214884" cy="214884"/>
+          </a:xfrm>
+          <a:prstGeom prst="ellipse">
+            <a:avLst/>
+          </a:prstGeom>
+          <a:solidFill>
+            <a:srgbClr val="E0A53A"/>
+          </a:solidFill>
+          <a:ln>
+            <a:noFill/>
+          </a:ln>
+          <a:effectLst/>
+        </p:spPr>
+        <p:style>
+          <a:lnRef idx="1">
+            <a:schemeClr val="accent1"/>
+          </a:lnRef>
+          <a:fillRef idx="3">
+            <a:schemeClr val="accent1"/>
+          </a:fillRef>
+          <a:effectRef idx="2">
+            <a:schemeClr val="accent1"/>
+          </a:effectRef>
+          <a:fontRef idx="minor">
+            <a:schemeClr val="lt1"/>
+          </a:fontRef>
+        </p:style>
+        <p:txBody>
+          <a:bodyPr rtlCol="0" anchor="ctr"/>
+          <a:lstStyle/>
+          <a:p>
+            <a:pPr algn="ctr"/>
+          </a:p>
+        </p:txBody>
+      </p:sp>
+      <p:sp>
+        <p:nvSpPr>
+          <p:cNvPr id="28" name="Oval 27"/>
+          <p:cNvSpPr/>
+          <p:nvPr/>
+        </p:nvSpPr>
+        <p:spPr>
+          <a:xfrm>
+            <a:off x="3394710" y="5442966"/>
             <a:ext cx="214884" cy="214884"/>
           </a:xfrm>
           <a:prstGeom prst="ellipse">
@@ -5644,57 +6276,13 @@
       </p:sp>
       <p:sp>
         <p:nvSpPr>
-          <p:cNvPr id="22" name="Oval 21"/>
+          <p:cNvPr id="29" name="Oval 28"/>
           <p:cNvSpPr/>
           <p:nvPr/>
         </p:nvSpPr>
         <p:spPr>
           <a:xfrm>
-            <a:off x="3394710" y="4401464"/>
-            <a:ext cx="214884" cy="214884"/>
-          </a:xfrm>
-          <a:prstGeom prst="ellipse">
-            <a:avLst/>
-          </a:prstGeom>
-          <a:solidFill>
-            <a:srgbClr val="E0A53A"/>
-          </a:solidFill>
-          <a:ln>
-            <a:noFill/>
-          </a:ln>
-          <a:effectLst/>
-        </p:spPr>
-        <p:style>
-          <a:lnRef idx="1">
-            <a:schemeClr val="accent1"/>
-          </a:lnRef>
-          <a:fillRef idx="3">
-            <a:schemeClr val="accent1"/>
-          </a:fillRef>
-          <a:effectRef idx="2">
-            <a:schemeClr val="accent1"/>
-          </a:effectRef>
-          <a:fontRef idx="minor">
-            <a:schemeClr val="lt1"/>
-          </a:fontRef>
-        </p:style>
-        <p:txBody>
-          <a:bodyPr rtlCol="0" anchor="ctr"/>
-          <a:lstStyle/>
-          <a:p>
-            <a:pPr algn="ctr"/>
-          </a:p>
-        </p:txBody>
-      </p:sp>
-      <p:sp>
-        <p:nvSpPr>
-          <p:cNvPr id="23" name="Oval 22"/>
-          <p:cNvSpPr/>
-          <p:nvPr/>
-        </p:nvSpPr>
-        <p:spPr>
-          <a:xfrm>
-            <a:off x="3394710" y="4805629"/>
+            <a:off x="3394710" y="5753862"/>
             <a:ext cx="214884" cy="214884"/>
           </a:xfrm>
           <a:prstGeom prst="ellipse">
@@ -5734,13 +6322,13 @@
       </p:sp>
       <p:sp>
         <p:nvSpPr>
-          <p:cNvPr id="24" name="Oval 23"/>
+          <p:cNvPr id="30" name="Oval 29"/>
           <p:cNvSpPr/>
           <p:nvPr/>
         </p:nvSpPr>
         <p:spPr>
           <a:xfrm>
-            <a:off x="3394710" y="5209794"/>
+            <a:off x="3394710" y="6064758"/>
             <a:ext cx="214884" cy="214884"/>
           </a:xfrm>
           <a:prstGeom prst="ellipse">
@@ -5780,99 +6368,7 @@
       </p:sp>
       <p:sp>
         <p:nvSpPr>
-          <p:cNvPr id="25" name="Oval 24"/>
-          <p:cNvSpPr/>
-          <p:nvPr/>
-        </p:nvSpPr>
-        <p:spPr>
-          <a:xfrm>
-            <a:off x="3394710" y="5613958"/>
-            <a:ext cx="214884" cy="214884"/>
-          </a:xfrm>
-          <a:prstGeom prst="ellipse">
-            <a:avLst/>
-          </a:prstGeom>
-          <a:solidFill>
-            <a:srgbClr val="FFFFFF"/>
-          </a:solidFill>
-          <a:ln w="19050">
-            <a:solidFill>
-              <a:srgbClr val="CDBDA4"/>
-            </a:solidFill>
-          </a:ln>
-          <a:effectLst/>
-        </p:spPr>
-        <p:style>
-          <a:lnRef idx="1">
-            <a:schemeClr val="accent1"/>
-          </a:lnRef>
-          <a:fillRef idx="3">
-            <a:schemeClr val="accent1"/>
-          </a:fillRef>
-          <a:effectRef idx="2">
-            <a:schemeClr val="accent1"/>
-          </a:effectRef>
-          <a:fontRef idx="minor">
-            <a:schemeClr val="lt1"/>
-          </a:fontRef>
-        </p:style>
-        <p:txBody>
-          <a:bodyPr rtlCol="0" anchor="ctr"/>
-          <a:lstStyle/>
-          <a:p>
-            <a:pPr algn="ctr"/>
-          </a:p>
-        </p:txBody>
-      </p:sp>
-      <p:sp>
-        <p:nvSpPr>
-          <p:cNvPr id="26" name="Oval 25"/>
-          <p:cNvSpPr/>
-          <p:nvPr/>
-        </p:nvSpPr>
-        <p:spPr>
-          <a:xfrm>
-            <a:off x="3394710" y="6018123"/>
-            <a:ext cx="214884" cy="214884"/>
-          </a:xfrm>
-          <a:prstGeom prst="ellipse">
-            <a:avLst/>
-          </a:prstGeom>
-          <a:solidFill>
-            <a:srgbClr val="FFFFFF"/>
-          </a:solidFill>
-          <a:ln w="19050">
-            <a:solidFill>
-              <a:srgbClr val="CDBDA4"/>
-            </a:solidFill>
-          </a:ln>
-          <a:effectLst/>
-        </p:spPr>
-        <p:style>
-          <a:lnRef idx="1">
-            <a:schemeClr val="accent1"/>
-          </a:lnRef>
-          <a:fillRef idx="3">
-            <a:schemeClr val="accent1"/>
-          </a:fillRef>
-          <a:effectRef idx="2">
-            <a:schemeClr val="accent1"/>
-          </a:effectRef>
-          <a:fontRef idx="minor">
-            <a:schemeClr val="lt1"/>
-          </a:fontRef>
-        </p:style>
-        <p:txBody>
-          <a:bodyPr rtlCol="0" anchor="ctr"/>
-          <a:lstStyle/>
-          <a:p>
-            <a:pPr algn="ctr"/>
-          </a:p>
-        </p:txBody>
-      </p:sp>
-      <p:sp>
-        <p:nvSpPr>
-          <p:cNvPr id="27" name="Rounded Rectangle 26"/>
+          <p:cNvPr id="31" name="Rounded Rectangle 30"/>
           <p:cNvSpPr/>
           <p:nvPr/>
         </p:nvSpPr>
@@ -5920,7 +6416,7 @@
       </p:sp>
       <p:sp>
         <p:nvSpPr>
-          <p:cNvPr id="28" name="Oval 27"/>
+          <p:cNvPr id="32" name="Oval 31"/>
           <p:cNvSpPr/>
           <p:nvPr/>
         </p:nvSpPr>
@@ -5973,7 +6469,7 @@
       </p:sp>
       <p:sp>
         <p:nvSpPr>
-          <p:cNvPr id="29" name="TextBox 28"/>
+          <p:cNvPr id="33" name="TextBox 32"/>
           <p:cNvSpPr txBox="1"/>
           <p:nvPr/>
         </p:nvSpPr>
@@ -6008,7 +6504,7 @@
       </p:sp>
       <p:sp>
         <p:nvSpPr>
-          <p:cNvPr id="30" name="TextBox 29"/>
+          <p:cNvPr id="34" name="TextBox 33"/>
           <p:cNvSpPr txBox="1"/>
           <p:nvPr/>
         </p:nvSpPr>
@@ -6087,7 +6583,7 @@
       </p:sp>
       <p:sp>
         <p:nvSpPr>
-          <p:cNvPr id="31" name="Rounded Rectangle 30"/>
+          <p:cNvPr id="35" name="Rounded Rectangle 34"/>
           <p:cNvSpPr/>
           <p:nvPr/>
         </p:nvSpPr>
@@ -6135,7 +6631,7 @@
       </p:sp>
       <p:sp>
         <p:nvSpPr>
-          <p:cNvPr id="32" name="Oval 31"/>
+          <p:cNvPr id="36" name="Oval 35"/>
           <p:cNvSpPr/>
           <p:nvPr/>
         </p:nvSpPr>
@@ -6188,7 +6684,7 @@
       </p:sp>
       <p:sp>
         <p:nvSpPr>
-          <p:cNvPr id="33" name="TextBox 32"/>
+          <p:cNvPr id="37" name="TextBox 36"/>
           <p:cNvSpPr txBox="1"/>
           <p:nvPr/>
         </p:nvSpPr>
@@ -6223,7 +6719,7 @@
       </p:sp>
       <p:sp>
         <p:nvSpPr>
-          <p:cNvPr id="34" name="TextBox 33"/>
+          <p:cNvPr id="38" name="TextBox 37"/>
           <p:cNvSpPr txBox="1"/>
           <p:nvPr/>
         </p:nvSpPr>
@@ -6302,7 +6798,7 @@
       </p:sp>
       <p:sp>
         <p:nvSpPr>
-          <p:cNvPr id="35" name="Rounded Rectangle 34"/>
+          <p:cNvPr id="39" name="Rounded Rectangle 38"/>
           <p:cNvSpPr/>
           <p:nvPr/>
         </p:nvSpPr>
@@ -6350,7 +6846,7 @@
       </p:sp>
       <p:sp>
         <p:nvSpPr>
-          <p:cNvPr id="36" name="Oval 35"/>
+          <p:cNvPr id="40" name="Oval 39"/>
           <p:cNvSpPr/>
           <p:nvPr/>
         </p:nvSpPr>
@@ -6403,7 +6899,7 @@
       </p:sp>
       <p:sp>
         <p:nvSpPr>
-          <p:cNvPr id="37" name="TextBox 36"/>
+          <p:cNvPr id="41" name="TextBox 40"/>
           <p:cNvSpPr txBox="1"/>
           <p:nvPr/>
         </p:nvSpPr>
@@ -6438,7 +6934,7 @@
       </p:sp>
       <p:sp>
         <p:nvSpPr>
-          <p:cNvPr id="38" name="TextBox 37"/>
+          <p:cNvPr id="42" name="TextBox 41"/>
           <p:cNvSpPr txBox="1"/>
           <p:nvPr/>
         </p:nvSpPr>
@@ -6470,7 +6966,7 @@
                 </a:solidFill>
                 <a:latin typeface="Segoe UI"/>
               </a:rPr>
-              <a:t>Projeto dentro do cronograma. Custo e homologação só iniciam após o fechamento da formulação (etapas 2 e 6).</a:t>
+              <a:t>Projeto dentro do cronograma.</a:t>
             </a:r>
           </a:p>
         </p:txBody>
@@ -7334,7 +7830,7 @@
                                           </p:stCondLst>
                                         </p:cTn>
                                         <p:tgtEl>
-                                          <p:spTgt spid="27"/>
+                                          <p:spTgt spid="31"/>
                                         </p:tgtEl>
                                         <p:attrNameLst>
                                           <p:attrName>style.visibility</p:attrName>
@@ -7348,7 +7844,7 @@
                                       <p:cBhvr>
                                         <p:cTn id="7" dur="420"/>
                                         <p:tgtEl>
-                                          <p:spTgt spid="27"/>
+                                          <p:spTgt spid="31"/>
                                         </p:tgtEl>
                                       </p:cBhvr>
                                     </p:animEffect>
@@ -7369,7 +7865,7 @@
                                           </p:stCondLst>
                                         </p:cTn>
                                         <p:tgtEl>
-                                          <p:spTgt spid="28"/>
+                                          <p:spTgt spid="32"/>
                                         </p:tgtEl>
                                         <p:attrNameLst>
                                           <p:attrName>style.visibility</p:attrName>
@@ -7383,7 +7879,7 @@
                                       <p:cBhvr>
                                         <p:cTn id="10" dur="420"/>
                                         <p:tgtEl>
-                                          <p:spTgt spid="28"/>
+                                          <p:spTgt spid="32"/>
                                         </p:tgtEl>
                                       </p:cBhvr>
                                     </p:animEffect>
@@ -7404,7 +7900,7 @@
                                           </p:stCondLst>
                                         </p:cTn>
                                         <p:tgtEl>
-                                          <p:spTgt spid="29"/>
+                                          <p:spTgt spid="33"/>
                                         </p:tgtEl>
                                         <p:attrNameLst>
                                           <p:attrName>style.visibility</p:attrName>
@@ -7418,7 +7914,7 @@
                                       <p:cBhvr>
                                         <p:cTn id="13" dur="420"/>
                                         <p:tgtEl>
-                                          <p:spTgt spid="29"/>
+                                          <p:spTgt spid="33"/>
                                         </p:tgtEl>
                                       </p:cBhvr>
                                     </p:animEffect>
@@ -7439,7 +7935,7 @@
                                           </p:stCondLst>
                                         </p:cTn>
                                         <p:tgtEl>
-                                          <p:spTgt spid="30"/>
+                                          <p:spTgt spid="34"/>
                                         </p:tgtEl>
                                         <p:attrNameLst>
                                           <p:attrName>style.visibility</p:attrName>
@@ -7453,7 +7949,7 @@
                                       <p:cBhvr>
                                         <p:cTn id="16" dur="420"/>
                                         <p:tgtEl>
-                                          <p:spTgt spid="30"/>
+                                          <p:spTgt spid="34"/>
                                         </p:tgtEl>
                                       </p:cBhvr>
                                     </p:animEffect>
@@ -7492,7 +7988,7 @@
                                           </p:stCondLst>
                                         </p:cTn>
                                         <p:tgtEl>
-                                          <p:spTgt spid="31"/>
+                                          <p:spTgt spid="35"/>
                                         </p:tgtEl>
                                         <p:attrNameLst>
                                           <p:attrName>style.visibility</p:attrName>
@@ -7506,7 +8002,7 @@
                                       <p:cBhvr>
                                         <p:cTn id="21" dur="420"/>
                                         <p:tgtEl>
-                                          <p:spTgt spid="31"/>
+                                          <p:spTgt spid="35"/>
                                         </p:tgtEl>
                                       </p:cBhvr>
                                     </p:animEffect>
@@ -7527,7 +8023,7 @@
                                           </p:stCondLst>
                                         </p:cTn>
                                         <p:tgtEl>
-                                          <p:spTgt spid="32"/>
+                                          <p:spTgt spid="36"/>
                                         </p:tgtEl>
                                         <p:attrNameLst>
                                           <p:attrName>style.visibility</p:attrName>
@@ -7541,7 +8037,7 @@
                                       <p:cBhvr>
                                         <p:cTn id="24" dur="420"/>
                                         <p:tgtEl>
-                                          <p:spTgt spid="32"/>
+                                          <p:spTgt spid="36"/>
                                         </p:tgtEl>
                                       </p:cBhvr>
                                     </p:animEffect>
@@ -7562,7 +8058,7 @@
                                           </p:stCondLst>
                                         </p:cTn>
                                         <p:tgtEl>
-                                          <p:spTgt spid="33"/>
+                                          <p:spTgt spid="37"/>
                                         </p:tgtEl>
                                         <p:attrNameLst>
                                           <p:attrName>style.visibility</p:attrName>
@@ -7576,7 +8072,7 @@
                                       <p:cBhvr>
                                         <p:cTn id="27" dur="420"/>
                                         <p:tgtEl>
-                                          <p:spTgt spid="33"/>
+                                          <p:spTgt spid="37"/>
                                         </p:tgtEl>
                                       </p:cBhvr>
                                     </p:animEffect>
@@ -7597,7 +8093,7 @@
                                           </p:stCondLst>
                                         </p:cTn>
                                         <p:tgtEl>
-                                          <p:spTgt spid="34"/>
+                                          <p:spTgt spid="38"/>
                                         </p:tgtEl>
                                         <p:attrNameLst>
                                           <p:attrName>style.visibility</p:attrName>
@@ -7611,7 +8107,7 @@
                                       <p:cBhvr>
                                         <p:cTn id="30" dur="420"/>
                                         <p:tgtEl>
-                                          <p:spTgt spid="34"/>
+                                          <p:spTgt spid="38"/>
                                         </p:tgtEl>
                                       </p:cBhvr>
                                     </p:animEffect>
@@ -7650,7 +8146,7 @@
                                           </p:stCondLst>
                                         </p:cTn>
                                         <p:tgtEl>
-                                          <p:spTgt spid="35"/>
+                                          <p:spTgt spid="39"/>
                                         </p:tgtEl>
                                         <p:attrNameLst>
                                           <p:attrName>style.visibility</p:attrName>
@@ -7664,7 +8160,7 @@
                                       <p:cBhvr>
                                         <p:cTn id="35" dur="420"/>
                                         <p:tgtEl>
-                                          <p:spTgt spid="35"/>
+                                          <p:spTgt spid="39"/>
                                         </p:tgtEl>
                                       </p:cBhvr>
                                     </p:animEffect>
@@ -7685,7 +8181,7 @@
                                           </p:stCondLst>
                                         </p:cTn>
                                         <p:tgtEl>
-                                          <p:spTgt spid="36"/>
+                                          <p:spTgt spid="40"/>
                                         </p:tgtEl>
                                         <p:attrNameLst>
                                           <p:attrName>style.visibility</p:attrName>
@@ -7699,7 +8195,7 @@
                                       <p:cBhvr>
                                         <p:cTn id="38" dur="420"/>
                                         <p:tgtEl>
-                                          <p:spTgt spid="36"/>
+                                          <p:spTgt spid="40"/>
                                         </p:tgtEl>
                                       </p:cBhvr>
                                     </p:animEffect>
@@ -7720,7 +8216,7 @@
                                           </p:stCondLst>
                                         </p:cTn>
                                         <p:tgtEl>
-                                          <p:spTgt spid="37"/>
+                                          <p:spTgt spid="41"/>
                                         </p:tgtEl>
                                         <p:attrNameLst>
                                           <p:attrName>style.visibility</p:attrName>
@@ -7734,7 +8230,7 @@
                                       <p:cBhvr>
                                         <p:cTn id="41" dur="420"/>
                                         <p:tgtEl>
-                                          <p:spTgt spid="37"/>
+                                          <p:spTgt spid="41"/>
                                         </p:tgtEl>
                                       </p:cBhvr>
                                     </p:animEffect>
@@ -7755,7 +8251,7 @@
                                           </p:stCondLst>
                                         </p:cTn>
                                         <p:tgtEl>
-                                          <p:spTgt spid="38"/>
+                                          <p:spTgt spid="42"/>
                                         </p:tgtEl>
                                         <p:attrNameLst>
                                           <p:attrName>style.visibility</p:attrName>
@@ -7769,7 +8265,7 @@
                                       <p:cBhvr>
                                         <p:cTn id="44" dur="420"/>
                                         <p:tgtEl>
-                                          <p:spTgt spid="38"/>
+                                          <p:spTgt spid="42"/>
                                         </p:tgtEl>
                                       </p:cBhvr>
                                     </p:animEffect>
@@ -7804,10 +8300,6 @@
       </p:par>
     </p:tnLst>
     <p:bldLst>
-      <p:bldP spid="27" grpId="0" animBg="1"/>
-      <p:bldP spid="28" grpId="0" animBg="1"/>
-      <p:bldP spid="29" grpId="0" animBg="1"/>
-      <p:bldP spid="30" grpId="0" animBg="1"/>
       <p:bldP spid="31" grpId="0" animBg="1"/>
       <p:bldP spid="32" grpId="0" animBg="1"/>
       <p:bldP spid="33" grpId="0" animBg="1"/>
@@ -7816,6 +8308,10 @@
       <p:bldP spid="36" grpId="0" animBg="1"/>
       <p:bldP spid="37" grpId="0" animBg="1"/>
       <p:bldP spid="38" grpId="0" animBg="1"/>
+      <p:bldP spid="39" grpId="0" animBg="1"/>
+      <p:bldP spid="40" grpId="0" animBg="1"/>
+      <p:bldP spid="41" grpId="0" animBg="1"/>
+      <p:bldP spid="42" grpId="0" animBg="1"/>
     </p:bldLst>
   </p:timing>
 </p:sld>
@@ -10174,7 +10670,7 @@
         <p:spPr>
           <a:xfrm>
             <a:off x="347472" y="982980"/>
-            <a:ext cx="8686800" cy="256032"/>
+            <a:ext cx="7680960" cy="256032"/>
           </a:xfrm>
           <a:prstGeom prst="rect">
             <a:avLst/>
@@ -10355,7 +10851,7 @@
         </p:nvGraphicFramePr>
         <p:xfrm>
           <a:off x="566928" y="1993392"/>
-          <a:ext cx="5504688" cy="4334248"/>
+          <a:ext cx="5504688" cy="4334256"/>
         </p:xfrm>
         <a:graphic>
           <a:graphicData uri="http://schemas.openxmlformats.org/drawingml/2006/table">
@@ -10463,7 +10959,7 @@
                   </a:tcPr>
                 </a:tc>
               </a:tr>
-              <a:tr h="404164">
+              <a:tr h="310896">
                 <a:tc>
                   <a:txBody>
                     <a:bodyPr/>
@@ -10471,7 +10967,7 @@
                     <a:p>
                       <a:pPr algn="l"/>
                       <a:r>
-                        <a:rPr sz="950" b="1">
+                        <a:rPr sz="850" b="1">
                           <a:solidFill>
                             <a:srgbClr val="3E2419"/>
                           </a:solidFill>
@@ -10517,7 +11013,7 @@
                     <a:p>
                       <a:pPr algn="l"/>
                       <a:r>
-                        <a:rPr sz="950" b="0">
+                        <a:rPr sz="850" b="0">
                           <a:solidFill>
                             <a:srgbClr val="5A3A2A"/>
                           </a:solidFill>
@@ -10540,7 +11036,7 @@
                     <a:p>
                       <a:pPr algn="ctr"/>
                       <a:r>
-                        <a:rPr sz="950" b="0">
+                        <a:rPr sz="850" b="0">
                           <a:solidFill>
                             <a:srgbClr val="5A3A2A"/>
                           </a:solidFill>
@@ -10557,7 +11053,7 @@
                   </a:tcPr>
                 </a:tc>
               </a:tr>
-              <a:tr h="404164">
+              <a:tr h="310896">
                 <a:tc>
                   <a:txBody>
                     <a:bodyPr/>
@@ -10565,7 +11061,7 @@
                     <a:p>
                       <a:pPr algn="l"/>
                       <a:r>
-                        <a:rPr sz="950" b="1">
+                        <a:rPr sz="850" b="1">
                           <a:solidFill>
                             <a:srgbClr val="3E2419"/>
                           </a:solidFill>
@@ -10611,7 +11107,7 @@
                     <a:p>
                       <a:pPr algn="l"/>
                       <a:r>
-                        <a:rPr sz="950" b="0">
+                        <a:rPr sz="850" b="0">
                           <a:solidFill>
                             <a:srgbClr val="5A3A2A"/>
                           </a:solidFill>
@@ -10634,7 +11130,7 @@
                     <a:p>
                       <a:pPr algn="ctr"/>
                       <a:r>
-                        <a:rPr sz="950" b="0">
+                        <a:rPr sz="850" b="0">
                           <a:solidFill>
                             <a:srgbClr val="5A3A2A"/>
                           </a:solidFill>
@@ -10651,7 +11147,7 @@
                   </a:tcPr>
                 </a:tc>
               </a:tr>
-              <a:tr h="404164">
+              <a:tr h="310896">
                 <a:tc>
                   <a:txBody>
                     <a:bodyPr/>
@@ -10659,13 +11155,13 @@
                     <a:p>
                       <a:pPr algn="l"/>
                       <a:r>
-                        <a:rPr sz="950" b="1">
+                        <a:rPr sz="850" b="1">
                           <a:solidFill>
                             <a:srgbClr val="3E2419"/>
                           </a:solidFill>
                           <a:latin typeface="Segoe UI"/>
                         </a:rPr>
-                        <a:t>3. Custo</a:t>
+                        <a:t>3. Custo e preço de venda</a:t>
                       </a:r>
                     </a:p>
                   </a:txBody>
@@ -10705,7 +11201,7 @@
                     <a:p>
                       <a:pPr algn="l"/>
                       <a:r>
-                        <a:rPr sz="950" b="0">
+                        <a:rPr sz="850" b="0">
                           <a:solidFill>
                             <a:srgbClr val="5A3A2A"/>
                           </a:solidFill>
@@ -10728,7 +11224,7 @@
                     <a:p>
                       <a:pPr algn="ctr"/>
                       <a:r>
-                        <a:rPr sz="950" b="0">
+                        <a:rPr sz="850" b="0">
                           <a:solidFill>
                             <a:srgbClr val="5A3A2A"/>
                           </a:solidFill>
@@ -10745,7 +11241,7 @@
                   </a:tcPr>
                 </a:tc>
               </a:tr>
-              <a:tr h="404164">
+              <a:tr h="310896">
                 <a:tc>
                   <a:txBody>
                     <a:bodyPr/>
@@ -10753,13 +11249,13 @@
                     <a:p>
                       <a:pPr algn="l"/>
                       <a:r>
-                        <a:rPr sz="950" b="1">
+                        <a:rPr sz="850" b="1">
                           <a:solidFill>
                             <a:srgbClr val="3E2419"/>
                           </a:solidFill>
                           <a:latin typeface="Segoe UI"/>
                         </a:rPr>
-                        <a:t>4. Homologação</a:t>
+                        <a:t>4. Viabilidade produtiva/teste em linha</a:t>
                       </a:r>
                     </a:p>
                   </a:txBody>
@@ -10799,7 +11295,7 @@
                     <a:p>
                       <a:pPr algn="l"/>
                       <a:r>
-                        <a:rPr sz="950" b="0">
+                        <a:rPr sz="850" b="0">
                           <a:solidFill>
                             <a:srgbClr val="5A3A2A"/>
                           </a:solidFill>
@@ -10822,7 +11318,7 @@
                     <a:p>
                       <a:pPr algn="ctr"/>
                       <a:r>
-                        <a:rPr sz="950" b="0">
+                        <a:rPr sz="850" b="0">
                           <a:solidFill>
                             <a:srgbClr val="5A3A2A"/>
                           </a:solidFill>
@@ -10839,7 +11335,7 @@
                   </a:tcPr>
                 </a:tc>
               </a:tr>
-              <a:tr h="404164">
+              <a:tr h="310896">
                 <a:tc>
                   <a:txBody>
                     <a:bodyPr/>
@@ -10847,13 +11343,13 @@
                     <a:p>
                       <a:pPr algn="l"/>
                       <a:r>
-                        <a:rPr sz="950" b="1">
+                        <a:rPr sz="850" b="1">
                           <a:solidFill>
                             <a:srgbClr val="3E2419"/>
                           </a:solidFill>
                           <a:latin typeface="Segoe UI"/>
                         </a:rPr>
-                        <a:t>5. Volume (comercial)</a:t>
+                        <a:t>5. Homologação</a:t>
                       </a:r>
                     </a:p>
                   </a:txBody>
@@ -10893,7 +11389,7 @@
                     <a:p>
                       <a:pPr algn="l"/>
                       <a:r>
-                        <a:rPr sz="950" b="0">
+                        <a:rPr sz="850" b="0">
                           <a:solidFill>
                             <a:srgbClr val="5A3A2A"/>
                           </a:solidFill>
@@ -10916,7 +11412,7 @@
                     <a:p>
                       <a:pPr algn="ctr"/>
                       <a:r>
-                        <a:rPr sz="950" b="0">
+                        <a:rPr sz="850" b="0">
                           <a:solidFill>
                             <a:srgbClr val="5A3A2A"/>
                           </a:solidFill>
@@ -10933,7 +11429,7 @@
                   </a:tcPr>
                 </a:tc>
               </a:tr>
-              <a:tr h="404164">
+              <a:tr h="310896">
                 <a:tc>
                   <a:txBody>
                     <a:bodyPr/>
@@ -10941,13 +11437,13 @@
                     <a:p>
                       <a:pPr algn="l"/>
                       <a:r>
-                        <a:rPr sz="950" b="1">
+                        <a:rPr sz="850" b="1">
                           <a:solidFill>
                             <a:srgbClr val="3E2419"/>
                           </a:solidFill>
                           <a:latin typeface="Segoe UI"/>
                         </a:rPr>
-                        <a:t>6. Engenharias e FTs</a:t>
+                        <a:t>6. Volume (comercial)</a:t>
                       </a:r>
                     </a:p>
                   </a:txBody>
@@ -10987,7 +11483,7 @@
                     <a:p>
                       <a:pPr algn="l"/>
                       <a:r>
-                        <a:rPr sz="950" b="0">
+                        <a:rPr sz="850" b="0">
                           <a:solidFill>
                             <a:srgbClr val="5A3A2A"/>
                           </a:solidFill>
@@ -11010,7 +11506,7 @@
                     <a:p>
                       <a:pPr algn="ctr"/>
                       <a:r>
-                        <a:rPr sz="950" b="0">
+                        <a:rPr sz="850" b="0">
                           <a:solidFill>
                             <a:srgbClr val="5A3A2A"/>
                           </a:solidFill>
@@ -11027,7 +11523,7 @@
                   </a:tcPr>
                 </a:tc>
               </a:tr>
-              <a:tr h="404164">
+              <a:tr h="310896">
                 <a:tc>
                   <a:txBody>
                     <a:bodyPr/>
@@ -11035,13 +11531,13 @@
                     <a:p>
                       <a:pPr algn="l"/>
                       <a:r>
-                        <a:rPr sz="950" b="1">
+                        <a:rPr sz="850" b="1">
                           <a:solidFill>
                             <a:srgbClr val="3E2419"/>
                           </a:solidFill>
                           <a:latin typeface="Segoe UI"/>
                         </a:rPr>
-                        <a:t>7. Criação da arte e etiquetas</a:t>
+                        <a:t>7. Engenharias e FTs</a:t>
                       </a:r>
                     </a:p>
                   </a:txBody>
@@ -11081,7 +11577,7 @@
                     <a:p>
                       <a:pPr algn="l"/>
                       <a:r>
-                        <a:rPr sz="950" b="0">
+                        <a:rPr sz="850" b="0">
                           <a:solidFill>
                             <a:srgbClr val="5A3A2A"/>
                           </a:solidFill>
@@ -11104,7 +11600,7 @@
                     <a:p>
                       <a:pPr algn="ctr"/>
                       <a:r>
-                        <a:rPr sz="950" b="0">
+                        <a:rPr sz="850" b="0">
                           <a:solidFill>
                             <a:srgbClr val="5A3A2A"/>
                           </a:solidFill>
@@ -11121,7 +11617,7 @@
                   </a:tcPr>
                 </a:tc>
               </a:tr>
-              <a:tr h="404164">
+              <a:tr h="310896">
                 <a:tc>
                   <a:txBody>
                     <a:bodyPr/>
@@ -11129,13 +11625,13 @@
                     <a:p>
                       <a:pPr algn="l"/>
                       <a:r>
-                        <a:rPr sz="950" b="1">
+                        <a:rPr sz="850" b="1">
                           <a:solidFill>
                             <a:srgbClr val="3E2419"/>
                           </a:solidFill>
                           <a:latin typeface="Segoe UI"/>
                         </a:rPr>
-                        <a:t>8. Tabela comercial</a:t>
+                        <a:t>8. Criação da arte e etiquetas</a:t>
                       </a:r>
                     </a:p>
                   </a:txBody>
@@ -11175,7 +11671,7 @@
                     <a:p>
                       <a:pPr algn="l"/>
                       <a:r>
-                        <a:rPr sz="950" b="0">
+                        <a:rPr sz="850" b="0">
                           <a:solidFill>
                             <a:srgbClr val="5A3A2A"/>
                           </a:solidFill>
@@ -11198,7 +11694,7 @@
                     <a:p>
                       <a:pPr algn="ctr"/>
                       <a:r>
-                        <a:rPr sz="950" b="0">
+                        <a:rPr sz="850" b="0">
                           <a:solidFill>
                             <a:srgbClr val="5A3A2A"/>
                           </a:solidFill>
@@ -11215,7 +11711,7 @@
                   </a:tcPr>
                 </a:tc>
               </a:tr>
-              <a:tr h="404164">
+              <a:tr h="310896">
                 <a:tc>
                   <a:txBody>
                     <a:bodyPr/>
@@ -11223,13 +11719,13 @@
                     <a:p>
                       <a:pPr algn="l"/>
                       <a:r>
-                        <a:rPr sz="950" b="1">
+                        <a:rPr sz="850" b="1">
                           <a:solidFill>
                             <a:srgbClr val="3E2419"/>
                           </a:solidFill>
                           <a:latin typeface="Segoe UI"/>
                         </a:rPr>
-                        <a:t>9. Comunicado vendedores</a:t>
+                        <a:t>9. Compras</a:t>
                       </a:r>
                     </a:p>
                   </a:txBody>
@@ -11269,7 +11765,7 @@
                     <a:p>
                       <a:pPr algn="l"/>
                       <a:r>
-                        <a:rPr sz="950" b="0">
+                        <a:rPr sz="850" b="0">
                           <a:solidFill>
                             <a:srgbClr val="5A3A2A"/>
                           </a:solidFill>
@@ -11292,7 +11788,7 @@
                     <a:p>
                       <a:pPr algn="ctr"/>
                       <a:r>
-                        <a:rPr sz="950" b="0">
+                        <a:rPr sz="850" b="0">
                           <a:solidFill>
                             <a:srgbClr val="5A3A2A"/>
                           </a:solidFill>
@@ -11309,7 +11805,7 @@
                   </a:tcPr>
                 </a:tc>
               </a:tr>
-              <a:tr h="404164">
+              <a:tr h="310896">
                 <a:tc>
                   <a:txBody>
                     <a:bodyPr/>
@@ -11317,13 +11813,13 @@
                     <a:p>
                       <a:pPr algn="l"/>
                       <a:r>
-                        <a:rPr sz="950" b="1">
+                        <a:rPr sz="850" b="1">
                           <a:solidFill>
                             <a:srgbClr val="3E2419"/>
                           </a:solidFill>
                           <a:latin typeface="Segoe UI"/>
                         </a:rPr>
-                        <a:t>10. Lançamento</a:t>
+                        <a:t>10. Tabela comercial</a:t>
                       </a:r>
                     </a:p>
                   </a:txBody>
@@ -11363,7 +11859,7 @@
                     <a:p>
                       <a:pPr algn="l"/>
                       <a:r>
-                        <a:rPr sz="950" b="0">
+                        <a:rPr sz="850" b="0">
                           <a:solidFill>
                             <a:srgbClr val="5A3A2A"/>
                           </a:solidFill>
@@ -11386,7 +11882,7 @@
                     <a:p>
                       <a:pPr algn="ctr"/>
                       <a:r>
-                        <a:rPr sz="950" b="0">
+                        <a:rPr sz="850" b="0">
                           <a:solidFill>
                             <a:srgbClr val="5A3A2A"/>
                           </a:solidFill>
@@ -11403,6 +11899,288 @@
                   </a:tcPr>
                 </a:tc>
               </a:tr>
+              <a:tr h="310896">
+                <a:tc>
+                  <a:txBody>
+                    <a:bodyPr/>
+                    <a:lstStyle/>
+                    <a:p>
+                      <a:pPr algn="l"/>
+                      <a:r>
+                        <a:rPr sz="850" b="1">
+                          <a:solidFill>
+                            <a:srgbClr val="3E2419"/>
+                          </a:solidFill>
+                          <a:latin typeface="Segoe UI"/>
+                        </a:rPr>
+                        <a:t>11. Produção</a:t>
+                      </a:r>
+                    </a:p>
+                  </a:txBody>
+                  <a:tcPr anchor="ctr" marL="64008" marR="27432" marT="9144" marB="9144">
+                    <a:solidFill>
+                      <a:srgbClr val="FFFFFF"/>
+                    </a:solidFill>
+                  </a:tcPr>
+                </a:tc>
+                <a:tc>
+                  <a:txBody>
+                    <a:bodyPr/>
+                    <a:lstStyle/>
+                    <a:p>
+                      <a:pPr algn="ctr"/>
+                      <a:r>
+                        <a:rPr sz="900" b="0">
+                          <a:solidFill>
+                            <a:srgbClr val="3E2419"/>
+                          </a:solidFill>
+                          <a:latin typeface="Segoe UI"/>
+                        </a:rPr>
+                        <a:t/>
+                      </a:r>
+                    </a:p>
+                  </a:txBody>
+                  <a:tcPr anchor="ctr" marL="64008" marR="27432" marT="9144" marB="9144">
+                    <a:solidFill>
+                      <a:srgbClr val="FFFFFF"/>
+                    </a:solidFill>
+                  </a:tcPr>
+                </a:tc>
+                <a:tc>
+                  <a:txBody>
+                    <a:bodyPr/>
+                    <a:lstStyle/>
+                    <a:p>
+                      <a:pPr algn="l"/>
+                      <a:r>
+                        <a:rPr sz="850" b="0">
+                          <a:solidFill>
+                            <a:srgbClr val="5A3A2A"/>
+                          </a:solidFill>
+                          <a:latin typeface="Segoe UI"/>
+                        </a:rPr>
+                        <a:t>—</a:t>
+                      </a:r>
+                    </a:p>
+                  </a:txBody>
+                  <a:tcPr anchor="ctr" marL="64008" marR="27432" marT="9144" marB="9144">
+                    <a:solidFill>
+                      <a:srgbClr val="FFFFFF"/>
+                    </a:solidFill>
+                  </a:tcPr>
+                </a:tc>
+                <a:tc>
+                  <a:txBody>
+                    <a:bodyPr/>
+                    <a:lstStyle/>
+                    <a:p>
+                      <a:pPr algn="ctr"/>
+                      <a:r>
+                        <a:rPr sz="850" b="0">
+                          <a:solidFill>
+                            <a:srgbClr val="5A3A2A"/>
+                          </a:solidFill>
+                          <a:latin typeface="Segoe UI"/>
+                        </a:rPr>
+                        <a:t>—</a:t>
+                      </a:r>
+                    </a:p>
+                  </a:txBody>
+                  <a:tcPr anchor="ctr" marL="64008" marR="27432" marT="9144" marB="9144">
+                    <a:solidFill>
+                      <a:srgbClr val="FFFFFF"/>
+                    </a:solidFill>
+                  </a:tcPr>
+                </a:tc>
+              </a:tr>
+              <a:tr h="310896">
+                <a:tc>
+                  <a:txBody>
+                    <a:bodyPr/>
+                    <a:lstStyle/>
+                    <a:p>
+                      <a:pPr algn="l"/>
+                      <a:r>
+                        <a:rPr sz="850" b="1">
+                          <a:solidFill>
+                            <a:srgbClr val="3E2419"/>
+                          </a:solidFill>
+                          <a:latin typeface="Segoe UI"/>
+                        </a:rPr>
+                        <a:t>12. Comunicado vendedores</a:t>
+                      </a:r>
+                    </a:p>
+                  </a:txBody>
+                  <a:tcPr anchor="ctr" marL="64008" marR="27432" marT="9144" marB="9144">
+                    <a:solidFill>
+                      <a:srgbClr val="F9F3E4"/>
+                    </a:solidFill>
+                  </a:tcPr>
+                </a:tc>
+                <a:tc>
+                  <a:txBody>
+                    <a:bodyPr/>
+                    <a:lstStyle/>
+                    <a:p>
+                      <a:pPr algn="ctr"/>
+                      <a:r>
+                        <a:rPr sz="900" b="0">
+                          <a:solidFill>
+                            <a:srgbClr val="3E2419"/>
+                          </a:solidFill>
+                          <a:latin typeface="Segoe UI"/>
+                        </a:rPr>
+                        <a:t/>
+                      </a:r>
+                    </a:p>
+                  </a:txBody>
+                  <a:tcPr anchor="ctr" marL="64008" marR="27432" marT="9144" marB="9144">
+                    <a:solidFill>
+                      <a:srgbClr val="F9F3E4"/>
+                    </a:solidFill>
+                  </a:tcPr>
+                </a:tc>
+                <a:tc>
+                  <a:txBody>
+                    <a:bodyPr/>
+                    <a:lstStyle/>
+                    <a:p>
+                      <a:pPr algn="l"/>
+                      <a:r>
+                        <a:rPr sz="850" b="0">
+                          <a:solidFill>
+                            <a:srgbClr val="5A3A2A"/>
+                          </a:solidFill>
+                          <a:latin typeface="Segoe UI"/>
+                        </a:rPr>
+                        <a:t>—</a:t>
+                      </a:r>
+                    </a:p>
+                  </a:txBody>
+                  <a:tcPr anchor="ctr" marL="64008" marR="27432" marT="9144" marB="9144">
+                    <a:solidFill>
+                      <a:srgbClr val="F9F3E4"/>
+                    </a:solidFill>
+                  </a:tcPr>
+                </a:tc>
+                <a:tc>
+                  <a:txBody>
+                    <a:bodyPr/>
+                    <a:lstStyle/>
+                    <a:p>
+                      <a:pPr algn="ctr"/>
+                      <a:r>
+                        <a:rPr sz="850" b="0">
+                          <a:solidFill>
+                            <a:srgbClr val="5A3A2A"/>
+                          </a:solidFill>
+                          <a:latin typeface="Segoe UI"/>
+                        </a:rPr>
+                        <a:t>—</a:t>
+                      </a:r>
+                    </a:p>
+                  </a:txBody>
+                  <a:tcPr anchor="ctr" marL="64008" marR="27432" marT="9144" marB="9144">
+                    <a:solidFill>
+                      <a:srgbClr val="F9F3E4"/>
+                    </a:solidFill>
+                  </a:tcPr>
+                </a:tc>
+              </a:tr>
+              <a:tr h="310896">
+                <a:tc>
+                  <a:txBody>
+                    <a:bodyPr/>
+                    <a:lstStyle/>
+                    <a:p>
+                      <a:pPr algn="l"/>
+                      <a:r>
+                        <a:rPr sz="850" b="1">
+                          <a:solidFill>
+                            <a:srgbClr val="3E2419"/>
+                          </a:solidFill>
+                          <a:latin typeface="Segoe UI"/>
+                        </a:rPr>
+                        <a:t>13. Campanha de lançamento</a:t>
+                      </a:r>
+                    </a:p>
+                  </a:txBody>
+                  <a:tcPr anchor="ctr" marL="64008" marR="27432" marT="9144" marB="9144">
+                    <a:solidFill>
+                      <a:srgbClr val="FFFFFF"/>
+                    </a:solidFill>
+                  </a:tcPr>
+                </a:tc>
+                <a:tc>
+                  <a:txBody>
+                    <a:bodyPr/>
+                    <a:lstStyle/>
+                    <a:p>
+                      <a:pPr algn="ctr"/>
+                      <a:r>
+                        <a:rPr sz="900" b="0">
+                          <a:solidFill>
+                            <a:srgbClr val="3E2419"/>
+                          </a:solidFill>
+                          <a:latin typeface="Segoe UI"/>
+                        </a:rPr>
+                        <a:t/>
+                      </a:r>
+                    </a:p>
+                  </a:txBody>
+                  <a:tcPr anchor="ctr" marL="64008" marR="27432" marT="9144" marB="9144">
+                    <a:solidFill>
+                      <a:srgbClr val="FFFFFF"/>
+                    </a:solidFill>
+                  </a:tcPr>
+                </a:tc>
+                <a:tc>
+                  <a:txBody>
+                    <a:bodyPr/>
+                    <a:lstStyle/>
+                    <a:p>
+                      <a:pPr algn="l"/>
+                      <a:r>
+                        <a:rPr sz="850" b="0">
+                          <a:solidFill>
+                            <a:srgbClr val="5A3A2A"/>
+                          </a:solidFill>
+                          <a:latin typeface="Segoe UI"/>
+                        </a:rPr>
+                        <a:t>—</a:t>
+                      </a:r>
+                    </a:p>
+                  </a:txBody>
+                  <a:tcPr anchor="ctr" marL="64008" marR="27432" marT="9144" marB="9144">
+                    <a:solidFill>
+                      <a:srgbClr val="FFFFFF"/>
+                    </a:solidFill>
+                  </a:tcPr>
+                </a:tc>
+                <a:tc>
+                  <a:txBody>
+                    <a:bodyPr/>
+                    <a:lstStyle/>
+                    <a:p>
+                      <a:pPr algn="ctr"/>
+                      <a:r>
+                        <a:rPr sz="850" b="0">
+                          <a:solidFill>
+                            <a:srgbClr val="5A3A2A"/>
+                          </a:solidFill>
+                          <a:latin typeface="Segoe UI"/>
+                        </a:rPr>
+                        <a:t>—</a:t>
+                      </a:r>
+                    </a:p>
+                  </a:txBody>
+                  <a:tcPr anchor="ctr" marL="64008" marR="27432" marT="9144" marB="9144">
+                    <a:solidFill>
+                      <a:srgbClr val="FFFFFF"/>
+                    </a:solidFill>
+                  </a:tcPr>
+                </a:tc>
+              </a:tr>
             </a:tbl>
           </a:graphicData>
         </a:graphic>
@@ -11415,7 +12193,7 @@
         </p:nvSpPr>
         <p:spPr>
           <a:xfrm>
-            <a:off x="3394710" y="2380640"/>
+            <a:off x="3394710" y="2334006"/>
             <a:ext cx="214884" cy="214884"/>
           </a:xfrm>
           <a:prstGeom prst="ellipse">
@@ -11461,7 +12239,7 @@
         </p:nvSpPr>
         <p:spPr>
           <a:xfrm>
-            <a:off x="3394710" y="2784805"/>
+            <a:off x="3394710" y="2644901"/>
             <a:ext cx="214884" cy="214884"/>
           </a:xfrm>
           <a:prstGeom prst="ellipse">
@@ -11507,7 +12285,7 @@
         </p:nvSpPr>
         <p:spPr>
           <a:xfrm>
-            <a:off x="3394710" y="3188970"/>
+            <a:off x="3394710" y="2955797"/>
             <a:ext cx="214884" cy="214884"/>
           </a:xfrm>
           <a:prstGeom prst="ellipse">
@@ -11553,7 +12331,7 @@
         </p:nvSpPr>
         <p:spPr>
           <a:xfrm>
-            <a:off x="3394710" y="3593134"/>
+            <a:off x="3394710" y="3266694"/>
             <a:ext cx="214884" cy="214884"/>
           </a:xfrm>
           <a:prstGeom prst="ellipse">
@@ -11599,7 +12377,7 @@
         </p:nvSpPr>
         <p:spPr>
           <a:xfrm>
-            <a:off x="3394710" y="3997299"/>
+            <a:off x="3394710" y="3577590"/>
             <a:ext cx="214884" cy="214884"/>
           </a:xfrm>
           <a:prstGeom prst="ellipse">
@@ -11645,7 +12423,7 @@
         </p:nvSpPr>
         <p:spPr>
           <a:xfrm>
-            <a:off x="3394710" y="4401464"/>
+            <a:off x="3394710" y="3888485"/>
             <a:ext cx="214884" cy="214884"/>
           </a:xfrm>
           <a:prstGeom prst="ellipse">
@@ -11691,7 +12469,7 @@
         </p:nvSpPr>
         <p:spPr>
           <a:xfrm>
-            <a:off x="3394710" y="4805629"/>
+            <a:off x="3394710" y="4199382"/>
             <a:ext cx="214884" cy="214884"/>
           </a:xfrm>
           <a:prstGeom prst="ellipse">
@@ -11737,7 +12515,7 @@
         </p:nvSpPr>
         <p:spPr>
           <a:xfrm>
-            <a:off x="3394710" y="5209794"/>
+            <a:off x="3394710" y="4510278"/>
             <a:ext cx="214884" cy="214884"/>
           </a:xfrm>
           <a:prstGeom prst="ellipse">
@@ -11783,7 +12561,7 @@
         </p:nvSpPr>
         <p:spPr>
           <a:xfrm>
-            <a:off x="3394710" y="5613958"/>
+            <a:off x="3394710" y="4821174"/>
             <a:ext cx="214884" cy="214884"/>
           </a:xfrm>
           <a:prstGeom prst="ellipse">
@@ -11829,7 +12607,7 @@
         </p:nvSpPr>
         <p:spPr>
           <a:xfrm>
-            <a:off x="3394710" y="6018123"/>
+            <a:off x="3394710" y="5132070"/>
             <a:ext cx="214884" cy="214884"/>
           </a:xfrm>
           <a:prstGeom prst="ellipse">
@@ -11869,7 +12647,145 @@
       </p:sp>
       <p:sp>
         <p:nvSpPr>
-          <p:cNvPr id="27" name="Rounded Rectangle 26"/>
+          <p:cNvPr id="27" name="Oval 26"/>
+          <p:cNvSpPr/>
+          <p:nvPr/>
+        </p:nvSpPr>
+        <p:spPr>
+          <a:xfrm>
+            <a:off x="3394710" y="5442966"/>
+            <a:ext cx="214884" cy="214884"/>
+          </a:xfrm>
+          <a:prstGeom prst="ellipse">
+            <a:avLst/>
+          </a:prstGeom>
+          <a:solidFill>
+            <a:srgbClr val="FFFFFF"/>
+          </a:solidFill>
+          <a:ln w="19050">
+            <a:solidFill>
+              <a:srgbClr val="CDBDA4"/>
+            </a:solidFill>
+          </a:ln>
+          <a:effectLst/>
+        </p:spPr>
+        <p:style>
+          <a:lnRef idx="1">
+            <a:schemeClr val="accent1"/>
+          </a:lnRef>
+          <a:fillRef idx="3">
+            <a:schemeClr val="accent1"/>
+          </a:fillRef>
+          <a:effectRef idx="2">
+            <a:schemeClr val="accent1"/>
+          </a:effectRef>
+          <a:fontRef idx="minor">
+            <a:schemeClr val="lt1"/>
+          </a:fontRef>
+        </p:style>
+        <p:txBody>
+          <a:bodyPr rtlCol="0" anchor="ctr"/>
+          <a:lstStyle/>
+          <a:p>
+            <a:pPr algn="ctr"/>
+          </a:p>
+        </p:txBody>
+      </p:sp>
+      <p:sp>
+        <p:nvSpPr>
+          <p:cNvPr id="28" name="Oval 27"/>
+          <p:cNvSpPr/>
+          <p:nvPr/>
+        </p:nvSpPr>
+        <p:spPr>
+          <a:xfrm>
+            <a:off x="3394710" y="5753862"/>
+            <a:ext cx="214884" cy="214884"/>
+          </a:xfrm>
+          <a:prstGeom prst="ellipse">
+            <a:avLst/>
+          </a:prstGeom>
+          <a:solidFill>
+            <a:srgbClr val="FFFFFF"/>
+          </a:solidFill>
+          <a:ln w="19050">
+            <a:solidFill>
+              <a:srgbClr val="CDBDA4"/>
+            </a:solidFill>
+          </a:ln>
+          <a:effectLst/>
+        </p:spPr>
+        <p:style>
+          <a:lnRef idx="1">
+            <a:schemeClr val="accent1"/>
+          </a:lnRef>
+          <a:fillRef idx="3">
+            <a:schemeClr val="accent1"/>
+          </a:fillRef>
+          <a:effectRef idx="2">
+            <a:schemeClr val="accent1"/>
+          </a:effectRef>
+          <a:fontRef idx="minor">
+            <a:schemeClr val="lt1"/>
+          </a:fontRef>
+        </p:style>
+        <p:txBody>
+          <a:bodyPr rtlCol="0" anchor="ctr"/>
+          <a:lstStyle/>
+          <a:p>
+            <a:pPr algn="ctr"/>
+          </a:p>
+        </p:txBody>
+      </p:sp>
+      <p:sp>
+        <p:nvSpPr>
+          <p:cNvPr id="29" name="Oval 28"/>
+          <p:cNvSpPr/>
+          <p:nvPr/>
+        </p:nvSpPr>
+        <p:spPr>
+          <a:xfrm>
+            <a:off x="3394710" y="6064758"/>
+            <a:ext cx="214884" cy="214884"/>
+          </a:xfrm>
+          <a:prstGeom prst="ellipse">
+            <a:avLst/>
+          </a:prstGeom>
+          <a:solidFill>
+            <a:srgbClr val="FFFFFF"/>
+          </a:solidFill>
+          <a:ln w="19050">
+            <a:solidFill>
+              <a:srgbClr val="CDBDA4"/>
+            </a:solidFill>
+          </a:ln>
+          <a:effectLst/>
+        </p:spPr>
+        <p:style>
+          <a:lnRef idx="1">
+            <a:schemeClr val="accent1"/>
+          </a:lnRef>
+          <a:fillRef idx="3">
+            <a:schemeClr val="accent1"/>
+          </a:fillRef>
+          <a:effectRef idx="2">
+            <a:schemeClr val="accent1"/>
+          </a:effectRef>
+          <a:fontRef idx="minor">
+            <a:schemeClr val="lt1"/>
+          </a:fontRef>
+        </p:style>
+        <p:txBody>
+          <a:bodyPr rtlCol="0" anchor="ctr"/>
+          <a:lstStyle/>
+          <a:p>
+            <a:pPr algn="ctr"/>
+          </a:p>
+        </p:txBody>
+      </p:sp>
+      <p:sp>
+        <p:nvSpPr>
+          <p:cNvPr id="30" name="Rounded Rectangle 29"/>
           <p:cNvSpPr/>
           <p:nvPr/>
         </p:nvSpPr>
@@ -11917,7 +12833,7 @@
       </p:sp>
       <p:sp>
         <p:nvSpPr>
-          <p:cNvPr id="28" name="Oval 27"/>
+          <p:cNvPr id="31" name="Oval 30"/>
           <p:cNvSpPr/>
           <p:nvPr/>
         </p:nvSpPr>
@@ -11970,7 +12886,7 @@
       </p:sp>
       <p:sp>
         <p:nvSpPr>
-          <p:cNvPr id="29" name="TextBox 28"/>
+          <p:cNvPr id="32" name="TextBox 31"/>
           <p:cNvSpPr txBox="1"/>
           <p:nvPr/>
         </p:nvSpPr>
@@ -12005,7 +12921,7 @@
       </p:sp>
       <p:sp>
         <p:nvSpPr>
-          <p:cNvPr id="30" name="TextBox 29"/>
+          <p:cNvPr id="33" name="TextBox 32"/>
           <p:cNvSpPr txBox="1"/>
           <p:nvPr/>
         </p:nvSpPr>
@@ -12084,7 +13000,7 @@
       </p:sp>
       <p:sp>
         <p:nvSpPr>
-          <p:cNvPr id="31" name="Rounded Rectangle 30"/>
+          <p:cNvPr id="34" name="Rounded Rectangle 33"/>
           <p:cNvSpPr/>
           <p:nvPr/>
         </p:nvSpPr>
@@ -12132,7 +13048,7 @@
       </p:sp>
       <p:sp>
         <p:nvSpPr>
-          <p:cNvPr id="32" name="Oval 31"/>
+          <p:cNvPr id="35" name="Oval 34"/>
           <p:cNvSpPr/>
           <p:nvPr/>
         </p:nvSpPr>
@@ -12185,7 +13101,7 @@
       </p:sp>
       <p:sp>
         <p:nvSpPr>
-          <p:cNvPr id="33" name="TextBox 32"/>
+          <p:cNvPr id="36" name="TextBox 35"/>
           <p:cNvSpPr txBox="1"/>
           <p:nvPr/>
         </p:nvSpPr>
@@ -12220,7 +13136,7 @@
       </p:sp>
       <p:sp>
         <p:nvSpPr>
-          <p:cNvPr id="34" name="TextBox 33"/>
+          <p:cNvPr id="37" name="TextBox 36"/>
           <p:cNvSpPr txBox="1"/>
           <p:nvPr/>
         </p:nvSpPr>
@@ -12299,7 +13215,7 @@
       </p:sp>
       <p:sp>
         <p:nvSpPr>
-          <p:cNvPr id="35" name="Rounded Rectangle 34"/>
+          <p:cNvPr id="38" name="Rounded Rectangle 37"/>
           <p:cNvSpPr/>
           <p:nvPr/>
         </p:nvSpPr>
@@ -12347,7 +13263,7 @@
       </p:sp>
       <p:sp>
         <p:nvSpPr>
-          <p:cNvPr id="36" name="Oval 35"/>
+          <p:cNvPr id="39" name="Oval 38"/>
           <p:cNvSpPr/>
           <p:nvPr/>
         </p:nvSpPr>
@@ -12400,7 +13316,7 @@
       </p:sp>
       <p:sp>
         <p:nvSpPr>
-          <p:cNvPr id="37" name="TextBox 36"/>
+          <p:cNvPr id="40" name="TextBox 39"/>
           <p:cNvSpPr txBox="1"/>
           <p:nvPr/>
         </p:nvSpPr>
@@ -12435,7 +13351,7 @@
       </p:sp>
       <p:sp>
         <p:nvSpPr>
-          <p:cNvPr id="38" name="TextBox 37"/>
+          <p:cNvPr id="41" name="TextBox 40"/>
           <p:cNvSpPr txBox="1"/>
           <p:nvPr/>
         </p:nvSpPr>
@@ -13331,7 +14247,7 @@
                                           </p:stCondLst>
                                         </p:cTn>
                                         <p:tgtEl>
-                                          <p:spTgt spid="27"/>
+                                          <p:spTgt spid="30"/>
                                         </p:tgtEl>
                                         <p:attrNameLst>
                                           <p:attrName>style.visibility</p:attrName>
@@ -13345,7 +14261,7 @@
                                       <p:cBhvr>
                                         <p:cTn id="7" dur="420"/>
                                         <p:tgtEl>
-                                          <p:spTgt spid="27"/>
+                                          <p:spTgt spid="30"/>
                                         </p:tgtEl>
                                       </p:cBhvr>
                                     </p:animEffect>
@@ -13366,7 +14282,7 @@
                                           </p:stCondLst>
                                         </p:cTn>
                                         <p:tgtEl>
-                                          <p:spTgt spid="28"/>
+                                          <p:spTgt spid="31"/>
                                         </p:tgtEl>
                                         <p:attrNameLst>
                                           <p:attrName>style.visibility</p:attrName>
@@ -13380,7 +14296,7 @@
                                       <p:cBhvr>
                                         <p:cTn id="10" dur="420"/>
                                         <p:tgtEl>
-                                          <p:spTgt spid="28"/>
+                                          <p:spTgt spid="31"/>
                                         </p:tgtEl>
                                       </p:cBhvr>
                                     </p:animEffect>
@@ -13401,7 +14317,7 @@
                                           </p:stCondLst>
                                         </p:cTn>
                                         <p:tgtEl>
-                                          <p:spTgt spid="29"/>
+                                          <p:spTgt spid="32"/>
                                         </p:tgtEl>
                                         <p:attrNameLst>
                                           <p:attrName>style.visibility</p:attrName>
@@ -13415,7 +14331,7 @@
                                       <p:cBhvr>
                                         <p:cTn id="13" dur="420"/>
                                         <p:tgtEl>
-                                          <p:spTgt spid="29"/>
+                                          <p:spTgt spid="32"/>
                                         </p:tgtEl>
                                       </p:cBhvr>
                                     </p:animEffect>
@@ -13436,7 +14352,7 @@
                                           </p:stCondLst>
                                         </p:cTn>
                                         <p:tgtEl>
-                                          <p:spTgt spid="30"/>
+                                          <p:spTgt spid="33"/>
                                         </p:tgtEl>
                                         <p:attrNameLst>
                                           <p:attrName>style.visibility</p:attrName>
@@ -13450,7 +14366,7 @@
                                       <p:cBhvr>
                                         <p:cTn id="16" dur="420"/>
                                         <p:tgtEl>
-                                          <p:spTgt spid="30"/>
+                                          <p:spTgt spid="33"/>
                                         </p:tgtEl>
                                       </p:cBhvr>
                                     </p:animEffect>
@@ -13489,7 +14405,7 @@
                                           </p:stCondLst>
                                         </p:cTn>
                                         <p:tgtEl>
-                                          <p:spTgt spid="31"/>
+                                          <p:spTgt spid="34"/>
                                         </p:tgtEl>
                                         <p:attrNameLst>
                                           <p:attrName>style.visibility</p:attrName>
@@ -13503,7 +14419,7 @@
                                       <p:cBhvr>
                                         <p:cTn id="21" dur="420"/>
                                         <p:tgtEl>
-                                          <p:spTgt spid="31"/>
+                                          <p:spTgt spid="34"/>
                                         </p:tgtEl>
                                       </p:cBhvr>
                                     </p:animEffect>
@@ -13524,7 +14440,7 @@
                                           </p:stCondLst>
                                         </p:cTn>
                                         <p:tgtEl>
-                                          <p:spTgt spid="32"/>
+                                          <p:spTgt spid="35"/>
                                         </p:tgtEl>
                                         <p:attrNameLst>
                                           <p:attrName>style.visibility</p:attrName>
@@ -13538,7 +14454,7 @@
                                       <p:cBhvr>
                                         <p:cTn id="24" dur="420"/>
                                         <p:tgtEl>
-                                          <p:spTgt spid="32"/>
+                                          <p:spTgt spid="35"/>
                                         </p:tgtEl>
                                       </p:cBhvr>
                                     </p:animEffect>
@@ -13559,7 +14475,7 @@
                                           </p:stCondLst>
                                         </p:cTn>
                                         <p:tgtEl>
-                                          <p:spTgt spid="33"/>
+                                          <p:spTgt spid="36"/>
                                         </p:tgtEl>
                                         <p:attrNameLst>
                                           <p:attrName>style.visibility</p:attrName>
@@ -13573,7 +14489,7 @@
                                       <p:cBhvr>
                                         <p:cTn id="27" dur="420"/>
                                         <p:tgtEl>
-                                          <p:spTgt spid="33"/>
+                                          <p:spTgt spid="36"/>
                                         </p:tgtEl>
                                       </p:cBhvr>
                                     </p:animEffect>
@@ -13594,7 +14510,7 @@
                                           </p:stCondLst>
                                         </p:cTn>
                                         <p:tgtEl>
-                                          <p:spTgt spid="34"/>
+                                          <p:spTgt spid="37"/>
                                         </p:tgtEl>
                                         <p:attrNameLst>
                                           <p:attrName>style.visibility</p:attrName>
@@ -13608,7 +14524,7 @@
                                       <p:cBhvr>
                                         <p:cTn id="30" dur="420"/>
                                         <p:tgtEl>
-                                          <p:spTgt spid="34"/>
+                                          <p:spTgt spid="37"/>
                                         </p:tgtEl>
                                       </p:cBhvr>
                                     </p:animEffect>
@@ -13647,7 +14563,7 @@
                                           </p:stCondLst>
                                         </p:cTn>
                                         <p:tgtEl>
-                                          <p:spTgt spid="35"/>
+                                          <p:spTgt spid="38"/>
                                         </p:tgtEl>
                                         <p:attrNameLst>
                                           <p:attrName>style.visibility</p:attrName>
@@ -13661,7 +14577,7 @@
                                       <p:cBhvr>
                                         <p:cTn id="35" dur="420"/>
                                         <p:tgtEl>
-                                          <p:spTgt spid="35"/>
+                                          <p:spTgt spid="38"/>
                                         </p:tgtEl>
                                       </p:cBhvr>
                                     </p:animEffect>
@@ -13682,7 +14598,7 @@
                                           </p:stCondLst>
                                         </p:cTn>
                                         <p:tgtEl>
-                                          <p:spTgt spid="36"/>
+                                          <p:spTgt spid="39"/>
                                         </p:tgtEl>
                                         <p:attrNameLst>
                                           <p:attrName>style.visibility</p:attrName>
@@ -13696,7 +14612,7 @@
                                       <p:cBhvr>
                                         <p:cTn id="38" dur="420"/>
                                         <p:tgtEl>
-                                          <p:spTgt spid="36"/>
+                                          <p:spTgt spid="39"/>
                                         </p:tgtEl>
                                       </p:cBhvr>
                                     </p:animEffect>
@@ -13717,7 +14633,7 @@
                                           </p:stCondLst>
                                         </p:cTn>
                                         <p:tgtEl>
-                                          <p:spTgt spid="37"/>
+                                          <p:spTgt spid="40"/>
                                         </p:tgtEl>
                                         <p:attrNameLst>
                                           <p:attrName>style.visibility</p:attrName>
@@ -13731,7 +14647,7 @@
                                       <p:cBhvr>
                                         <p:cTn id="41" dur="420"/>
                                         <p:tgtEl>
-                                          <p:spTgt spid="37"/>
+                                          <p:spTgt spid="40"/>
                                         </p:tgtEl>
                                       </p:cBhvr>
                                     </p:animEffect>
@@ -13752,7 +14668,7 @@
                                           </p:stCondLst>
                                         </p:cTn>
                                         <p:tgtEl>
-                                          <p:spTgt spid="38"/>
+                                          <p:spTgt spid="41"/>
                                         </p:tgtEl>
                                         <p:attrNameLst>
                                           <p:attrName>style.visibility</p:attrName>
@@ -13766,7 +14682,7 @@
                                       <p:cBhvr>
                                         <p:cTn id="44" dur="420"/>
                                         <p:tgtEl>
-                                          <p:spTgt spid="38"/>
+                                          <p:spTgt spid="41"/>
                                         </p:tgtEl>
                                       </p:cBhvr>
                                     </p:animEffect>
@@ -13801,9 +14717,6 @@
       </p:par>
     </p:tnLst>
     <p:bldLst>
-      <p:bldP spid="27" grpId="0" animBg="1"/>
-      <p:bldP spid="28" grpId="0" animBg="1"/>
-      <p:bldP spid="29" grpId="0" animBg="1"/>
       <p:bldP spid="30" grpId="0" animBg="1"/>
       <p:bldP spid="31" grpId="0" animBg="1"/>
       <p:bldP spid="32" grpId="0" animBg="1"/>
@@ -13813,6 +14726,9 @@
       <p:bldP spid="36" grpId="0" animBg="1"/>
       <p:bldP spid="37" grpId="0" animBg="1"/>
       <p:bldP spid="38" grpId="0" animBg="1"/>
+      <p:bldP spid="39" grpId="0" animBg="1"/>
+      <p:bldP spid="40" grpId="0" animBg="1"/>
+      <p:bldP spid="41" grpId="0" animBg="1"/>
     </p:bldLst>
   </p:timing>
 </p:sld>
@@ -17214,6 +18130,462 @@
 </p:sld>
 </file>
 
+<file path=ppt/slides/slide7.xml><?xml version="1.0" encoding="utf-8"?>
+<p:sld xmlns:a="http://schemas.openxmlformats.org/drawingml/2006/main" xmlns:p="http://schemas.openxmlformats.org/presentationml/2006/main" xmlns:r="http://schemas.openxmlformats.org/officeDocument/2006/relationships">
+  <p:cSld>
+    <p:bg>
+      <p:bgPr>
+        <a:solidFill>
+          <a:srgbClr val="3E2419"/>
+        </a:solidFill>
+        <a:effectLst/>
+      </p:bgPr>
+    </p:bg>
+    <p:spTree>
+      <p:nvGrpSpPr>
+        <p:cNvPr id="1" name=""/>
+        <p:cNvGrpSpPr/>
+        <p:nvPr/>
+      </p:nvGrpSpPr>
+      <p:grpSpPr/>
+      <p:pic>
+        <p:nvPicPr>
+          <p:cNvPr id="2" name="Picture 1" descr="capa_bg.jpg"/>
+          <p:cNvPicPr>
+            <a:picLocks noChangeAspect="1"/>
+          </p:cNvPicPr>
+          <p:nvPr/>
+        </p:nvPicPr>
+        <p:blipFill>
+          <a:blip r:embed="rId2"/>
+          <a:stretch>
+            <a:fillRect/>
+          </a:stretch>
+        </p:blipFill>
+        <p:spPr>
+          <a:xfrm>
+            <a:off x="0" y="0"/>
+            <a:ext cx="12191695" cy="6858000"/>
+          </a:xfrm>
+          <a:prstGeom prst="rect">
+            <a:avLst/>
+          </a:prstGeom>
+        </p:spPr>
+      </p:pic>
+      <p:sp>
+        <p:nvSpPr>
+          <p:cNvPr id="3" name="Rectangle 2"/>
+          <p:cNvSpPr/>
+          <p:nvPr/>
+        </p:nvSpPr>
+        <p:spPr>
+          <a:xfrm>
+            <a:off x="0" y="6711696"/>
+            <a:ext cx="12191695" cy="146304"/>
+          </a:xfrm>
+          <a:prstGeom prst="rect">
+            <a:avLst/>
+          </a:prstGeom>
+          <a:solidFill>
+            <a:srgbClr val="C9932E"/>
+          </a:solidFill>
+          <a:ln>
+            <a:noFill/>
+          </a:ln>
+          <a:effectLst/>
+        </p:spPr>
+        <p:style>
+          <a:lnRef idx="1">
+            <a:schemeClr val="accent1"/>
+          </a:lnRef>
+          <a:fillRef idx="3">
+            <a:schemeClr val="accent1"/>
+          </a:fillRef>
+          <a:effectRef idx="2">
+            <a:schemeClr val="accent1"/>
+          </a:effectRef>
+          <a:fontRef idx="minor">
+            <a:schemeClr val="lt1"/>
+          </a:fontRef>
+        </p:style>
+        <p:txBody>
+          <a:bodyPr rtlCol="0" anchor="ctr"/>
+          <a:lstStyle/>
+          <a:p>
+            <a:pPr algn="ctr"/>
+          </a:p>
+        </p:txBody>
+      </p:sp>
+      <p:sp>
+        <p:nvSpPr>
+          <p:cNvPr id="4" name="TextBox 3"/>
+          <p:cNvSpPr txBox="1"/>
+          <p:nvPr/>
+        </p:nvSpPr>
+        <p:spPr>
+          <a:xfrm>
+            <a:off x="841248" y="2331720"/>
+            <a:ext cx="10515600" cy="1188720"/>
+          </a:xfrm>
+          <a:prstGeom prst="rect">
+            <a:avLst/>
+          </a:prstGeom>
+          <a:noFill/>
+        </p:spPr>
+        <p:txBody>
+          <a:bodyPr wrap="square" anchor="t" lIns="0" rIns="0" tIns="0" bIns="0">
+            <a:spAutoFit/>
+          </a:bodyPr>
+          <a:lstStyle/>
+          <a:p>
+            <a:pPr algn="l"/>
+            <a:r>
+              <a:rPr sz="5400" b="1" i="0">
+                <a:solidFill>
+                  <a:srgbClr val="FFFFFF"/>
+                </a:solidFill>
+                <a:latin typeface="Segoe UI"/>
+              </a:rPr>
+              <a:t>Muito obrigada!</a:t>
+            </a:r>
+          </a:p>
+        </p:txBody>
+      </p:sp>
+      <p:sp>
+        <p:nvSpPr>
+          <p:cNvPr id="5" name="TextBox 4"/>
+          <p:cNvSpPr txBox="1"/>
+          <p:nvPr/>
+        </p:nvSpPr>
+        <p:spPr>
+          <a:xfrm>
+            <a:off x="868680" y="3611880"/>
+            <a:ext cx="9144000" cy="365760"/>
+          </a:xfrm>
+          <a:prstGeom prst="rect">
+            <a:avLst/>
+          </a:prstGeom>
+          <a:noFill/>
+        </p:spPr>
+        <p:txBody>
+          <a:bodyPr wrap="square" anchor="t" lIns="0" rIns="0" tIns="0" bIns="0">
+            <a:spAutoFit/>
+          </a:bodyPr>
+          <a:lstStyle/>
+          <a:p>
+            <a:pPr algn="l"/>
+            <a:r>
+              <a:rPr sz="1500" b="0" i="0">
+                <a:solidFill>
+                  <a:srgbClr val="E7D8C2"/>
+                </a:solidFill>
+                <a:latin typeface="Segoe UI"/>
+              </a:rPr>
+              <a:t>Divine Chocolates · Pesquisa &amp; Desenvolvimento</a:t>
+            </a:r>
+          </a:p>
+        </p:txBody>
+      </p:sp>
+      <p:pic>
+        <p:nvPicPr>
+          <p:cNvPr id="6" name="Picture 5" descr="logo_wordmark.png"/>
+          <p:cNvPicPr>
+            <a:picLocks noChangeAspect="1"/>
+          </p:cNvPicPr>
+          <p:nvPr/>
+        </p:nvPicPr>
+        <p:blipFill>
+          <a:blip r:embed="rId3"/>
+          <a:stretch>
+            <a:fillRect/>
+          </a:stretch>
+        </p:blipFill>
+        <p:spPr>
+          <a:xfrm>
+            <a:off x="841248" y="5074920"/>
+            <a:ext cx="2519265" cy="822960"/>
+          </a:xfrm>
+          <a:prstGeom prst="rect">
+            <a:avLst/>
+          </a:prstGeom>
+        </p:spPr>
+      </p:pic>
+      <p:sp>
+        <p:nvSpPr>
+          <p:cNvPr id="7" name="TextBox 6"/>
+          <p:cNvSpPr txBox="1"/>
+          <p:nvPr/>
+        </p:nvSpPr>
+        <p:spPr>
+          <a:xfrm>
+            <a:off x="841248" y="5961888"/>
+            <a:ext cx="2519265" cy="274320"/>
+          </a:xfrm>
+          <a:prstGeom prst="rect">
+            <a:avLst/>
+          </a:prstGeom>
+          <a:noFill/>
+        </p:spPr>
+        <p:txBody>
+          <a:bodyPr wrap="none" anchor="t" lIns="0" rIns="0" tIns="0" bIns="0">
+            <a:spAutoFit/>
+          </a:bodyPr>
+          <a:lstStyle/>
+          <a:p>
+            <a:pPr algn="ctr"/>
+            <a:r>
+              <a:rPr sz="950" b="1" i="0">
+                <a:solidFill>
+                  <a:srgbClr val="E7D8C2"/>
+                </a:solidFill>
+                <a:latin typeface="Segoe UI"/>
+              </a:rPr>
+              <a:t>C H O C O L A T E   D E   V E R D A D E</a:t>
+            </a:r>
+          </a:p>
+        </p:txBody>
+      </p:sp>
+    </p:spTree>
+  </p:cSld>
+  <p:clrMapOvr>
+    <a:masterClrMapping/>
+  </p:clrMapOvr>
+  <p:transition spd="med">
+    <p:fade/>
+  </p:transition>
+  <p:timing>
+    <p:tnLst>
+      <p:par>
+        <p:cTn id="1" dur="indefinite" restart="never" nodeType="tmRoot">
+          <p:childTnLst>
+            <p:seq concurrent="1" nextAc="seek">
+              <p:cTn id="2" dur="indefinite" nodeType="mainSeq">
+                <p:childTnLst>
+                  <p:par>
+                    <p:cTn id="3" fill="hold">
+                      <p:stCondLst>
+                        <p:cond delay="200"/>
+                      </p:stCondLst>
+                      <p:childTnLst>
+                        <p:par>
+                          <p:cTn id="4" fill="hold">
+                            <p:stCondLst>
+                              <p:cond delay="0"/>
+                            </p:stCondLst>
+                            <p:childTnLst>
+                              <p:par>
+                                <p:cTn id="5" presetID="10" presetClass="entr" presetSubtype="0" fill="hold" grpId="0" nodeType="afterEffect">
+                                  <p:stCondLst>
+                                    <p:cond delay="0"/>
+                                  </p:stCondLst>
+                                  <p:childTnLst>
+                                    <p:set>
+                                      <p:cBhvr>
+                                        <p:cTn id="6" dur="1" fill="hold">
+                                          <p:stCondLst>
+                                            <p:cond delay="0"/>
+                                          </p:stCondLst>
+                                        </p:cTn>
+                                        <p:tgtEl>
+                                          <p:spTgt spid="4"/>
+                                        </p:tgtEl>
+                                        <p:attrNameLst>
+                                          <p:attrName>style.visibility</p:attrName>
+                                        </p:attrNameLst>
+                                      </p:cBhvr>
+                                      <p:to>
+                                        <p:strVal val="visible"/>
+                                      </p:to>
+                                    </p:set>
+                                    <p:animEffect transition="in" filter="fade">
+                                      <p:cBhvr>
+                                        <p:cTn id="7" dur="420"/>
+                                        <p:tgtEl>
+                                          <p:spTgt spid="4"/>
+                                        </p:tgtEl>
+                                      </p:cBhvr>
+                                    </p:animEffect>
+                                  </p:childTnLst>
+                                </p:cTn>
+                              </p:par>
+                            </p:childTnLst>
+                          </p:cTn>
+                        </p:par>
+                      </p:childTnLst>
+                    </p:cTn>
+                  </p:par>
+                  <p:par>
+                    <p:cTn id="8" fill="hold">
+                      <p:stCondLst>
+                        <p:cond delay="350"/>
+                      </p:stCondLst>
+                      <p:childTnLst>
+                        <p:par>
+                          <p:cTn id="9" fill="hold">
+                            <p:stCondLst>
+                              <p:cond delay="0"/>
+                            </p:stCondLst>
+                            <p:childTnLst>
+                              <p:par>
+                                <p:cTn id="10" presetID="10" presetClass="entr" presetSubtype="0" fill="hold" grpId="0" nodeType="afterEffect">
+                                  <p:stCondLst>
+                                    <p:cond delay="0"/>
+                                  </p:stCondLst>
+                                  <p:childTnLst>
+                                    <p:set>
+                                      <p:cBhvr>
+                                        <p:cTn id="11" dur="1" fill="hold">
+                                          <p:stCondLst>
+                                            <p:cond delay="0"/>
+                                          </p:stCondLst>
+                                        </p:cTn>
+                                        <p:tgtEl>
+                                          <p:spTgt spid="5"/>
+                                        </p:tgtEl>
+                                        <p:attrNameLst>
+                                          <p:attrName>style.visibility</p:attrName>
+                                        </p:attrNameLst>
+                                      </p:cBhvr>
+                                      <p:to>
+                                        <p:strVal val="visible"/>
+                                      </p:to>
+                                    </p:set>
+                                    <p:animEffect transition="in" filter="fade">
+                                      <p:cBhvr>
+                                        <p:cTn id="12" dur="420"/>
+                                        <p:tgtEl>
+                                          <p:spTgt spid="5"/>
+                                        </p:tgtEl>
+                                      </p:cBhvr>
+                                    </p:animEffect>
+                                  </p:childTnLst>
+                                </p:cTn>
+                              </p:par>
+                            </p:childTnLst>
+                          </p:cTn>
+                        </p:par>
+                      </p:childTnLst>
+                    </p:cTn>
+                  </p:par>
+                  <p:par>
+                    <p:cTn id="13" fill="hold">
+                      <p:stCondLst>
+                        <p:cond delay="350"/>
+                      </p:stCondLst>
+                      <p:childTnLst>
+                        <p:par>
+                          <p:cTn id="14" fill="hold">
+                            <p:stCondLst>
+                              <p:cond delay="0"/>
+                            </p:stCondLst>
+                            <p:childTnLst>
+                              <p:par>
+                                <p:cTn id="15" presetID="10" presetClass="entr" presetSubtype="0" fill="hold" grpId="0" nodeType="afterEffect">
+                                  <p:stCondLst>
+                                    <p:cond delay="0"/>
+                                  </p:stCondLst>
+                                  <p:childTnLst>
+                                    <p:set>
+                                      <p:cBhvr>
+                                        <p:cTn id="16" dur="1" fill="hold">
+                                          <p:stCondLst>
+                                            <p:cond delay="0"/>
+                                          </p:stCondLst>
+                                        </p:cTn>
+                                        <p:tgtEl>
+                                          <p:spTgt spid="6"/>
+                                        </p:tgtEl>
+                                        <p:attrNameLst>
+                                          <p:attrName>style.visibility</p:attrName>
+                                        </p:attrNameLst>
+                                      </p:cBhvr>
+                                      <p:to>
+                                        <p:strVal val="visible"/>
+                                      </p:to>
+                                    </p:set>
+                                    <p:animEffect transition="in" filter="fade">
+                                      <p:cBhvr>
+                                        <p:cTn id="17" dur="420"/>
+                                        <p:tgtEl>
+                                          <p:spTgt spid="6"/>
+                                        </p:tgtEl>
+                                      </p:cBhvr>
+                                    </p:animEffect>
+                                  </p:childTnLst>
+                                </p:cTn>
+                              </p:par>
+                              <p:par>
+                                <p:cTn id="18" presetID="10" presetClass="entr" presetSubtype="0" fill="hold" grpId="0" nodeType="withEffect">
+                                  <p:stCondLst>
+                                    <p:cond delay="0"/>
+                                  </p:stCondLst>
+                                  <p:childTnLst>
+                                    <p:set>
+                                      <p:cBhvr>
+                                        <p:cTn id="19" dur="1" fill="hold">
+                                          <p:stCondLst>
+                                            <p:cond delay="0"/>
+                                          </p:stCondLst>
+                                        </p:cTn>
+                                        <p:tgtEl>
+                                          <p:spTgt spid="7"/>
+                                        </p:tgtEl>
+                                        <p:attrNameLst>
+                                          <p:attrName>style.visibility</p:attrName>
+                                        </p:attrNameLst>
+                                      </p:cBhvr>
+                                      <p:to>
+                                        <p:strVal val="visible"/>
+                                      </p:to>
+                                    </p:set>
+                                    <p:animEffect transition="in" filter="fade">
+                                      <p:cBhvr>
+                                        <p:cTn id="20" dur="420"/>
+                                        <p:tgtEl>
+                                          <p:spTgt spid="7"/>
+                                        </p:tgtEl>
+                                      </p:cBhvr>
+                                    </p:animEffect>
+                                  </p:childTnLst>
+                                </p:cTn>
+                              </p:par>
+                            </p:childTnLst>
+                          </p:cTn>
+                        </p:par>
+                      </p:childTnLst>
+                    </p:cTn>
+                  </p:par>
+                </p:childTnLst>
+              </p:cTn>
+              <p:prevCondLst>
+                <p:cond evt="onPrev" delay="0">
+                  <p:tgtEl>
+                    <p:sldTgt/>
+                  </p:tgtEl>
+                </p:cond>
+              </p:prevCondLst>
+              <p:nextCondLst>
+                <p:cond evt="onNext" delay="0">
+                  <p:tgtEl>
+                    <p:sldTgt/>
+                  </p:tgtEl>
+                </p:cond>
+              </p:nextCondLst>
+            </p:seq>
+          </p:childTnLst>
+        </p:cTn>
+      </p:par>
+    </p:tnLst>
+    <p:bldLst>
+      <p:bldP spid="4" grpId="0" animBg="1"/>
+      <p:bldP spid="5" grpId="0" animBg="1"/>
+      <p:bldP spid="6" grpId="0" animBg="1"/>
+      <p:bldP spid="7" grpId="0" animBg="1"/>
+    </p:bldLst>
+  </p:timing>
+</p:sld>
+</file>
+
 <file path=ppt/theme/theme1.xml><?xml version="1.0" encoding="utf-8"?>
 <a:theme xmlns:a="http://schemas.openxmlformats.org/drawingml/2006/main" name="Office Theme">
   <a:themeElements>

</xml_diff>